<commit_message>
10-minute deck: extra results slide for the Myrranox (physics body, key figures, path v1 -> v10); 11 slides
Co-Authored-By: Claude Opus 5.5 <noreply@anthropic.com>
</commit_message>
<xml_diff>
--- a/docs/presentation/Endemic_Creatures_RL_10min.pptx
+++ b/docs/presentation/Endemic_Creatures_RL_10min.pptx
@@ -15,9 +15,10 @@
     <p:sldId id="263" r:id="rId9"/>
     <p:sldId id="264" r:id="rId10"/>
     <p:sldId id="265" r:id="rId11"/>
+    <p:sldId id="266" r:id="rId12"/>
   </p:sldIdLst>
   <p:notesMasterIdLst>
-    <p:notesMasterId r:id="rId12"/>
+    <p:notesMasterId r:id="rId13"/>
   </p:notesMasterIdLst>
   <p:sldSz cx="12192000" cy="6858000"/>
   <p:notesSz cx="6858000" cy="12192000"/>
@@ -116,30 +117,31 @@
   <p:extLst>
     <p:ext uri="{521415D9-36F7-43E2-AB2F-B90AF26B5E84}">
       <p14:sectionLst xmlns:p14="http://schemas.microsoft.com/office/powerpoint/2010/main">
-        <p14:section name="Einstieg" id="{92dd9ff4-121c-9537-12e1-5dcd84b662bc}">
+        <p14:section name="Einstieg" id="{d1167562-039a-5936-e233-6be23282bad2}">
           <p14:sldIdLst>
             <p14:sldId id="256"/>
             <p14:sldId id="257"/>
           </p14:sldIdLst>
         </p14:section>
-        <p14:section name="Vorgehen" id="{b5a92346-05c3-e178-0ff5-38409a14c7f9}">
+        <p14:section name="Vorgehen" id="{2b8000d8-c156-c0fd-7e09-89f6359b19e7}">
           <p14:sldIdLst>
             <p14:sldId id="258"/>
             <p14:sldId id="259"/>
           </p14:sldIdLst>
         </p14:section>
-        <p14:section name="Lernen" id="{fe3fede1-f4ce-b1ad-7049-7e308b4c4b1d}">
+        <p14:section name="Lernen" id="{42e867a3-a040-f4ee-0abe-86f35587cca0}">
           <p14:sldIdLst>
             <p14:sldId id="260"/>
             <p14:sldId id="261"/>
+            <p14:sldId id="262"/>
           </p14:sldIdLst>
         </p14:section>
-        <p14:section name="Rückblick" id="{beb4e82d-7d46-912e-cfb2-ba5cb0cd3335}">
+        <p14:section name="Rückblick" id="{74488e48-7b7b-7685-6862-892f2f4cb3cb}">
           <p14:sldIdLst>
-            <p14:sldId id="262"/>
             <p14:sldId id="263"/>
             <p14:sldId id="264"/>
             <p14:sldId id="265"/>
+            <p14:sldId id="266"/>
           </p14:sldIdLst>
         </p14:section>
       </p14:sectionLst>
@@ -634,7 +636,7 @@
           <a:p>
             <a:r>
               <a:rPr lang="en-US" dirty="0"/>
-              <a:t>ca. 30 s plus Fragen. Optional hier das 30-s-Video zeigen.</a:t>
+              <a:t>ca. 1 min. Die drei wichtigsten: Körper zuerst, Belohnung vorher testen, bessere Hardware.</a:t>
             </a:r>
             <a:endParaRPr lang="en-US" dirty="0"/>
           </a:p>
@@ -658,6 +660,94 @@
             <a:fld id="{F7021451-1387-4CA6-816F-3879F97B5CBC}" type="slidenum">
               <a:rPr lang="en-US"/>
               <a:t>10</a:t>
+            </a:fld>
+            <a:endParaRPr lang="en-US"/>
+          </a:p>
+        </p:txBody>
+      </p:sp>
+    </p:spTree>
+    <p:extLst>
+      <p:ext uri="{BB962C8B-B14F-4D97-AF65-F5344CB8AC3E}">
+        <p14:creationId xmlns:p14="http://schemas.microsoft.com/office/powerpoint/2010/main" val="1024086991"/>
+      </p:ext>
+    </p:extLst>
+  </p:cSld>
+  <p:clrMapOvr>
+    <a:masterClrMapping/>
+  </p:clrMapOvr>
+</p:notes>
+</file>
+
+<file path=ppt/notesSlides/notesSlide11.xml><?xml version="1.0" encoding="utf-8"?>
+<p:notes xmlns:a="http://schemas.openxmlformats.org/drawingml/2006/main" xmlns:r="http://schemas.openxmlformats.org/officeDocument/2006/relationships" xmlns:p="http://schemas.openxmlformats.org/presentationml/2006/main">
+  <p:cSld>
+    <p:spTree>
+      <p:nvGrpSpPr>
+        <p:cNvPr id="1" name=""/>
+        <p:cNvGrpSpPr/>
+        <p:nvPr/>
+      </p:nvGrpSpPr>
+      <p:grpSpPr>
+        <a:xfrm>
+          <a:off x="0" y="0"/>
+          <a:ext cx="0" cy="0"/>
+          <a:chOff x="0" y="0"/>
+          <a:chExt cx="0" cy="0"/>
+        </a:xfrm>
+      </p:grpSpPr>
+      <p:sp>
+        <p:nvSpPr>
+          <p:cNvPr id="2" name="Slide Image Placeholder 1"/>
+          <p:cNvSpPr>
+            <a:spLocks noGrp="1" noRot="1" noChangeAspect="1"/>
+          </p:cNvSpPr>
+          <p:nvPr>
+            <p:ph type="sldImg"/>
+          </p:nvPr>
+        </p:nvSpPr>
+        <p:spPr/>
+      </p:sp>
+      <p:sp>
+        <p:nvSpPr>
+          <p:cNvPr id="3" name="Notes Placeholder 2"/>
+          <p:cNvSpPr>
+            <a:spLocks noGrp="1"/>
+          </p:cNvSpPr>
+          <p:nvPr>
+            <p:ph type="body" idx="1"/>
+          </p:nvPr>
+        </p:nvSpPr>
+        <p:spPr/>
+        <p:txBody>
+          <a:bodyPr/>
+          <a:lstStyle/>
+          <a:p>
+            <a:r>
+              <a:rPr lang="en-US" dirty="0"/>
+              <a:t>ca. 30 s plus Fragen. Optional hier das 30-s-Video zeigen.</a:t>
+            </a:r>
+            <a:endParaRPr lang="en-US" dirty="0"/>
+          </a:p>
+        </p:txBody>
+      </p:sp>
+      <p:sp>
+        <p:nvSpPr>
+          <p:cNvPr id="4" name="Slide Number Placeholder 3"/>
+          <p:cNvSpPr>
+            <a:spLocks noGrp="1"/>
+          </p:cNvSpPr>
+          <p:nvPr>
+            <p:ph type="sldNum" sz="quarter" idx="10"/>
+          </p:nvPr>
+        </p:nvSpPr>
+        <p:spPr/>
+        <p:txBody>
+          <a:bodyPr/>
+          <a:lstStyle/>
+          <a:p>
+            <a:fld id="{F7021451-1387-4CA6-816F-3879F97B5CBC}" type="slidenum">
+              <a:rPr lang="en-US"/>
+              <a:t>11</a:t>
             </a:fld>
             <a:endParaRPr lang="en-US"/>
           </a:p>
@@ -898,7 +988,7 @@
           <a:p>
             <a:r>
               <a:rPr lang="en-US" dirty="0"/>
-              <a:t>ca. 1 min. Alles Open Source ausser dem Assistenten. Rechnen nur auf dem Laptop: ein Grund, warum Training und Rendern lange dauerten.</a:t>
+              <a:t>ca. 50 s. Alles Open Source ausser dem Assistenten. Rechnen nur auf dem Laptop: ein Grund, warum Training und Rendern lange dauerten.</a:t>
             </a:r>
             <a:endParaRPr lang="en-US" dirty="0"/>
           </a:p>
@@ -1074,7 +1164,7 @@
           <a:p>
             <a:r>
               <a:rPr lang="en-US" dirty="0"/>
-              <a:t>ca. 45 s. Kurz die Zahlen; Bild: alter Physik-Körper (Blöcke) gegen den neuen aus 218 Teilen.</a:t>
+              <a:t>ca. 40 s. Kurz die Zahlen; Bild: alter DC-Physik-Körper (Blöcke) gegen den neuen aus 218 Teilen.</a:t>
             </a:r>
             <a:endParaRPr lang="en-US" dirty="0"/>
           </a:p>
@@ -1162,7 +1252,7 @@
           <a:p>
             <a:r>
               <a:rPr lang="en-US" dirty="0"/>
-              <a:t>ca. 1 min 15 s. Wichtigste Erkenntnis: RL optimiert genau das, was man belohnt - nicht das, was man meint. Beispiele nennen.</a:t>
+              <a:t>ca. 45 s. Der Myrranox war schwieriger als gedacht: erst als das Gewicht stimmte (leichterer Hinterleib) und ein fester Dreifuß-Rhythmus vorgegeben wurde, lief er wie ein Insekt. Rückwärts und Drehen auf der Stelle hat er erst mit v10 gelernt.</a:t>
             </a:r>
             <a:endParaRPr lang="en-US" dirty="0"/>
           </a:p>
@@ -1250,7 +1340,7 @@
           <a:p>
             <a:r>
               <a:rPr lang="en-US" dirty="0"/>
-              <a:t>ca. 1 min 15 s. Ehrlich: viele Runden waren Fehlversuche. Jede hat aber eine Lehre gebracht.</a:t>
+              <a:t>ca. 1 min 15 s. Wichtigste Erkenntnis: RL optimiert genau das, was man belohnt - nicht das, was man meint. Beispiele nennen.</a:t>
             </a:r>
             <a:endParaRPr lang="en-US" dirty="0"/>
           </a:p>
@@ -1338,7 +1428,7 @@
           <a:p>
             <a:r>
               <a:rPr lang="en-US" dirty="0"/>
-              <a:t>ca. 1 min. Die drei wichtigsten: Körper zuerst, Belohnung vorher testen, bessere Hardware.</a:t>
+              <a:t>ca. 1 min 15 s. Ehrlich: viele Runden waren Fehlversuche. Jede hat aber eine Lehre gebracht.</a:t>
             </a:r>
             <a:endParaRPr lang="en-US" dirty="0"/>
           </a:p>
@@ -2147,6 +2237,1113 @@
           <a:chExt cx="0" cy="0"/>
         </a:xfrm>
       </p:grpSpPr>
+      <p:sp>
+        <p:nvSpPr>
+          <p:cNvPr id="2" name="Text 0"/>
+          <p:cNvSpPr/>
+          <p:nvPr>
+            <p:ph idx="100" type="title" hasCustomPrompt="1"/>
+          </p:nvPr>
+        </p:nvSpPr>
+        <p:spPr>
+          <a:xfrm>
+            <a:off x="548640" y="320040"/>
+            <a:ext cx="11064240" cy="777240"/>
+          </a:xfrm>
+          <a:prstGeom prst="rect">
+            <a:avLst/>
+          </a:prstGeom>
+          <a:noFill/>
+          <a:ln/>
+        </p:spPr>
+        <p:txBody>
+          <a:bodyPr wrap="square" rtlCol="0" anchor="ctr"/>
+          <a:lstStyle/>
+          <a:p>
+            <a:pPr algn="l" indent="0" marL="0">
+              <a:buNone/>
+            </a:pPr>
+            <a:r>
+              <a:rPr lang="en-US" sz="3200" b="1" dirty="0">
+                <a:solidFill>
+                  <a:schemeClr val="tx2"/>
+                </a:solidFill>
+                <a:latin typeface="Cambria" pitchFamily="34" charset="0"/>
+                <a:ea typeface="Cambria" pitchFamily="34" charset="-122"/>
+                <a:cs typeface="Cambria" pitchFamily="34" charset="-120"/>
+              </a:rPr>
+              <a:t>Was würde ich anders machen?</a:t>
+            </a:r>
+            <a:endParaRPr lang="en-US" sz="3200" dirty="0"/>
+          </a:p>
+        </p:txBody>
+      </p:sp>
+      <p:sp>
+        <p:nvSpPr>
+          <p:cNvPr id="3" name="diff0"/>
+          <p:cNvSpPr/>
+          <p:nvPr/>
+        </p:nvSpPr>
+        <p:spPr>
+          <a:xfrm>
+            <a:off x="548640" y="1371600"/>
+            <a:ext cx="3520440" cy="2011680"/>
+          </a:xfrm>
+          <a:prstGeom prst="roundRect">
+            <a:avLst>
+              <a:gd name="adj" fmla="val 3636"/>
+            </a:avLst>
+          </a:prstGeom>
+          <a:solidFill>
+            <a:schemeClr val="bg2"/>
+          </a:solidFill>
+          <a:ln w="12700">
+            <a:solidFill>
+              <a:schemeClr val="bg2"/>
+            </a:solidFill>
+            <a:prstDash val="solid"/>
+          </a:ln>
+        </p:spPr>
+      </p:sp>
+      <p:sp>
+        <p:nvSpPr>
+          <p:cNvPr id="4" name="Shape 2"/>
+          <p:cNvSpPr/>
+          <p:nvPr/>
+        </p:nvSpPr>
+        <p:spPr>
+          <a:xfrm>
+            <a:off x="777240" y="1600200"/>
+            <a:ext cx="502920" cy="502920"/>
+          </a:xfrm>
+          <a:prstGeom prst="ellipse">
+            <a:avLst/>
+          </a:prstGeom>
+          <a:solidFill>
+            <a:schemeClr val="accent1"/>
+          </a:solidFill>
+          <a:ln w="12700">
+            <a:solidFill>
+              <a:schemeClr val="accent1"/>
+            </a:solidFill>
+            <a:prstDash val="solid"/>
+          </a:ln>
+        </p:spPr>
+      </p:sp>
+      <p:sp>
+        <p:nvSpPr>
+          <p:cNvPr id="5" name="Text 3"/>
+          <p:cNvSpPr txBox="1"/>
+          <p:nvPr/>
+        </p:nvSpPr>
+        <p:spPr>
+          <a:xfrm>
+            <a:off x="777240" y="1600200"/>
+            <a:ext cx="502920" cy="502920"/>
+          </a:xfrm>
+          <a:prstGeom prst="rect">
+            <a:avLst/>
+          </a:prstGeom>
+          <a:noFill/>
+          <a:ln/>
+        </p:spPr>
+        <p:txBody>
+          <a:bodyPr wrap="square" lIns="0" tIns="0" rIns="0" bIns="0" rtlCol="0" anchor="ctr"/>
+          <a:lstStyle/>
+          <a:p>
+            <a:pPr algn="ctr" indent="0" marL="0">
+              <a:buNone/>
+            </a:pPr>
+            <a:r>
+              <a:rPr lang="en-US" sz="1500" b="1" dirty="0">
+                <a:solidFill>
+                  <a:schemeClr val="bg1"/>
+                </a:solidFill>
+              </a:rPr>
+              <a:t>→</a:t>
+            </a:r>
+            <a:endParaRPr lang="en-US" sz="1500" dirty="0"/>
+          </a:p>
+        </p:txBody>
+      </p:sp>
+      <p:sp>
+        <p:nvSpPr>
+          <p:cNvPr id="6" name="Text 4"/>
+          <p:cNvSpPr txBox="1"/>
+          <p:nvPr/>
+        </p:nvSpPr>
+        <p:spPr>
+          <a:xfrm>
+            <a:off x="1463040" y="1645920"/>
+            <a:ext cx="2468880" cy="457200"/>
+          </a:xfrm>
+          <a:prstGeom prst="rect">
+            <a:avLst/>
+          </a:prstGeom>
+          <a:noFill/>
+          <a:ln/>
+        </p:spPr>
+        <p:txBody>
+          <a:bodyPr wrap="square" lIns="0" tIns="0" rIns="0" bIns="0" rtlCol="0" anchor="t"/>
+          <a:lstStyle/>
+          <a:p>
+            <a:pPr indent="0" marL="0">
+              <a:buNone/>
+            </a:pPr>
+            <a:r>
+              <a:rPr lang="en-US" sz="1600" b="1" dirty="0">
+                <a:solidFill>
+                  <a:schemeClr val="tx2"/>
+                </a:solidFill>
+                <a:latin typeface="Calibri" pitchFamily="34" charset="0"/>
+                <a:ea typeface="Calibri" pitchFamily="34" charset="-122"/>
+                <a:cs typeface="Calibri" pitchFamily="34" charset="-120"/>
+              </a:rPr>
+              <a:t>Körper zuerst prüfen</a:t>
+            </a:r>
+            <a:endParaRPr lang="en-US" sz="1600" dirty="0"/>
+          </a:p>
+        </p:txBody>
+      </p:sp>
+      <p:sp>
+        <p:nvSpPr>
+          <p:cNvPr id="7" name="Text 5"/>
+          <p:cNvSpPr txBox="1"/>
+          <p:nvPr/>
+        </p:nvSpPr>
+        <p:spPr>
+          <a:xfrm>
+            <a:off x="777240" y="2240280"/>
+            <a:ext cx="3108960" cy="1051560"/>
+          </a:xfrm>
+          <a:prstGeom prst="rect">
+            <a:avLst/>
+          </a:prstGeom>
+          <a:noFill/>
+          <a:ln/>
+        </p:spPr>
+        <p:txBody>
+          <a:bodyPr wrap="square" lIns="0" tIns="0" rIns="0" bIns="0" rtlCol="0" anchor="t"/>
+          <a:lstStyle/>
+          <a:p>
+            <a:pPr indent="0" marL="0">
+              <a:buNone/>
+            </a:pPr>
+            <a:r>
+              <a:rPr lang="en-US" sz="1400" dirty="0">
+                <a:solidFill>
+                  <a:schemeClr val="tx1"/>
+                </a:solidFill>
+                <a:latin typeface="Calibri" pitchFamily="34" charset="0"/>
+                <a:ea typeface="Calibri" pitchFamily="34" charset="-122"/>
+                <a:cs typeface="Calibri" pitchFamily="34" charset="-120"/>
+              </a:rPr>
+              <a:t>Masse, Geometrie, Reichweite der Glieder vor dem ersten Training messen</a:t>
+            </a:r>
+            <a:endParaRPr lang="en-US" sz="1400" dirty="0"/>
+          </a:p>
+        </p:txBody>
+      </p:sp>
+      <p:sp>
+        <p:nvSpPr>
+          <p:cNvPr id="8" name="diff1"/>
+          <p:cNvSpPr/>
+          <p:nvPr/>
+        </p:nvSpPr>
+        <p:spPr>
+          <a:xfrm>
+            <a:off x="4297680" y="1371600"/>
+            <a:ext cx="3520440" cy="2011680"/>
+          </a:xfrm>
+          <a:prstGeom prst="roundRect">
+            <a:avLst>
+              <a:gd name="adj" fmla="val 3636"/>
+            </a:avLst>
+          </a:prstGeom>
+          <a:solidFill>
+            <a:schemeClr val="bg2"/>
+          </a:solidFill>
+          <a:ln w="12700">
+            <a:solidFill>
+              <a:schemeClr val="bg2"/>
+            </a:solidFill>
+            <a:prstDash val="solid"/>
+          </a:ln>
+        </p:spPr>
+      </p:sp>
+      <p:sp>
+        <p:nvSpPr>
+          <p:cNvPr id="9" name="Shape 7"/>
+          <p:cNvSpPr/>
+          <p:nvPr/>
+        </p:nvSpPr>
+        <p:spPr>
+          <a:xfrm>
+            <a:off x="4526280" y="1600200"/>
+            <a:ext cx="502920" cy="502920"/>
+          </a:xfrm>
+          <a:prstGeom prst="ellipse">
+            <a:avLst/>
+          </a:prstGeom>
+          <a:solidFill>
+            <a:schemeClr val="accent1"/>
+          </a:solidFill>
+          <a:ln w="12700">
+            <a:solidFill>
+              <a:schemeClr val="accent1"/>
+            </a:solidFill>
+            <a:prstDash val="solid"/>
+          </a:ln>
+        </p:spPr>
+      </p:sp>
+      <p:sp>
+        <p:nvSpPr>
+          <p:cNvPr id="10" name="Text 8"/>
+          <p:cNvSpPr txBox="1"/>
+          <p:nvPr/>
+        </p:nvSpPr>
+        <p:spPr>
+          <a:xfrm>
+            <a:off x="4526280" y="1600200"/>
+            <a:ext cx="502920" cy="502920"/>
+          </a:xfrm>
+          <a:prstGeom prst="rect">
+            <a:avLst/>
+          </a:prstGeom>
+          <a:noFill/>
+          <a:ln/>
+        </p:spPr>
+        <p:txBody>
+          <a:bodyPr wrap="square" lIns="0" tIns="0" rIns="0" bIns="0" rtlCol="0" anchor="ctr"/>
+          <a:lstStyle/>
+          <a:p>
+            <a:pPr algn="ctr" indent="0" marL="0">
+              <a:buNone/>
+            </a:pPr>
+            <a:r>
+              <a:rPr lang="en-US" sz="1500" b="1" dirty="0">
+                <a:solidFill>
+                  <a:schemeClr val="bg1"/>
+                </a:solidFill>
+              </a:rPr>
+              <a:t>→</a:t>
+            </a:r>
+            <a:endParaRPr lang="en-US" sz="1500" dirty="0"/>
+          </a:p>
+        </p:txBody>
+      </p:sp>
+      <p:sp>
+        <p:nvSpPr>
+          <p:cNvPr id="11" name="Text 9"/>
+          <p:cNvSpPr txBox="1"/>
+          <p:nvPr/>
+        </p:nvSpPr>
+        <p:spPr>
+          <a:xfrm>
+            <a:off x="5212080" y="1645920"/>
+            <a:ext cx="2468880" cy="457200"/>
+          </a:xfrm>
+          <a:prstGeom prst="rect">
+            <a:avLst/>
+          </a:prstGeom>
+          <a:noFill/>
+          <a:ln/>
+        </p:spPr>
+        <p:txBody>
+          <a:bodyPr wrap="square" lIns="0" tIns="0" rIns="0" bIns="0" rtlCol="0" anchor="t"/>
+          <a:lstStyle/>
+          <a:p>
+            <a:pPr indent="0" marL="0">
+              <a:buNone/>
+            </a:pPr>
+            <a:r>
+              <a:rPr lang="en-US" sz="1600" b="1" dirty="0">
+                <a:solidFill>
+                  <a:schemeClr val="tx2"/>
+                </a:solidFill>
+                <a:latin typeface="Calibri" pitchFamily="34" charset="0"/>
+                <a:ea typeface="Calibri" pitchFamily="34" charset="-122"/>
+                <a:cs typeface="Calibri" pitchFamily="34" charset="-120"/>
+              </a:rPr>
+              <a:t>Belohnung vorher testen</a:t>
+            </a:r>
+            <a:endParaRPr lang="en-US" sz="1600" dirty="0"/>
+          </a:p>
+        </p:txBody>
+      </p:sp>
+      <p:sp>
+        <p:nvSpPr>
+          <p:cNvPr id="12" name="Text 10"/>
+          <p:cNvSpPr txBox="1"/>
+          <p:nvPr/>
+        </p:nvSpPr>
+        <p:spPr>
+          <a:xfrm>
+            <a:off x="4526280" y="2240280"/>
+            <a:ext cx="3108960" cy="1051560"/>
+          </a:xfrm>
+          <a:prstGeom prst="rect">
+            <a:avLst/>
+          </a:prstGeom>
+          <a:noFill/>
+          <a:ln/>
+        </p:spPr>
+        <p:txBody>
+          <a:bodyPr wrap="square" lIns="0" tIns="0" rIns="0" bIns="0" rtlCol="0" anchor="t"/>
+          <a:lstStyle/>
+          <a:p>
+            <a:pPr indent="0" marL="0">
+              <a:buNone/>
+            </a:pPr>
+            <a:r>
+              <a:rPr lang="en-US" sz="1400" dirty="0">
+                <a:solidFill>
+                  <a:schemeClr val="tx1"/>
+                </a:solidFill>
+                <a:latin typeface="Calibri" pitchFamily="34" charset="0"/>
+                <a:ea typeface="Calibri" pitchFamily="34" charset="-122"/>
+                <a:cs typeface="Calibri" pitchFamily="34" charset="-120"/>
+              </a:rPr>
+              <a:t>Mit einfachen Skript-Figuren prüfen, ob Stehen oder Schlupflöcher sich lohnen</a:t>
+            </a:r>
+            <a:endParaRPr lang="en-US" sz="1400" dirty="0"/>
+          </a:p>
+        </p:txBody>
+      </p:sp>
+      <p:sp>
+        <p:nvSpPr>
+          <p:cNvPr id="13" name="diff2"/>
+          <p:cNvSpPr/>
+          <p:nvPr/>
+        </p:nvSpPr>
+        <p:spPr>
+          <a:xfrm>
+            <a:off x="8046720" y="1371600"/>
+            <a:ext cx="3520440" cy="2011680"/>
+          </a:xfrm>
+          <a:prstGeom prst="roundRect">
+            <a:avLst>
+              <a:gd name="adj" fmla="val 3636"/>
+            </a:avLst>
+          </a:prstGeom>
+          <a:solidFill>
+            <a:schemeClr val="bg2"/>
+          </a:solidFill>
+          <a:ln w="12700">
+            <a:solidFill>
+              <a:schemeClr val="bg2"/>
+            </a:solidFill>
+            <a:prstDash val="solid"/>
+          </a:ln>
+        </p:spPr>
+      </p:sp>
+      <p:sp>
+        <p:nvSpPr>
+          <p:cNvPr id="14" name="Shape 12"/>
+          <p:cNvSpPr/>
+          <p:nvPr/>
+        </p:nvSpPr>
+        <p:spPr>
+          <a:xfrm>
+            <a:off x="8275320" y="1600200"/>
+            <a:ext cx="502920" cy="502920"/>
+          </a:xfrm>
+          <a:prstGeom prst="ellipse">
+            <a:avLst/>
+          </a:prstGeom>
+          <a:solidFill>
+            <a:schemeClr val="accent1"/>
+          </a:solidFill>
+          <a:ln w="12700">
+            <a:solidFill>
+              <a:schemeClr val="accent1"/>
+            </a:solidFill>
+            <a:prstDash val="solid"/>
+          </a:ln>
+        </p:spPr>
+      </p:sp>
+      <p:sp>
+        <p:nvSpPr>
+          <p:cNvPr id="15" name="Text 13"/>
+          <p:cNvSpPr txBox="1"/>
+          <p:nvPr/>
+        </p:nvSpPr>
+        <p:spPr>
+          <a:xfrm>
+            <a:off x="8275320" y="1600200"/>
+            <a:ext cx="502920" cy="502920"/>
+          </a:xfrm>
+          <a:prstGeom prst="rect">
+            <a:avLst/>
+          </a:prstGeom>
+          <a:noFill/>
+          <a:ln/>
+        </p:spPr>
+        <p:txBody>
+          <a:bodyPr wrap="square" lIns="0" tIns="0" rIns="0" bIns="0" rtlCol="0" anchor="ctr"/>
+          <a:lstStyle/>
+          <a:p>
+            <a:pPr algn="ctr" indent="0" marL="0">
+              <a:buNone/>
+            </a:pPr>
+            <a:r>
+              <a:rPr lang="en-US" sz="1500" b="1" dirty="0">
+                <a:solidFill>
+                  <a:schemeClr val="bg1"/>
+                </a:solidFill>
+              </a:rPr>
+              <a:t>→</a:t>
+            </a:r>
+            <a:endParaRPr lang="en-US" sz="1500" dirty="0"/>
+          </a:p>
+        </p:txBody>
+      </p:sp>
+      <p:sp>
+        <p:nvSpPr>
+          <p:cNvPr id="16" name="Text 14"/>
+          <p:cNvSpPr txBox="1"/>
+          <p:nvPr/>
+        </p:nvSpPr>
+        <p:spPr>
+          <a:xfrm>
+            <a:off x="8961120" y="1645920"/>
+            <a:ext cx="2468880" cy="457200"/>
+          </a:xfrm>
+          <a:prstGeom prst="rect">
+            <a:avLst/>
+          </a:prstGeom>
+          <a:noFill/>
+          <a:ln/>
+        </p:spPr>
+        <p:txBody>
+          <a:bodyPr wrap="square" lIns="0" tIns="0" rIns="0" bIns="0" rtlCol="0" anchor="t"/>
+          <a:lstStyle/>
+          <a:p>
+            <a:pPr indent="0" marL="0">
+              <a:buNone/>
+            </a:pPr>
+            <a:r>
+              <a:rPr lang="en-US" sz="1600" b="1" dirty="0">
+                <a:solidFill>
+                  <a:schemeClr val="tx2"/>
+                </a:solidFill>
+                <a:latin typeface="Calibri" pitchFamily="34" charset="0"/>
+                <a:ea typeface="Calibri" pitchFamily="34" charset="-122"/>
+                <a:cs typeface="Calibri" pitchFamily="34" charset="-120"/>
+              </a:rPr>
+              <a:t>Vorbild früher nutzen</a:t>
+            </a:r>
+            <a:endParaRPr lang="en-US" sz="1600" dirty="0"/>
+          </a:p>
+        </p:txBody>
+      </p:sp>
+      <p:sp>
+        <p:nvSpPr>
+          <p:cNvPr id="17" name="Text 15"/>
+          <p:cNvSpPr txBox="1"/>
+          <p:nvPr/>
+        </p:nvSpPr>
+        <p:spPr>
+          <a:xfrm>
+            <a:off x="8275320" y="2240280"/>
+            <a:ext cx="3108960" cy="1051560"/>
+          </a:xfrm>
+          <a:prstGeom prst="rect">
+            <a:avLst/>
+          </a:prstGeom>
+          <a:noFill/>
+          <a:ln/>
+        </p:spPr>
+        <p:txBody>
+          <a:bodyPr wrap="square" lIns="0" tIns="0" rIns="0" bIns="0" rtlCol="0" anchor="t"/>
+          <a:lstStyle/>
+          <a:p>
+            <a:pPr indent="0" marL="0">
+              <a:buNone/>
+            </a:pPr>
+            <a:r>
+              <a:rPr lang="en-US" sz="1400" dirty="0">
+                <a:solidFill>
+                  <a:schemeClr val="tx1"/>
+                </a:solidFill>
+                <a:latin typeface="Calibri" pitchFamily="34" charset="0"/>
+                <a:ea typeface="Calibri" pitchFamily="34" charset="-122"/>
+                <a:cs typeface="Calibri" pitchFamily="34" charset="-120"/>
+              </a:rPr>
+              <a:t>Eine Referenz-Bewegung (z. B. der Wolf) von Anfang an als Ziel</a:t>
+            </a:r>
+            <a:endParaRPr lang="en-US" sz="1400" dirty="0"/>
+          </a:p>
+        </p:txBody>
+      </p:sp>
+      <p:sp>
+        <p:nvSpPr>
+          <p:cNvPr id="18" name="diff3"/>
+          <p:cNvSpPr/>
+          <p:nvPr/>
+        </p:nvSpPr>
+        <p:spPr>
+          <a:xfrm>
+            <a:off x="548640" y="3657600"/>
+            <a:ext cx="3520440" cy="2011680"/>
+          </a:xfrm>
+          <a:prstGeom prst="roundRect">
+            <a:avLst>
+              <a:gd name="adj" fmla="val 3636"/>
+            </a:avLst>
+          </a:prstGeom>
+          <a:solidFill>
+            <a:schemeClr val="bg2"/>
+          </a:solidFill>
+          <a:ln w="12700">
+            <a:solidFill>
+              <a:schemeClr val="bg2"/>
+            </a:solidFill>
+            <a:prstDash val="solid"/>
+          </a:ln>
+        </p:spPr>
+      </p:sp>
+      <p:sp>
+        <p:nvSpPr>
+          <p:cNvPr id="19" name="Shape 17"/>
+          <p:cNvSpPr/>
+          <p:nvPr/>
+        </p:nvSpPr>
+        <p:spPr>
+          <a:xfrm>
+            <a:off x="777240" y="3886200"/>
+            <a:ext cx="502920" cy="502920"/>
+          </a:xfrm>
+          <a:prstGeom prst="ellipse">
+            <a:avLst/>
+          </a:prstGeom>
+          <a:solidFill>
+            <a:schemeClr val="accent2"/>
+          </a:solidFill>
+          <a:ln w="12700">
+            <a:solidFill>
+              <a:schemeClr val="accent2"/>
+            </a:solidFill>
+            <a:prstDash val="solid"/>
+          </a:ln>
+        </p:spPr>
+      </p:sp>
+      <p:sp>
+        <p:nvSpPr>
+          <p:cNvPr id="20" name="Text 18"/>
+          <p:cNvSpPr txBox="1"/>
+          <p:nvPr/>
+        </p:nvSpPr>
+        <p:spPr>
+          <a:xfrm>
+            <a:off x="777240" y="3886200"/>
+            <a:ext cx="502920" cy="502920"/>
+          </a:xfrm>
+          <a:prstGeom prst="rect">
+            <a:avLst/>
+          </a:prstGeom>
+          <a:noFill/>
+          <a:ln/>
+        </p:spPr>
+        <p:txBody>
+          <a:bodyPr wrap="square" lIns="0" tIns="0" rIns="0" bIns="0" rtlCol="0" anchor="ctr"/>
+          <a:lstStyle/>
+          <a:p>
+            <a:pPr algn="ctr" indent="0" marL="0">
+              <a:buNone/>
+            </a:pPr>
+            <a:r>
+              <a:rPr lang="en-US" sz="1500" b="1" dirty="0">
+                <a:solidFill>
+                  <a:schemeClr val="bg1"/>
+                </a:solidFill>
+              </a:rPr>
+              <a:t>→</a:t>
+            </a:r>
+            <a:endParaRPr lang="en-US" sz="1500" dirty="0"/>
+          </a:p>
+        </p:txBody>
+      </p:sp>
+      <p:sp>
+        <p:nvSpPr>
+          <p:cNvPr id="21" name="Text 19"/>
+          <p:cNvSpPr txBox="1"/>
+          <p:nvPr/>
+        </p:nvSpPr>
+        <p:spPr>
+          <a:xfrm>
+            <a:off x="1463040" y="3931920"/>
+            <a:ext cx="2468880" cy="457200"/>
+          </a:xfrm>
+          <a:prstGeom prst="rect">
+            <a:avLst/>
+          </a:prstGeom>
+          <a:noFill/>
+          <a:ln/>
+        </p:spPr>
+        <p:txBody>
+          <a:bodyPr wrap="square" lIns="0" tIns="0" rIns="0" bIns="0" rtlCol="0" anchor="t"/>
+          <a:lstStyle/>
+          <a:p>
+            <a:pPr indent="0" marL="0">
+              <a:buNone/>
+            </a:pPr>
+            <a:r>
+              <a:rPr lang="en-US" sz="1600" b="1" dirty="0">
+                <a:solidFill>
+                  <a:schemeClr val="tx2"/>
+                </a:solidFill>
+                <a:latin typeface="Calibri" pitchFamily="34" charset="0"/>
+                <a:ea typeface="Calibri" pitchFamily="34" charset="-122"/>
+                <a:cs typeface="Calibri" pitchFamily="34" charset="-120"/>
+              </a:rPr>
+              <a:t>Ziele messbar festlegen</a:t>
+            </a:r>
+            <a:endParaRPr lang="en-US" sz="1600" dirty="0"/>
+          </a:p>
+        </p:txBody>
+      </p:sp>
+      <p:sp>
+        <p:nvSpPr>
+          <p:cNvPr id="22" name="Text 20"/>
+          <p:cNvSpPr txBox="1"/>
+          <p:nvPr/>
+        </p:nvSpPr>
+        <p:spPr>
+          <a:xfrm>
+            <a:off x="777240" y="4526280"/>
+            <a:ext cx="3108960" cy="1051560"/>
+          </a:xfrm>
+          <a:prstGeom prst="rect">
+            <a:avLst/>
+          </a:prstGeom>
+          <a:noFill/>
+          <a:ln/>
+        </p:spPr>
+        <p:txBody>
+          <a:bodyPr wrap="square" lIns="0" tIns="0" rIns="0" bIns="0" rtlCol="0" anchor="t"/>
+          <a:lstStyle/>
+          <a:p>
+            <a:pPr indent="0" marL="0">
+              <a:buNone/>
+            </a:pPr>
+            <a:r>
+              <a:rPr lang="en-US" sz="1400" dirty="0">
+                <a:solidFill>
+                  <a:schemeClr val="tx1"/>
+                </a:solidFill>
+                <a:latin typeface="Calibri" pitchFamily="34" charset="0"/>
+                <a:ea typeface="Calibri" pitchFamily="34" charset="-122"/>
+                <a:cs typeface="Calibri" pitchFamily="34" charset="-120"/>
+              </a:rPr>
+              <a:t>Tempo, Takt, Haltung als feste Tests vor jedem Training</a:t>
+            </a:r>
+            <a:endParaRPr lang="en-US" sz="1400" dirty="0"/>
+          </a:p>
+        </p:txBody>
+      </p:sp>
+      <p:sp>
+        <p:nvSpPr>
+          <p:cNvPr id="23" name="diff4"/>
+          <p:cNvSpPr/>
+          <p:nvPr/>
+        </p:nvSpPr>
+        <p:spPr>
+          <a:xfrm>
+            <a:off x="4297680" y="3657600"/>
+            <a:ext cx="3520440" cy="2011680"/>
+          </a:xfrm>
+          <a:prstGeom prst="roundRect">
+            <a:avLst>
+              <a:gd name="adj" fmla="val 3636"/>
+            </a:avLst>
+          </a:prstGeom>
+          <a:solidFill>
+            <a:schemeClr val="bg2"/>
+          </a:solidFill>
+          <a:ln w="12700">
+            <a:solidFill>
+              <a:schemeClr val="bg2"/>
+            </a:solidFill>
+            <a:prstDash val="solid"/>
+          </a:ln>
+        </p:spPr>
+      </p:sp>
+      <p:sp>
+        <p:nvSpPr>
+          <p:cNvPr id="24" name="Shape 22"/>
+          <p:cNvSpPr/>
+          <p:nvPr/>
+        </p:nvSpPr>
+        <p:spPr>
+          <a:xfrm>
+            <a:off x="4526280" y="3886200"/>
+            <a:ext cx="502920" cy="502920"/>
+          </a:xfrm>
+          <a:prstGeom prst="ellipse">
+            <a:avLst/>
+          </a:prstGeom>
+          <a:solidFill>
+            <a:schemeClr val="accent2"/>
+          </a:solidFill>
+          <a:ln w="12700">
+            <a:solidFill>
+              <a:schemeClr val="accent2"/>
+            </a:solidFill>
+            <a:prstDash val="solid"/>
+          </a:ln>
+        </p:spPr>
+      </p:sp>
+      <p:sp>
+        <p:nvSpPr>
+          <p:cNvPr id="25" name="Text 23"/>
+          <p:cNvSpPr txBox="1"/>
+          <p:nvPr/>
+        </p:nvSpPr>
+        <p:spPr>
+          <a:xfrm>
+            <a:off x="4526280" y="3886200"/>
+            <a:ext cx="502920" cy="502920"/>
+          </a:xfrm>
+          <a:prstGeom prst="rect">
+            <a:avLst/>
+          </a:prstGeom>
+          <a:noFill/>
+          <a:ln/>
+        </p:spPr>
+        <p:txBody>
+          <a:bodyPr wrap="square" lIns="0" tIns="0" rIns="0" bIns="0" rtlCol="0" anchor="ctr"/>
+          <a:lstStyle/>
+          <a:p>
+            <a:pPr algn="ctr" indent="0" marL="0">
+              <a:buNone/>
+            </a:pPr>
+            <a:r>
+              <a:rPr lang="en-US" sz="1500" b="1" dirty="0">
+                <a:solidFill>
+                  <a:schemeClr val="bg1"/>
+                </a:solidFill>
+              </a:rPr>
+              <a:t>→</a:t>
+            </a:r>
+            <a:endParaRPr lang="en-US" sz="1500" dirty="0"/>
+          </a:p>
+        </p:txBody>
+      </p:sp>
+      <p:sp>
+        <p:nvSpPr>
+          <p:cNvPr id="26" name="Text 24"/>
+          <p:cNvSpPr txBox="1"/>
+          <p:nvPr/>
+        </p:nvSpPr>
+        <p:spPr>
+          <a:xfrm>
+            <a:off x="5212080" y="3931920"/>
+            <a:ext cx="2468880" cy="457200"/>
+          </a:xfrm>
+          <a:prstGeom prst="rect">
+            <a:avLst/>
+          </a:prstGeom>
+          <a:noFill/>
+          <a:ln/>
+        </p:spPr>
+        <p:txBody>
+          <a:bodyPr wrap="square" lIns="0" tIns="0" rIns="0" bIns="0" rtlCol="0" anchor="t"/>
+          <a:lstStyle/>
+          <a:p>
+            <a:pPr indent="0" marL="0">
+              <a:buNone/>
+            </a:pPr>
+            <a:r>
+              <a:rPr lang="en-US" sz="1600" b="1" dirty="0">
+                <a:solidFill>
+                  <a:schemeClr val="tx2"/>
+                </a:solidFill>
+                <a:latin typeface="Calibri" pitchFamily="34" charset="0"/>
+                <a:ea typeface="Calibri" pitchFamily="34" charset="-122"/>
+                <a:cs typeface="Calibri" pitchFamily="34" charset="-120"/>
+              </a:rPr>
+              <a:t>Stärkere Hardware</a:t>
+            </a:r>
+            <a:endParaRPr lang="en-US" sz="1600" dirty="0"/>
+          </a:p>
+        </p:txBody>
+      </p:sp>
+      <p:sp>
+        <p:nvSpPr>
+          <p:cNvPr id="27" name="Text 25"/>
+          <p:cNvSpPr txBox="1"/>
+          <p:nvPr/>
+        </p:nvSpPr>
+        <p:spPr>
+          <a:xfrm>
+            <a:off x="4526280" y="4526280"/>
+            <a:ext cx="3108960" cy="1051560"/>
+          </a:xfrm>
+          <a:prstGeom prst="rect">
+            <a:avLst/>
+          </a:prstGeom>
+          <a:noFill/>
+          <a:ln/>
+        </p:spPr>
+        <p:txBody>
+          <a:bodyPr wrap="square" lIns="0" tIns="0" rIns="0" bIns="0" rtlCol="0" anchor="t"/>
+          <a:lstStyle/>
+          <a:p>
+            <a:pPr indent="0" marL="0">
+              <a:buNone/>
+            </a:pPr>
+            <a:r>
+              <a:rPr lang="en-US" sz="1400" dirty="0">
+                <a:solidFill>
+                  <a:schemeClr val="tx1"/>
+                </a:solidFill>
+                <a:latin typeface="Calibri" pitchFamily="34" charset="0"/>
+                <a:ea typeface="Calibri" pitchFamily="34" charset="-122"/>
+                <a:cs typeface="Calibri" pitchFamily="34" charset="-120"/>
+              </a:rPr>
+              <a:t>Rechner mit Grafikkarte oder Cloud: Rendern 10–20× schneller, nichts schläft ein</a:t>
+            </a:r>
+            <a:endParaRPr lang="en-US" sz="1400" dirty="0"/>
+          </a:p>
+        </p:txBody>
+      </p:sp>
+      <p:sp>
+        <p:nvSpPr>
+          <p:cNvPr id="28" name="diff5"/>
+          <p:cNvSpPr/>
+          <p:nvPr/>
+        </p:nvSpPr>
+        <p:spPr>
+          <a:xfrm>
+            <a:off x="8046720" y="3657600"/>
+            <a:ext cx="3520440" cy="2011680"/>
+          </a:xfrm>
+          <a:prstGeom prst="roundRect">
+            <a:avLst>
+              <a:gd name="adj" fmla="val 3636"/>
+            </a:avLst>
+          </a:prstGeom>
+          <a:solidFill>
+            <a:schemeClr val="bg2"/>
+          </a:solidFill>
+          <a:ln w="12700">
+            <a:solidFill>
+              <a:schemeClr val="bg2"/>
+            </a:solidFill>
+            <a:prstDash val="solid"/>
+          </a:ln>
+        </p:spPr>
+      </p:sp>
+      <p:sp>
+        <p:nvSpPr>
+          <p:cNvPr id="29" name="Shape 27"/>
+          <p:cNvSpPr/>
+          <p:nvPr/>
+        </p:nvSpPr>
+        <p:spPr>
+          <a:xfrm>
+            <a:off x="8275320" y="3886200"/>
+            <a:ext cx="502920" cy="502920"/>
+          </a:xfrm>
+          <a:prstGeom prst="ellipse">
+            <a:avLst/>
+          </a:prstGeom>
+          <a:solidFill>
+            <a:schemeClr val="accent2"/>
+          </a:solidFill>
+          <a:ln w="12700">
+            <a:solidFill>
+              <a:schemeClr val="accent2"/>
+            </a:solidFill>
+            <a:prstDash val="solid"/>
+          </a:ln>
+        </p:spPr>
+      </p:sp>
+      <p:sp>
+        <p:nvSpPr>
+          <p:cNvPr id="30" name="Text 28"/>
+          <p:cNvSpPr txBox="1"/>
+          <p:nvPr/>
+        </p:nvSpPr>
+        <p:spPr>
+          <a:xfrm>
+            <a:off x="8275320" y="3886200"/>
+            <a:ext cx="502920" cy="502920"/>
+          </a:xfrm>
+          <a:prstGeom prst="rect">
+            <a:avLst/>
+          </a:prstGeom>
+          <a:noFill/>
+          <a:ln/>
+        </p:spPr>
+        <p:txBody>
+          <a:bodyPr wrap="square" lIns="0" tIns="0" rIns="0" bIns="0" rtlCol="0" anchor="ctr"/>
+          <a:lstStyle/>
+          <a:p>
+            <a:pPr algn="ctr" indent="0" marL="0">
+              <a:buNone/>
+            </a:pPr>
+            <a:r>
+              <a:rPr lang="en-US" sz="1500" b="1" dirty="0">
+                <a:solidFill>
+                  <a:schemeClr val="bg1"/>
+                </a:solidFill>
+              </a:rPr>
+              <a:t>→</a:t>
+            </a:r>
+            <a:endParaRPr lang="en-US" sz="1500" dirty="0"/>
+          </a:p>
+        </p:txBody>
+      </p:sp>
+      <p:sp>
+        <p:nvSpPr>
+          <p:cNvPr id="31" name="Text 29"/>
+          <p:cNvSpPr txBox="1"/>
+          <p:nvPr/>
+        </p:nvSpPr>
+        <p:spPr>
+          <a:xfrm>
+            <a:off x="8961120" y="3931920"/>
+            <a:ext cx="2468880" cy="457200"/>
+          </a:xfrm>
+          <a:prstGeom prst="rect">
+            <a:avLst/>
+          </a:prstGeom>
+          <a:noFill/>
+          <a:ln/>
+        </p:spPr>
+        <p:txBody>
+          <a:bodyPr wrap="square" lIns="0" tIns="0" rIns="0" bIns="0" rtlCol="0" anchor="t"/>
+          <a:lstStyle/>
+          <a:p>
+            <a:pPr indent="0" marL="0">
+              <a:buNone/>
+            </a:pPr>
+            <a:r>
+              <a:rPr lang="en-US" sz="1600" b="1" dirty="0">
+                <a:solidFill>
+                  <a:schemeClr val="tx2"/>
+                </a:solidFill>
+                <a:latin typeface="Calibri" pitchFamily="34" charset="0"/>
+                <a:ea typeface="Calibri" pitchFamily="34" charset="-122"/>
+                <a:cs typeface="Calibri" pitchFamily="34" charset="-120"/>
+              </a:rPr>
+              <a:t>Weniger auf einmal</a:t>
+            </a:r>
+            <a:endParaRPr lang="en-US" sz="1600" dirty="0"/>
+          </a:p>
+        </p:txBody>
+      </p:sp>
+      <p:sp>
+        <p:nvSpPr>
+          <p:cNvPr id="32" name="Text 30"/>
+          <p:cNvSpPr txBox="1"/>
+          <p:nvPr/>
+        </p:nvSpPr>
+        <p:spPr>
+          <a:xfrm>
+            <a:off x="8275320" y="4526280"/>
+            <a:ext cx="3108960" cy="1051560"/>
+          </a:xfrm>
+          <a:prstGeom prst="rect">
+            <a:avLst/>
+          </a:prstGeom>
+          <a:noFill/>
+          <a:ln/>
+        </p:spPr>
+        <p:txBody>
+          <a:bodyPr wrap="square" lIns="0" tIns="0" rIns="0" bIns="0" rtlCol="0" anchor="t"/>
+          <a:lstStyle/>
+          <a:p>
+            <a:pPr indent="0" marL="0">
+              <a:buNone/>
+            </a:pPr>
+            <a:r>
+              <a:rPr lang="en-US" sz="1400" dirty="0">
+                <a:solidFill>
+                  <a:schemeClr val="tx1"/>
+                </a:solidFill>
+                <a:latin typeface="Calibri" pitchFamily="34" charset="0"/>
+                <a:ea typeface="Calibri" pitchFamily="34" charset="-122"/>
+                <a:cs typeface="Calibri" pitchFamily="34" charset="-120"/>
+              </a:rPr>
+              <a:t>Erst ein Tier fertig, dann das zweite; weniger Ideen parallel</a:t>
+            </a:r>
+            <a:endParaRPr lang="en-US" sz="1400" dirty="0"/>
+          </a:p>
+        </p:txBody>
+      </p:sp>
+      <p:sp>
+        <p:nvSpPr>
+          <p:cNvPr id="25" name="Slide Number Placeholder 0"/>
+          <p:cNvSpPr>
+            <a:spLocks noGrp="1"/>
+          </p:cNvSpPr>
+          <p:nvPr>
+            <p:ph type="sldNum" sz="quarter" idx="4294967295"/>
+          </p:nvPr>
+        </p:nvSpPr>
+        <p:spPr>
+          <a:xfrm>
+            <a:off x="11247120" y="6400800"/>
+            <a:ext cx="548640" cy="274320"/>
+          </a:xfrm>
+          <a:prstGeom prst="rect">
+            <a:avLst/>
+          </a:prstGeom>
+          <a:extLst>
+            <a:ext uri="{C572A759-6A51-4108-AA02-DFA0A04FC94B}">
+              <ma14:wrappingTextBoxFlag xmlns:ma14="http://schemas.microsoft.com/office/mac/drawingml/2011/main" val="0"/>
+            </a:ext>
+          </a:extLst>
+        </p:spPr>
+        <p:txBody>
+          <a:bodyPr/>
+          <a:lstStyle>
+            <a:lvl1pPr>
+              <a:defRPr sz="1000">
+                <a:solidFill>
+                  <a:srgbClr val="8FA89B"/>
+                </a:solidFill>
+              </a:defRPr>
+            </a:lvl1pPr>
+          </a:lstStyle>
+          <a:p>
+            <a:pPr algn="l"/>
+            <a:fld id="{F7021451-1387-4CA6-816F-3879F97B5CBC}" type="slidenum">
+              <a:rPr b="0" lang="en-US"/>
+              <a:t>10</a:t>
+            </a:fld>
+            <a:endParaRPr lang="en-US"/>
+          </a:p>
+        </p:txBody>
+      </p:sp>
+    </p:spTree>
+  </p:cSld>
+  <p:clrMapOvr>
+    <a:masterClrMapping/>
+  </p:clrMapOvr>
+</p:sld>
+</file>
+
+<file path=ppt/slides/slide11.xml><?xml version="1.0" encoding="utf-8"?>
+<p:sld xmlns:a="http://schemas.openxmlformats.org/drawingml/2006/main" xmlns:r="http://schemas.openxmlformats.org/officeDocument/2006/relationships" xmlns:p="http://schemas.openxmlformats.org/presentationml/2006/main">
+  <p:cSld name="Slide 11">
+    <p:spTree>
+      <p:nvGrpSpPr>
+        <p:cNvPr id="1" name=""/>
+        <p:cNvGrpSpPr/>
+        <p:nvPr/>
+      </p:nvGrpSpPr>
+      <p:grpSpPr>
+        <a:xfrm>
+          <a:off x="0" y="0"/>
+          <a:ext cx="0" cy="0"/>
+          <a:chOff x="0" y="0"/>
+          <a:chExt cx="0" cy="0"/>
+        </a:xfrm>
+      </p:grpSpPr>
       <p:pic>
         <p:nvPicPr>
           <p:cNvPr id="2" name="outro" descr="C:\Users\thoma\PycharmProjects\Reinforcement_Learning_Creature\docs\figures\showcase_v6_still.jpg">    </p:cNvPr>
@@ -6145,7 +7342,7 @@
                 <a:ea typeface="Cambria" pitchFamily="34" charset="-122"/>
                 <a:cs typeface="Cambria" pitchFamily="34" charset="-120"/>
               </a:rPr>
-              <a:t>Was ist herausgekommen?</a:t>
+              <a:t>Was ist herausgekommen? Überblick und DC</a:t>
             </a:r>
             <a:endParaRPr lang="en-US" sz="3200" dirty="0"/>
           </a:p>
@@ -7734,26 +8931,89 @@
                 <a:ea typeface="Cambria" pitchFamily="34" charset="-122"/>
                 <a:cs typeface="Cambria" pitchFamily="34" charset="-120"/>
               </a:rPr>
-              <a:t>Was habe ich gelernt?</a:t>
+              <a:t>Was ist herausgekommen? Myrranox</a:t>
             </a:r>
             <a:endParaRPr lang="en-US" sz="3200" dirty="0"/>
           </a:p>
         </p:txBody>
       </p:sp>
-      <p:sp>
-        <p:nvSpPr>
-          <p:cNvPr id="3" name="learn0"/>
+      <p:pic>
+        <p:nvPicPr>
+          <p:cNvPr id="3" name="myr_body" descr="C:\Users\thoma\PycharmProjects\Reinforcement_Learning_Creature\docs\presentation\src\myrranox_physics_body_mesh_deck.jpg">    </p:cNvPr>
+          <p:cNvPicPr>
+            <a:picLocks noChangeAspect="1"/>
+          </p:cNvPicPr>
+          <p:nvPr/>
+        </p:nvPicPr>
+        <p:blipFill>
+          <a:blip r:embed="rId1"/>
+          <a:stretch>
+            <a:fillRect/>
+          </a:stretch>
+        </p:blipFill>
+        <p:spPr>
+          <a:xfrm>
+            <a:off x="548640" y="1325880"/>
+            <a:ext cx="5120640" cy="3848239"/>
+          </a:xfrm>
+          <a:prstGeom prst="rect">
+            <a:avLst/>
+          </a:prstGeom>
+        </p:spPr>
+      </p:pic>
+      <p:sp>
+        <p:nvSpPr>
+          <p:cNvPr id="4" name="Text 1"/>
+          <p:cNvSpPr txBox="1"/>
+          <p:nvPr/>
+        </p:nvSpPr>
+        <p:spPr>
+          <a:xfrm>
+            <a:off x="548640" y="5257800"/>
+            <a:ext cx="5120640" cy="365760"/>
+          </a:xfrm>
+          <a:prstGeom prst="rect">
+            <a:avLst/>
+          </a:prstGeom>
+          <a:noFill/>
+          <a:ln/>
+        </p:spPr>
+        <p:txBody>
+          <a:bodyPr wrap="square" lIns="0" tIns="0" rIns="0" bIns="0" rtlCol="0" anchor="t"/>
+          <a:lstStyle/>
+          <a:p>
+            <a:pPr indent="0" marL="0">
+              <a:buNone/>
+            </a:pPr>
+            <a:r>
+              <a:rPr lang="en-US" sz="1300" i="1" dirty="0">
+                <a:solidFill>
+                  <a:schemeClr val="tx2"/>
+                </a:solidFill>
+                <a:latin typeface="Calibri" pitchFamily="34" charset="0"/>
+                <a:ea typeface="Calibri" pitchFamily="34" charset="-122"/>
+                <a:cs typeface="Calibri" pitchFamily="34" charset="-120"/>
+              </a:rPr>
+              <a:t>Physik-Körper aus dem echten Modell: 21 Hüllen, Krallen als Füße</a:t>
+            </a:r>
+            <a:endParaRPr lang="en-US" sz="1300" dirty="0"/>
+          </a:p>
+        </p:txBody>
+      </p:sp>
+      <p:sp>
+        <p:nvSpPr>
+          <p:cNvPr id="5" name="myr_stat0"/>
           <p:cNvSpPr/>
           <p:nvPr/>
         </p:nvSpPr>
         <p:spPr>
           <a:xfrm>
-            <a:off x="548640" y="1325880"/>
-            <a:ext cx="5394960" cy="1371600"/>
+            <a:off x="5989320" y="1325880"/>
+            <a:ext cx="1298448" cy="1600200"/>
           </a:xfrm>
           <a:prstGeom prst="roundRect">
             <a:avLst>
-              <a:gd name="adj" fmla="val 5333"/>
+              <a:gd name="adj" fmla="val 5634"/>
             </a:avLst>
           </a:prstGeom>
           <a:solidFill>
@@ -7769,75 +9029,53 @@
       </p:sp>
       <p:sp>
         <p:nvSpPr>
-          <p:cNvPr id="4" name="Shape 2"/>
-          <p:cNvSpPr/>
-          <p:nvPr/>
-        </p:nvSpPr>
-        <p:spPr>
-          <a:xfrm>
-            <a:off x="777240" y="1737360"/>
-            <a:ext cx="502920" cy="502920"/>
-          </a:xfrm>
-          <a:prstGeom prst="ellipse">
-            <a:avLst/>
-          </a:prstGeom>
-          <a:solidFill>
-            <a:schemeClr val="accent1"/>
-          </a:solidFill>
-          <a:ln w="12700">
-            <a:solidFill>
-              <a:schemeClr val="accent1"/>
-            </a:solidFill>
-            <a:prstDash val="solid"/>
-          </a:ln>
-        </p:spPr>
-      </p:sp>
-      <p:sp>
-        <p:nvSpPr>
-          <p:cNvPr id="5" name="Text 3"/>
+          <p:cNvPr id="6" name="Text 3"/>
           <p:cNvSpPr txBox="1"/>
           <p:nvPr/>
         </p:nvSpPr>
         <p:spPr>
           <a:xfrm>
-            <a:off x="777240" y="1737360"/>
-            <a:ext cx="502920" cy="502920"/>
-          </a:xfrm>
-          <a:prstGeom prst="rect">
-            <a:avLst/>
-          </a:prstGeom>
-          <a:noFill/>
-          <a:ln/>
-        </p:spPr>
-        <p:txBody>
-          <a:bodyPr wrap="square" lIns="0" tIns="0" rIns="0" bIns="0" rtlCol="0" anchor="ctr"/>
+            <a:off x="6035040" y="1463040"/>
+            <a:ext cx="1207008" cy="502920"/>
+          </a:xfrm>
+          <a:prstGeom prst="rect">
+            <a:avLst/>
+          </a:prstGeom>
+          <a:noFill/>
+          <a:ln/>
+        </p:spPr>
+        <p:txBody>
+          <a:bodyPr wrap="square" lIns="0" tIns="0" rIns="0" bIns="0" rtlCol="0" anchor="t"/>
           <a:lstStyle/>
           <a:p>
             <a:pPr algn="ctr" indent="0" marL="0">
               <a:buNone/>
             </a:pPr>
             <a:r>
-              <a:rPr lang="en-US" sz="1500" b="1" dirty="0">
-                <a:solidFill>
-                  <a:schemeClr val="bg1"/>
-                </a:solidFill>
-              </a:rPr>
-              <a:t>1</a:t>
-            </a:r>
-            <a:endParaRPr lang="en-US" sz="1500" dirty="0"/>
-          </a:p>
-        </p:txBody>
-      </p:sp>
-      <p:sp>
-        <p:nvSpPr>
-          <p:cNvPr id="6" name="Text 4"/>
+              <a:rPr lang="en-US" sz="1900" b="1" dirty="0">
+                <a:solidFill>
+                  <a:schemeClr val="accent2"/>
+                </a:solidFill>
+                <a:latin typeface="Cambria" pitchFamily="34" charset="0"/>
+                <a:ea typeface="Cambria" pitchFamily="34" charset="-122"/>
+                <a:cs typeface="Cambria" pitchFamily="34" charset="-120"/>
+              </a:rPr>
+              <a:t>0,52 m/s</a:t>
+            </a:r>
+            <a:endParaRPr lang="en-US" sz="1900" dirty="0"/>
+          </a:p>
+        </p:txBody>
+      </p:sp>
+      <p:sp>
+        <p:nvSpPr>
+          <p:cNvPr id="7" name="Text 4"/>
           <p:cNvSpPr txBox="1"/>
           <p:nvPr/>
         </p:nvSpPr>
         <p:spPr>
           <a:xfrm>
-            <a:off x="1463040" y="1490472"/>
-            <a:ext cx="4297680" cy="411480"/>
+            <a:off x="6035040" y="2057400"/>
+            <a:ext cx="1207008" cy="777240"/>
           </a:xfrm>
           <a:prstGeom prst="rect">
             <a:avLst/>
@@ -7849,11 +9087,11 @@
           <a:bodyPr wrap="square" lIns="0" tIns="0" rIns="0" bIns="0" rtlCol="0" anchor="t"/>
           <a:lstStyle/>
           <a:p>
-            <a:pPr indent="0" marL="0">
-              <a:buNone/>
-            </a:pPr>
-            <a:r>
-              <a:rPr lang="en-US" sz="1600" b="1" dirty="0">
+            <a:pPr algn="ctr" indent="0" marL="0">
+              <a:buNone/>
+            </a:pPr>
+            <a:r>
+              <a:rPr lang="en-US" sz="1200" dirty="0">
                 <a:solidFill>
                   <a:schemeClr val="tx2"/>
                 </a:solidFill>
@@ -7861,65 +9099,43 @@
                 <a:ea typeface="Calibri" pitchFamily="34" charset="-122"/>
                 <a:cs typeface="Calibri" pitchFamily="34" charset="-120"/>
               </a:rPr>
-              <a:t>Belohnung ist alles</a:t>
-            </a:r>
-            <a:endParaRPr lang="en-US" sz="1600" dirty="0"/>
-          </a:p>
-        </p:txBody>
-      </p:sp>
-      <p:sp>
-        <p:nvSpPr>
-          <p:cNvPr id="7" name="Text 5"/>
-          <p:cNvSpPr txBox="1"/>
-          <p:nvPr/>
-        </p:nvSpPr>
-        <p:spPr>
-          <a:xfrm>
-            <a:off x="1463040" y="1920240"/>
-            <a:ext cx="4297680" cy="731520"/>
-          </a:xfrm>
-          <a:prstGeom prst="rect">
-            <a:avLst/>
-          </a:prstGeom>
-          <a:noFill/>
-          <a:ln/>
-        </p:spPr>
-        <p:txBody>
-          <a:bodyPr wrap="square" lIns="0" tIns="0" rIns="0" bIns="0" rtlCol="0" anchor="t"/>
-          <a:lstStyle/>
-          <a:p>
-            <a:pPr indent="0" marL="0">
-              <a:buNone/>
-            </a:pPr>
-            <a:r>
-              <a:rPr lang="en-US" sz="1400" dirty="0">
-                <a:solidFill>
-                  <a:schemeClr val="tx1"/>
+              <a:t>Gehen</a:t>
+            </a:r>
+            <a:endParaRPr lang="en-US" sz="1200" dirty="0"/>
+          </a:p>
+          <a:p>
+            <a:pPr algn="ctr" indent="0" marL="0">
+              <a:buNone/>
+            </a:pPr>
+            <a:r>
+              <a:rPr lang="en-US" sz="1200" dirty="0">
+                <a:solidFill>
+                  <a:schemeClr val="tx2"/>
                 </a:solidFill>
                 <a:latin typeface="Calibri" pitchFamily="34" charset="0"/>
                 <a:ea typeface="Calibri" pitchFamily="34" charset="-122"/>
                 <a:cs typeface="Calibri" pitchFamily="34" charset="-120"/>
               </a:rPr>
-              <a:t>Das Gehirn findet jedes Schlupfloch: Stillstehen, Handstand, „Planke“ – wenn es Punkte bringt</a:t>
-            </a:r>
-            <a:endParaRPr lang="en-US" sz="1400" dirty="0"/>
-          </a:p>
-        </p:txBody>
-      </p:sp>
-      <p:sp>
-        <p:nvSpPr>
-          <p:cNvPr id="8" name="learn1"/>
+              <a:t>(Befehl 0,6)</a:t>
+            </a:r>
+            <a:endParaRPr lang="en-US" sz="1200" dirty="0"/>
+          </a:p>
+        </p:txBody>
+      </p:sp>
+      <p:sp>
+        <p:nvSpPr>
+          <p:cNvPr id="8" name="myr_stat1"/>
           <p:cNvSpPr/>
           <p:nvPr/>
         </p:nvSpPr>
         <p:spPr>
           <a:xfrm>
-            <a:off x="6217920" y="1325880"/>
-            <a:ext cx="5394960" cy="1371600"/>
+            <a:off x="7406640" y="1325880"/>
+            <a:ext cx="1298448" cy="1600200"/>
           </a:xfrm>
           <a:prstGeom prst="roundRect">
             <a:avLst>
-              <a:gd name="adj" fmla="val 5333"/>
+              <a:gd name="adj" fmla="val 5634"/>
             </a:avLst>
           </a:prstGeom>
           <a:solidFill>
@@ -7935,75 +9151,53 @@
       </p:sp>
       <p:sp>
         <p:nvSpPr>
-          <p:cNvPr id="9" name="Shape 7"/>
-          <p:cNvSpPr/>
-          <p:nvPr/>
-        </p:nvSpPr>
-        <p:spPr>
-          <a:xfrm>
-            <a:off x="6446520" y="1737360"/>
-            <a:ext cx="502920" cy="502920"/>
-          </a:xfrm>
-          <a:prstGeom prst="ellipse">
-            <a:avLst/>
-          </a:prstGeom>
-          <a:solidFill>
-            <a:schemeClr val="accent2"/>
-          </a:solidFill>
-          <a:ln w="12700">
-            <a:solidFill>
-              <a:schemeClr val="accent2"/>
-            </a:solidFill>
-            <a:prstDash val="solid"/>
-          </a:ln>
-        </p:spPr>
-      </p:sp>
-      <p:sp>
-        <p:nvSpPr>
-          <p:cNvPr id="10" name="Text 8"/>
+          <p:cNvPr id="9" name="Text 6"/>
           <p:cNvSpPr txBox="1"/>
           <p:nvPr/>
         </p:nvSpPr>
         <p:spPr>
           <a:xfrm>
-            <a:off x="6446520" y="1737360"/>
-            <a:ext cx="502920" cy="502920"/>
-          </a:xfrm>
-          <a:prstGeom prst="rect">
-            <a:avLst/>
-          </a:prstGeom>
-          <a:noFill/>
-          <a:ln/>
-        </p:spPr>
-        <p:txBody>
-          <a:bodyPr wrap="square" lIns="0" tIns="0" rIns="0" bIns="0" rtlCol="0" anchor="ctr"/>
+            <a:off x="7452360" y="1463040"/>
+            <a:ext cx="1207008" cy="502920"/>
+          </a:xfrm>
+          <a:prstGeom prst="rect">
+            <a:avLst/>
+          </a:prstGeom>
+          <a:noFill/>
+          <a:ln/>
+        </p:spPr>
+        <p:txBody>
+          <a:bodyPr wrap="square" lIns="0" tIns="0" rIns="0" bIns="0" rtlCol="0" anchor="t"/>
           <a:lstStyle/>
           <a:p>
             <a:pPr algn="ctr" indent="0" marL="0">
               <a:buNone/>
             </a:pPr>
             <a:r>
-              <a:rPr lang="en-US" sz="1500" b="1" dirty="0">
-                <a:solidFill>
-                  <a:schemeClr val="bg1"/>
-                </a:solidFill>
-              </a:rPr>
-              <a:t>2</a:t>
-            </a:r>
-            <a:endParaRPr lang="en-US" sz="1500" dirty="0"/>
-          </a:p>
-        </p:txBody>
-      </p:sp>
-      <p:sp>
-        <p:nvSpPr>
-          <p:cNvPr id="11" name="Text 9"/>
+              <a:rPr lang="en-US" sz="1900" b="1" dirty="0">
+                <a:solidFill>
+                  <a:schemeClr val="accent1"/>
+                </a:solidFill>
+                <a:latin typeface="Cambria" pitchFamily="34" charset="0"/>
+                <a:ea typeface="Cambria" pitchFamily="34" charset="-122"/>
+                <a:cs typeface="Cambria" pitchFamily="34" charset="-120"/>
+              </a:rPr>
+              <a:t>1,08 m/s</a:t>
+            </a:r>
+            <a:endParaRPr lang="en-US" sz="1900" dirty="0"/>
+          </a:p>
+        </p:txBody>
+      </p:sp>
+      <p:sp>
+        <p:nvSpPr>
+          <p:cNvPr id="10" name="Text 7"/>
           <p:cNvSpPr txBox="1"/>
           <p:nvPr/>
         </p:nvSpPr>
         <p:spPr>
           <a:xfrm>
-            <a:off x="7132320" y="1490472"/>
-            <a:ext cx="4297680" cy="411480"/>
+            <a:off x="7452360" y="2057400"/>
+            <a:ext cx="1207008" cy="777240"/>
           </a:xfrm>
           <a:prstGeom prst="rect">
             <a:avLst/>
@@ -8015,11 +9209,11 @@
           <a:bodyPr wrap="square" lIns="0" tIns="0" rIns="0" bIns="0" rtlCol="0" anchor="t"/>
           <a:lstStyle/>
           <a:p>
-            <a:pPr indent="0" marL="0">
-              <a:buNone/>
-            </a:pPr>
-            <a:r>
-              <a:rPr lang="en-US" sz="1600" b="1" dirty="0">
+            <a:pPr algn="ctr" indent="0" marL="0">
+              <a:buNone/>
+            </a:pPr>
+            <a:r>
+              <a:rPr lang="en-US" sz="1200" dirty="0">
                 <a:solidFill>
                   <a:schemeClr val="tx2"/>
                 </a:solidFill>
@@ -8027,65 +9221,43 @@
                 <a:ea typeface="Calibri" pitchFamily="34" charset="-122"/>
                 <a:cs typeface="Calibri" pitchFamily="34" charset="-120"/>
               </a:rPr>
-              <a:t>Erst der Körper, dann das Lernen</a:t>
-            </a:r>
-            <a:endParaRPr lang="en-US" sz="1600" dirty="0"/>
-          </a:p>
-        </p:txBody>
-      </p:sp>
-      <p:sp>
-        <p:nvSpPr>
-          <p:cNvPr id="12" name="Text 10"/>
-          <p:cNvSpPr txBox="1"/>
-          <p:nvPr/>
-        </p:nvSpPr>
-        <p:spPr>
-          <a:xfrm>
-            <a:off x="7132320" y="1920240"/>
-            <a:ext cx="4297680" cy="731520"/>
-          </a:xfrm>
-          <a:prstGeom prst="rect">
-            <a:avLst/>
-          </a:prstGeom>
-          <a:noFill/>
-          <a:ln/>
-        </p:spPr>
-        <p:txBody>
-          <a:bodyPr wrap="square" lIns="0" tIns="0" rIns="0" bIns="0" rtlCol="0" anchor="t"/>
-          <a:lstStyle/>
-          <a:p>
-            <a:pPr indent="0" marL="0">
-              <a:buNone/>
-            </a:pPr>
-            <a:r>
-              <a:rPr lang="en-US" sz="1400" dirty="0">
-                <a:solidFill>
-                  <a:schemeClr val="tx1"/>
+              <a:t>Vollgas</a:t>
+            </a:r>
+            <a:endParaRPr lang="en-US" sz="1200" dirty="0"/>
+          </a:p>
+          <a:p>
+            <a:pPr algn="ctr" indent="0" marL="0">
+              <a:buNone/>
+            </a:pPr>
+            <a:r>
+              <a:rPr lang="en-US" sz="1200" dirty="0">
+                <a:solidFill>
+                  <a:schemeClr val="tx2"/>
                 </a:solidFill>
                 <a:latin typeface="Calibri" pitchFamily="34" charset="0"/>
                 <a:ea typeface="Calibri" pitchFamily="34" charset="-122"/>
                 <a:cs typeface="Calibri" pitchFamily="34" charset="-120"/>
               </a:rPr>
-              <a:t>Falsche Masse, Geometrie oder Gelenke kann keine Regel ausgleichen</a:t>
-            </a:r>
-            <a:endParaRPr lang="en-US" sz="1400" dirty="0"/>
-          </a:p>
-        </p:txBody>
-      </p:sp>
-      <p:sp>
-        <p:nvSpPr>
-          <p:cNvPr id="13" name="learn2"/>
+              <a:t>(Befehl 1,2)</a:t>
+            </a:r>
+            <a:endParaRPr lang="en-US" sz="1200" dirty="0"/>
+          </a:p>
+        </p:txBody>
+      </p:sp>
+      <p:sp>
+        <p:nvSpPr>
+          <p:cNvPr id="11" name="myr_stat2"/>
           <p:cNvSpPr/>
           <p:nvPr/>
         </p:nvSpPr>
         <p:spPr>
           <a:xfrm>
-            <a:off x="548640" y="2898648"/>
-            <a:ext cx="5394960" cy="1371600"/>
+            <a:off x="8823960" y="1325880"/>
+            <a:ext cx="1298448" cy="1600200"/>
           </a:xfrm>
           <a:prstGeom prst="roundRect">
             <a:avLst>
-              <a:gd name="adj" fmla="val 5333"/>
+              <a:gd name="adj" fmla="val 5634"/>
             </a:avLst>
           </a:prstGeom>
           <a:solidFill>
@@ -8101,75 +9273,53 @@
       </p:sp>
       <p:sp>
         <p:nvSpPr>
-          <p:cNvPr id="14" name="Shape 12"/>
-          <p:cNvSpPr/>
-          <p:nvPr/>
-        </p:nvSpPr>
-        <p:spPr>
-          <a:xfrm>
-            <a:off x="777240" y="3310128"/>
-            <a:ext cx="502920" cy="502920"/>
-          </a:xfrm>
-          <a:prstGeom prst="ellipse">
-            <a:avLst/>
-          </a:prstGeom>
-          <a:solidFill>
-            <a:schemeClr val="accent1"/>
-          </a:solidFill>
-          <a:ln w="12700">
-            <a:solidFill>
-              <a:schemeClr val="accent1"/>
-            </a:solidFill>
-            <a:prstDash val="solid"/>
-          </a:ln>
-        </p:spPr>
-      </p:sp>
-      <p:sp>
-        <p:nvSpPr>
-          <p:cNvPr id="15" name="Text 13"/>
+          <p:cNvPr id="12" name="Text 9"/>
           <p:cNvSpPr txBox="1"/>
           <p:nvPr/>
         </p:nvSpPr>
         <p:spPr>
           <a:xfrm>
-            <a:off x="777240" y="3310128"/>
-            <a:ext cx="502920" cy="502920"/>
-          </a:xfrm>
-          <a:prstGeom prst="rect">
-            <a:avLst/>
-          </a:prstGeom>
-          <a:noFill/>
-          <a:ln/>
-        </p:spPr>
-        <p:txBody>
-          <a:bodyPr wrap="square" lIns="0" tIns="0" rIns="0" bIns="0" rtlCol="0" anchor="ctr"/>
+            <a:off x="8869680" y="1463040"/>
+            <a:ext cx="1207008" cy="502920"/>
+          </a:xfrm>
+          <a:prstGeom prst="rect">
+            <a:avLst/>
+          </a:prstGeom>
+          <a:noFill/>
+          <a:ln/>
+        </p:spPr>
+        <p:txBody>
+          <a:bodyPr wrap="square" lIns="0" tIns="0" rIns="0" bIns="0" rtlCol="0" anchor="t"/>
           <a:lstStyle/>
           <a:p>
             <a:pPr algn="ctr" indent="0" marL="0">
               <a:buNone/>
             </a:pPr>
             <a:r>
-              <a:rPr lang="en-US" sz="1500" b="1" dirty="0">
-                <a:solidFill>
-                  <a:schemeClr val="bg1"/>
-                </a:solidFill>
-              </a:rPr>
-              <a:t>3</a:t>
-            </a:r>
-            <a:endParaRPr lang="en-US" sz="1500" dirty="0"/>
-          </a:p>
-        </p:txBody>
-      </p:sp>
-      <p:sp>
-        <p:nvSpPr>
-          <p:cNvPr id="16" name="Text 14"/>
+              <a:rPr lang="en-US" sz="1900" b="1" dirty="0">
+                <a:solidFill>
+                  <a:schemeClr val="accent2"/>
+                </a:solidFill>
+                <a:latin typeface="Cambria" pitchFamily="34" charset="0"/>
+                <a:ea typeface="Cambria" pitchFamily="34" charset="-122"/>
+                <a:cs typeface="Cambria" pitchFamily="34" charset="-120"/>
+              </a:rPr>
+              <a:t>56 °/s</a:t>
+            </a:r>
+            <a:endParaRPr lang="en-US" sz="1900" dirty="0"/>
+          </a:p>
+        </p:txBody>
+      </p:sp>
+      <p:sp>
+        <p:nvSpPr>
+          <p:cNvPr id="13" name="Text 10"/>
           <p:cNvSpPr txBox="1"/>
           <p:nvPr/>
         </p:nvSpPr>
         <p:spPr>
           <a:xfrm>
-            <a:off x="1463040" y="3063240"/>
-            <a:ext cx="4297680" cy="411480"/>
+            <a:off x="8869680" y="2057400"/>
+            <a:ext cx="1207008" cy="777240"/>
           </a:xfrm>
           <a:prstGeom prst="rect">
             <a:avLst/>
@@ -8181,11 +9331,11 @@
           <a:bodyPr wrap="square" lIns="0" tIns="0" rIns="0" bIns="0" rtlCol="0" anchor="t"/>
           <a:lstStyle/>
           <a:p>
-            <a:pPr indent="0" marL="0">
-              <a:buNone/>
-            </a:pPr>
-            <a:r>
-              <a:rPr lang="en-US" sz="1600" b="1" dirty="0">
+            <a:pPr algn="ctr" indent="0" marL="0">
+              <a:buNone/>
+            </a:pPr>
+            <a:r>
+              <a:rPr lang="en-US" sz="1200" dirty="0">
                 <a:solidFill>
                   <a:schemeClr val="tx2"/>
                 </a:solidFill>
@@ -8193,65 +9343,43 @@
                 <a:ea typeface="Calibri" pitchFamily="34" charset="-122"/>
                 <a:cs typeface="Calibri" pitchFamily="34" charset="-120"/>
               </a:rPr>
-              <a:t>Multiplizieren statt abziehen</a:t>
-            </a:r>
-            <a:endParaRPr lang="en-US" sz="1600" dirty="0"/>
-          </a:p>
-        </p:txBody>
-      </p:sp>
-      <p:sp>
-        <p:nvSpPr>
-          <p:cNvPr id="17" name="Text 15"/>
-          <p:cNvSpPr txBox="1"/>
-          <p:nvPr/>
-        </p:nvSpPr>
-        <p:spPr>
-          <a:xfrm>
-            <a:off x="1463040" y="3493008"/>
-            <a:ext cx="4297680" cy="731520"/>
-          </a:xfrm>
-          <a:prstGeom prst="rect">
-            <a:avLst/>
-          </a:prstGeom>
-          <a:noFill/>
-          <a:ln/>
-        </p:spPr>
-        <p:txBody>
-          <a:bodyPr wrap="square" lIns="0" tIns="0" rIns="0" bIns="0" rtlCol="0" anchor="t"/>
-          <a:lstStyle/>
-          <a:p>
-            <a:pPr indent="0" marL="0">
-              <a:buNone/>
-            </a:pPr>
-            <a:r>
-              <a:rPr lang="en-US" sz="1400" dirty="0">
-                <a:solidFill>
-                  <a:schemeClr val="tx1"/>
+              <a:t>Drehen auf</a:t>
+            </a:r>
+            <a:endParaRPr lang="en-US" sz="1200" dirty="0"/>
+          </a:p>
+          <a:p>
+            <a:pPr algn="ctr" indent="0" marL="0">
+              <a:buNone/>
+            </a:pPr>
+            <a:r>
+              <a:rPr lang="en-US" sz="1200" dirty="0">
+                <a:solidFill>
+                  <a:schemeClr val="tx2"/>
                 </a:solidFill>
                 <a:latin typeface="Calibri" pitchFamily="34" charset="0"/>
                 <a:ea typeface="Calibri" pitchFamily="34" charset="-122"/>
                 <a:cs typeface="Calibri" pitchFamily="34" charset="-120"/>
               </a:rPr>
-              <a:t>Strafen verkleinern die Punkte – Stehen darf nie billiger sein als Laufen</a:t>
-            </a:r>
-            <a:endParaRPr lang="en-US" sz="1400" dirty="0"/>
-          </a:p>
-        </p:txBody>
-      </p:sp>
-      <p:sp>
-        <p:nvSpPr>
-          <p:cNvPr id="18" name="learn3"/>
+              <a:t>der Stelle</a:t>
+            </a:r>
+            <a:endParaRPr lang="en-US" sz="1200" dirty="0"/>
+          </a:p>
+        </p:txBody>
+      </p:sp>
+      <p:sp>
+        <p:nvSpPr>
+          <p:cNvPr id="14" name="myr_stat3"/>
           <p:cNvSpPr/>
           <p:nvPr/>
         </p:nvSpPr>
         <p:spPr>
           <a:xfrm>
-            <a:off x="6217920" y="2898648"/>
-            <a:ext cx="5394960" cy="1371600"/>
+            <a:off x="10241280" y="1325880"/>
+            <a:ext cx="1298448" cy="1600200"/>
           </a:xfrm>
           <a:prstGeom prst="roundRect">
             <a:avLst>
-              <a:gd name="adj" fmla="val 5333"/>
+              <a:gd name="adj" fmla="val 5634"/>
             </a:avLst>
           </a:prstGeom>
           <a:solidFill>
@@ -8267,75 +9395,53 @@
       </p:sp>
       <p:sp>
         <p:nvSpPr>
-          <p:cNvPr id="19" name="Shape 17"/>
-          <p:cNvSpPr/>
-          <p:nvPr/>
-        </p:nvSpPr>
-        <p:spPr>
-          <a:xfrm>
-            <a:off x="6446520" y="3310128"/>
-            <a:ext cx="502920" cy="502920"/>
-          </a:xfrm>
-          <a:prstGeom prst="ellipse">
-            <a:avLst/>
-          </a:prstGeom>
-          <a:solidFill>
-            <a:schemeClr val="accent2"/>
-          </a:solidFill>
-          <a:ln w="12700">
-            <a:solidFill>
-              <a:schemeClr val="accent2"/>
-            </a:solidFill>
-            <a:prstDash val="solid"/>
-          </a:ln>
-        </p:spPr>
-      </p:sp>
-      <p:sp>
-        <p:nvSpPr>
-          <p:cNvPr id="20" name="Text 18"/>
+          <p:cNvPr id="15" name="Text 12"/>
           <p:cNvSpPr txBox="1"/>
           <p:nvPr/>
         </p:nvSpPr>
         <p:spPr>
           <a:xfrm>
-            <a:off x="6446520" y="3310128"/>
-            <a:ext cx="502920" cy="502920"/>
-          </a:xfrm>
-          <a:prstGeom prst="rect">
-            <a:avLst/>
-          </a:prstGeom>
-          <a:noFill/>
-          <a:ln/>
-        </p:spPr>
-        <p:txBody>
-          <a:bodyPr wrap="square" lIns="0" tIns="0" rIns="0" bIns="0" rtlCol="0" anchor="ctr"/>
+            <a:off x="10287000" y="1463040"/>
+            <a:ext cx="1207008" cy="502920"/>
+          </a:xfrm>
+          <a:prstGeom prst="rect">
+            <a:avLst/>
+          </a:prstGeom>
+          <a:noFill/>
+          <a:ln/>
+        </p:spPr>
+        <p:txBody>
+          <a:bodyPr wrap="square" lIns="0" tIns="0" rIns="0" bIns="0" rtlCol="0" anchor="t"/>
           <a:lstStyle/>
           <a:p>
             <a:pPr algn="ctr" indent="0" marL="0">
               <a:buNone/>
             </a:pPr>
             <a:r>
-              <a:rPr lang="en-US" sz="1500" b="1" dirty="0">
-                <a:solidFill>
-                  <a:schemeClr val="bg1"/>
-                </a:solidFill>
-              </a:rPr>
-              <a:t>4</a:t>
-            </a:r>
-            <a:endParaRPr lang="en-US" sz="1500" dirty="0"/>
-          </a:p>
-        </p:txBody>
-      </p:sp>
-      <p:sp>
-        <p:nvSpPr>
-          <p:cNvPr id="21" name="Text 19"/>
+              <a:rPr lang="en-US" sz="1900" b="1" dirty="0">
+                <a:solidFill>
+                  <a:schemeClr val="accent1"/>
+                </a:solidFill>
+                <a:latin typeface="Cambria" pitchFamily="34" charset="0"/>
+                <a:ea typeface="Cambria" pitchFamily="34" charset="-122"/>
+                <a:cs typeface="Cambria" pitchFamily="34" charset="-120"/>
+              </a:rPr>
+              <a:t>−0,26 m/s</a:t>
+            </a:r>
+            <a:endParaRPr lang="en-US" sz="1900" dirty="0"/>
+          </a:p>
+        </p:txBody>
+      </p:sp>
+      <p:sp>
+        <p:nvSpPr>
+          <p:cNvPr id="16" name="Text 13"/>
           <p:cNvSpPr txBox="1"/>
           <p:nvPr/>
         </p:nvSpPr>
         <p:spPr>
           <a:xfrm>
-            <a:off x="7132320" y="3063240"/>
-            <a:ext cx="4297680" cy="411480"/>
+            <a:off x="10287000" y="2057400"/>
+            <a:ext cx="1207008" cy="777240"/>
           </a:xfrm>
           <a:prstGeom prst="rect">
             <a:avLst/>
@@ -8347,11 +9453,11 @@
           <a:bodyPr wrap="square" lIns="0" tIns="0" rIns="0" bIns="0" rtlCol="0" anchor="t"/>
           <a:lstStyle/>
           <a:p>
-            <a:pPr indent="0" marL="0">
-              <a:buNone/>
-            </a:pPr>
-            <a:r>
-              <a:rPr lang="en-US" sz="1600" b="1" dirty="0">
+            <a:pPr algn="ctr" indent="0" marL="0">
+              <a:buNone/>
+            </a:pPr>
+            <a:r>
+              <a:rPr lang="en-US" sz="1200" dirty="0">
                 <a:solidFill>
                   <a:schemeClr val="tx2"/>
                 </a:solidFill>
@@ -8359,65 +9465,43 @@
                 <a:ea typeface="Calibri" pitchFamily="34" charset="-122"/>
                 <a:cs typeface="Calibri" pitchFamily="34" charset="-120"/>
               </a:rPr>
-              <a:t>Messen und zuschauen</a:t>
-            </a:r>
-            <a:endParaRPr lang="en-US" sz="1600" dirty="0"/>
-          </a:p>
-        </p:txBody>
-      </p:sp>
-      <p:sp>
-        <p:nvSpPr>
-          <p:cNvPr id="22" name="Text 20"/>
-          <p:cNvSpPr txBox="1"/>
-          <p:nvPr/>
-        </p:nvSpPr>
-        <p:spPr>
-          <a:xfrm>
-            <a:off x="7132320" y="3493008"/>
-            <a:ext cx="4297680" cy="731520"/>
-          </a:xfrm>
-          <a:prstGeom prst="rect">
-            <a:avLst/>
-          </a:prstGeom>
-          <a:noFill/>
-          <a:ln/>
-        </p:spPr>
-        <p:txBody>
-          <a:bodyPr wrap="square" lIns="0" tIns="0" rIns="0" bIns="0" rtlCol="0" anchor="t"/>
-          <a:lstStyle/>
-          <a:p>
-            <a:pPr indent="0" marL="0">
-              <a:buNone/>
-            </a:pPr>
-            <a:r>
-              <a:rPr lang="en-US" sz="1400" dirty="0">
-                <a:solidFill>
-                  <a:schemeClr val="tx1"/>
+              <a:t>rückwärts –</a:t>
+            </a:r>
+            <a:endParaRPr lang="en-US" sz="1200" dirty="0"/>
+          </a:p>
+          <a:p>
+            <a:pPr algn="ctr" indent="0" marL="0">
+              <a:buNone/>
+            </a:pPr>
+            <a:r>
+              <a:rPr lang="en-US" sz="1200" dirty="0">
+                <a:solidFill>
+                  <a:schemeClr val="tx2"/>
                 </a:solidFill>
                 <a:latin typeface="Calibri" pitchFamily="34" charset="0"/>
                 <a:ea typeface="Calibri" pitchFamily="34" charset="-122"/>
                 <a:cs typeface="Calibri" pitchFamily="34" charset="-120"/>
               </a:rPr>
-              <a:t>Zahlen zeigen Trends, live zuschauen zeigt, was wirklich passiert</a:t>
-            </a:r>
-            <a:endParaRPr lang="en-US" sz="1400" dirty="0"/>
-          </a:p>
-        </p:txBody>
-      </p:sp>
-      <p:sp>
-        <p:nvSpPr>
-          <p:cNvPr id="23" name="learn4"/>
+              <a:t>erstmals gelernt</a:t>
+            </a:r>
+            <a:endParaRPr lang="en-US" sz="1200" dirty="0"/>
+          </a:p>
+        </p:txBody>
+      </p:sp>
+      <p:sp>
+        <p:nvSpPr>
+          <p:cNvPr id="17" name="myr_path"/>
           <p:cNvSpPr/>
           <p:nvPr/>
         </p:nvSpPr>
         <p:spPr>
           <a:xfrm>
-            <a:off x="548640" y="4471416"/>
-            <a:ext cx="5394960" cy="1371600"/>
+            <a:off x="5989320" y="3108960"/>
+            <a:ext cx="5623560" cy="2423160"/>
           </a:xfrm>
           <a:prstGeom prst="roundRect">
             <a:avLst>
-              <a:gd name="adj" fmla="val 5333"/>
+              <a:gd name="adj" fmla="val 3019"/>
             </a:avLst>
           </a:prstGeom>
           <a:solidFill>
@@ -8433,75 +9517,14 @@
       </p:sp>
       <p:sp>
         <p:nvSpPr>
-          <p:cNvPr id="24" name="Shape 22"/>
-          <p:cNvSpPr/>
-          <p:nvPr/>
-        </p:nvSpPr>
-        <p:spPr>
-          <a:xfrm>
-            <a:off x="777240" y="4882896"/>
-            <a:ext cx="502920" cy="502920"/>
-          </a:xfrm>
-          <a:prstGeom prst="ellipse">
-            <a:avLst/>
-          </a:prstGeom>
-          <a:solidFill>
-            <a:schemeClr val="accent1"/>
-          </a:solidFill>
-          <a:ln w="12700">
-            <a:solidFill>
-              <a:schemeClr val="accent1"/>
-            </a:solidFill>
-            <a:prstDash val="solid"/>
-          </a:ln>
-        </p:spPr>
-      </p:sp>
-      <p:sp>
-        <p:nvSpPr>
-          <p:cNvPr id="25" name="Text 23"/>
+          <p:cNvPr id="18" name="Text 15"/>
           <p:cNvSpPr txBox="1"/>
           <p:nvPr/>
         </p:nvSpPr>
         <p:spPr>
           <a:xfrm>
-            <a:off x="777240" y="4882896"/>
-            <a:ext cx="502920" cy="502920"/>
-          </a:xfrm>
-          <a:prstGeom prst="rect">
-            <a:avLst/>
-          </a:prstGeom>
-          <a:noFill/>
-          <a:ln/>
-        </p:spPr>
-        <p:txBody>
-          <a:bodyPr wrap="square" lIns="0" tIns="0" rIns="0" bIns="0" rtlCol="0" anchor="ctr"/>
-          <a:lstStyle/>
-          <a:p>
-            <a:pPr algn="ctr" indent="0" marL="0">
-              <a:buNone/>
-            </a:pPr>
-            <a:r>
-              <a:rPr lang="en-US" sz="1500" b="1" dirty="0">
-                <a:solidFill>
-                  <a:schemeClr val="bg1"/>
-                </a:solidFill>
-              </a:rPr>
-              <a:t>5</a:t>
-            </a:r>
-            <a:endParaRPr lang="en-US" sz="1500" dirty="0"/>
-          </a:p>
-        </p:txBody>
-      </p:sp>
-      <p:sp>
-        <p:nvSpPr>
-          <p:cNvPr id="26" name="Text 24"/>
-          <p:cNvSpPr txBox="1"/>
-          <p:nvPr/>
-        </p:nvSpPr>
-        <p:spPr>
-          <a:xfrm>
-            <a:off x="1463040" y="4636008"/>
-            <a:ext cx="4297680" cy="411480"/>
+            <a:off x="6217920" y="3246120"/>
+            <a:ext cx="5212080" cy="365760"/>
           </a:xfrm>
           <a:prstGeom prst="rect">
             <a:avLst/>
@@ -8517,7 +9540,7 @@
               <a:buNone/>
             </a:pPr>
             <a:r>
-              <a:rPr lang="en-US" sz="1600" b="1" dirty="0">
+              <a:rPr lang="en-US" sz="1700" b="1" dirty="0">
                 <a:solidFill>
                   <a:schemeClr val="tx2"/>
                 </a:solidFill>
@@ -8525,22 +9548,22 @@
                 <a:ea typeface="Calibri" pitchFamily="34" charset="-122"/>
                 <a:cs typeface="Calibri" pitchFamily="34" charset="-120"/>
               </a:rPr>
-              <a:t>Kleine Schritte</a:t>
-            </a:r>
-            <a:endParaRPr lang="en-US" sz="1600" dirty="0"/>
-          </a:p>
-        </p:txBody>
-      </p:sp>
-      <p:sp>
-        <p:nvSpPr>
-          <p:cNvPr id="27" name="Text 25"/>
+              <a:t>Der Weg zum Insekten-Gang</a:t>
+            </a:r>
+            <a:endParaRPr lang="en-US" sz="1700" dirty="0"/>
+          </a:p>
+        </p:txBody>
+      </p:sp>
+      <p:sp>
+        <p:nvSpPr>
+          <p:cNvPr id="19" name="Text 16"/>
           <p:cNvSpPr txBox="1"/>
           <p:nvPr/>
         </p:nvSpPr>
         <p:spPr>
           <a:xfrm>
-            <a:off x="1463040" y="5065776"/>
-            <a:ext cx="4297680" cy="731520"/>
+            <a:off x="6217920" y="3703320"/>
+            <a:ext cx="5257800" cy="1783080"/>
           </a:xfrm>
           <a:prstGeom prst="rect">
             <a:avLst/>
@@ -8552,187 +9575,133 @@
           <a:bodyPr wrap="square" lIns="0" tIns="0" rIns="0" bIns="0" rtlCol="0" anchor="t"/>
           <a:lstStyle/>
           <a:p>
+            <a:pPr marL="342900" indent="-342900">
+              <a:spcAft>
+                <a:spcPts val="600"/>
+              </a:spcAft>
+              <a:buSzPct val="100000"/>
+              <a:buChar char="•"/>
+            </a:pPr>
+            <a:r>
+              <a:rPr lang="en-US" sz="1400" dirty="0">
+                <a:solidFill>
+                  <a:srgbClr val="000000"/>
+                </a:solidFill>
+              </a:rPr>
+              <a:t>v1: läuft, aber nur mit den Mittelbeinen</a:t>
+            </a:r>
+            <a:endParaRPr lang="en-US" sz="1400" dirty="0"/>
+          </a:p>
+          <a:p>
+            <a:pPr marL="342900" indent="-342900">
+              <a:spcAft>
+                <a:spcPts val="600"/>
+              </a:spcAft>
+              <a:buSzPct val="100000"/>
+              <a:buChar char="•"/>
+            </a:pPr>
+            <a:r>
+              <a:rPr lang="en-US" sz="1400" dirty="0">
+                <a:solidFill>
+                  <a:srgbClr val="000000"/>
+                </a:solidFill>
+              </a:rPr>
+              <a:t>v2: Dreifuß-Takt (3 Beine am Boden), 5× weniger Energie</a:t>
+            </a:r>
+            <a:endParaRPr lang="en-US" sz="1400" dirty="0"/>
+          </a:p>
+          <a:p>
+            <a:pPr marL="342900" indent="-342900">
+              <a:spcAft>
+                <a:spcPts val="600"/>
+              </a:spcAft>
+              <a:buSzPct val="100000"/>
+              <a:buChar char="•"/>
+            </a:pPr>
+            <a:r>
+              <a:rPr lang="en-US" sz="1400" dirty="0">
+                <a:solidFill>
+                  <a:srgbClr val="000000"/>
+                </a:solidFill>
+              </a:rPr>
+              <a:t>v5: Knie endlich frei (waren seit v2 blockiert)</a:t>
+            </a:r>
+            <a:endParaRPr lang="en-US" sz="1400" dirty="0"/>
+          </a:p>
+          <a:p>
+            <a:pPr marL="342900" indent="-342900">
+              <a:spcAft>
+                <a:spcPts val="600"/>
+              </a:spcAft>
+              <a:buSzPct val="100000"/>
+              <a:buChar char="•"/>
+            </a:pPr>
+            <a:r>
+              <a:rPr lang="en-US" sz="1400" dirty="0">
+                <a:solidFill>
+                  <a:srgbClr val="000000"/>
+                </a:solidFill>
+              </a:rPr>
+              <a:t>v9: „Schubkarre“ – der Hinterleib war 54 % des Gewichts</a:t>
+            </a:r>
+            <a:endParaRPr lang="en-US" sz="1400" dirty="0"/>
+          </a:p>
+          <a:p>
+            <a:pPr marL="342900" indent="-342900">
+              <a:spcAft>
+                <a:spcPts val="600"/>
+              </a:spcAft>
+              <a:buSzPct val="100000"/>
+              <a:buChar char="•"/>
+            </a:pPr>
+            <a:r>
+              <a:rPr lang="en-US" sz="1400" dirty="0">
+                <a:solidFill>
+                  <a:srgbClr val="000000"/>
+                </a:solidFill>
+              </a:rPr>
+              <a:t>v10: Hinterleib leichter (23 %) + Dreifuß-Schrittgeber → final</a:t>
+            </a:r>
+            <a:endParaRPr lang="en-US" sz="1400" dirty="0"/>
+          </a:p>
+        </p:txBody>
+      </p:sp>
+      <p:sp>
+        <p:nvSpPr>
+          <p:cNvPr id="20" name="Text 17"/>
+          <p:cNvSpPr txBox="1"/>
+          <p:nvPr/>
+        </p:nvSpPr>
+        <p:spPr>
+          <a:xfrm>
+            <a:off x="548640" y="5806440"/>
+            <a:ext cx="11064240" cy="365760"/>
+          </a:xfrm>
+          <a:prstGeom prst="rect">
+            <a:avLst/>
+          </a:prstGeom>
+          <a:noFill/>
+          <a:ln/>
+        </p:spPr>
+        <p:txBody>
+          <a:bodyPr wrap="square" lIns="0" tIns="0" rIns="0" bIns="0" rtlCol="0" anchor="t"/>
+          <a:lstStyle/>
+          <a:p>
             <a:pPr indent="0" marL="0">
               <a:buNone/>
             </a:pPr>
             <a:r>
-              <a:rPr lang="en-US" sz="1400" dirty="0">
-                <a:solidFill>
-                  <a:schemeClr val="tx1"/>
+              <a:rPr lang="en-US" sz="1300" i="1" dirty="0">
+                <a:solidFill>
+                  <a:schemeClr val="accent3"/>
                 </a:solidFill>
                 <a:latin typeface="Calibri" pitchFamily="34" charset="0"/>
                 <a:ea typeface="Calibri" pitchFamily="34" charset="-122"/>
                 <a:cs typeface="Calibri" pitchFamily="34" charset="-120"/>
               </a:rPr>
-              <a:t>Eine Änderung pro Training; jeden Checkpoint behalten</a:t>
-            </a:r>
-            <a:endParaRPr lang="en-US" sz="1400" dirty="0"/>
-          </a:p>
-        </p:txBody>
-      </p:sp>
-      <p:sp>
-        <p:nvSpPr>
-          <p:cNvPr id="28" name="learn5"/>
-          <p:cNvSpPr/>
-          <p:nvPr/>
-        </p:nvSpPr>
-        <p:spPr>
-          <a:xfrm>
-            <a:off x="6217920" y="4471416"/>
-            <a:ext cx="5394960" cy="1371600"/>
-          </a:xfrm>
-          <a:prstGeom prst="roundRect">
-            <a:avLst>
-              <a:gd name="adj" fmla="val 5333"/>
-            </a:avLst>
-          </a:prstGeom>
-          <a:solidFill>
-            <a:schemeClr val="bg2"/>
-          </a:solidFill>
-          <a:ln w="12700">
-            <a:solidFill>
-              <a:schemeClr val="bg2"/>
-            </a:solidFill>
-            <a:prstDash val="solid"/>
-          </a:ln>
-        </p:spPr>
-      </p:sp>
-      <p:sp>
-        <p:nvSpPr>
-          <p:cNvPr id="29" name="Shape 27"/>
-          <p:cNvSpPr/>
-          <p:nvPr/>
-        </p:nvSpPr>
-        <p:spPr>
-          <a:xfrm>
-            <a:off x="6446520" y="4882896"/>
-            <a:ext cx="502920" cy="502920"/>
-          </a:xfrm>
-          <a:prstGeom prst="ellipse">
-            <a:avLst/>
-          </a:prstGeom>
-          <a:solidFill>
-            <a:schemeClr val="accent2"/>
-          </a:solidFill>
-          <a:ln w="12700">
-            <a:solidFill>
-              <a:schemeClr val="accent2"/>
-            </a:solidFill>
-            <a:prstDash val="solid"/>
-          </a:ln>
-        </p:spPr>
-      </p:sp>
-      <p:sp>
-        <p:nvSpPr>
-          <p:cNvPr id="30" name="Text 28"/>
-          <p:cNvSpPr txBox="1"/>
-          <p:nvPr/>
-        </p:nvSpPr>
-        <p:spPr>
-          <a:xfrm>
-            <a:off x="6446520" y="4882896"/>
-            <a:ext cx="502920" cy="502920"/>
-          </a:xfrm>
-          <a:prstGeom prst="rect">
-            <a:avLst/>
-          </a:prstGeom>
-          <a:noFill/>
-          <a:ln/>
-        </p:spPr>
-        <p:txBody>
-          <a:bodyPr wrap="square" lIns="0" tIns="0" rIns="0" bIns="0" rtlCol="0" anchor="ctr"/>
-          <a:lstStyle/>
-          <a:p>
-            <a:pPr algn="ctr" indent="0" marL="0">
-              <a:buNone/>
-            </a:pPr>
-            <a:r>
-              <a:rPr lang="en-US" sz="1500" b="1" dirty="0">
-                <a:solidFill>
-                  <a:schemeClr val="bg1"/>
-                </a:solidFill>
-              </a:rPr>
-              <a:t>6</a:t>
-            </a:r>
-            <a:endParaRPr lang="en-US" sz="1500" dirty="0"/>
-          </a:p>
-        </p:txBody>
-      </p:sp>
-      <p:sp>
-        <p:nvSpPr>
-          <p:cNvPr id="31" name="Text 29"/>
-          <p:cNvSpPr txBox="1"/>
-          <p:nvPr/>
-        </p:nvSpPr>
-        <p:spPr>
-          <a:xfrm>
-            <a:off x="7132320" y="4636008"/>
-            <a:ext cx="4297680" cy="411480"/>
-          </a:xfrm>
-          <a:prstGeom prst="rect">
-            <a:avLst/>
-          </a:prstGeom>
-          <a:noFill/>
-          <a:ln/>
-        </p:spPr>
-        <p:txBody>
-          <a:bodyPr wrap="square" lIns="0" tIns="0" rIns="0" bIns="0" rtlCol="0" anchor="t"/>
-          <a:lstStyle/>
-          <a:p>
-            <a:pPr indent="0" marL="0">
-              <a:buNone/>
-            </a:pPr>
-            <a:r>
-              <a:rPr lang="en-US" sz="1600" b="1" dirty="0">
-                <a:solidFill>
-                  <a:schemeClr val="tx2"/>
-                </a:solidFill>
-                <a:latin typeface="Calibri" pitchFamily="34" charset="0"/>
-                <a:ea typeface="Calibri" pitchFamily="34" charset="-122"/>
-                <a:cs typeface="Calibri" pitchFamily="34" charset="-120"/>
-              </a:rPr>
-              <a:t>Regeln gezielt einsetzen</a:t>
-            </a:r>
-            <a:endParaRPr lang="en-US" sz="1600" dirty="0"/>
-          </a:p>
-        </p:txBody>
-      </p:sp>
-      <p:sp>
-        <p:nvSpPr>
-          <p:cNvPr id="32" name="Text 30"/>
-          <p:cNvSpPr txBox="1"/>
-          <p:nvPr/>
-        </p:nvSpPr>
-        <p:spPr>
-          <a:xfrm>
-            <a:off x="7132320" y="5065776"/>
-            <a:ext cx="4297680" cy="731520"/>
-          </a:xfrm>
-          <a:prstGeom prst="rect">
-            <a:avLst/>
-          </a:prstGeom>
-          <a:noFill/>
-          <a:ln/>
-        </p:spPr>
-        <p:txBody>
-          <a:bodyPr wrap="square" lIns="0" tIns="0" rIns="0" bIns="0" rtlCol="0" anchor="t"/>
-          <a:lstStyle/>
-          <a:p>
-            <a:pPr indent="0" marL="0">
-              <a:buNone/>
-            </a:pPr>
-            <a:r>
-              <a:rPr lang="en-US" sz="1400" dirty="0">
-                <a:solidFill>
-                  <a:schemeClr val="tx1"/>
-                </a:solidFill>
-                <a:latin typeface="Calibri" pitchFamily="34" charset="0"/>
-                <a:ea typeface="Calibri" pitchFamily="34" charset="-122"/>
-                <a:cs typeface="Calibri" pitchFamily="34" charset="-120"/>
-              </a:rPr>
-              <a:t>Eine Geh-Regel im Sprint hat das Sprinten verhindert</a:t>
-            </a:r>
-            <a:endParaRPr lang="en-US" sz="1400" dirty="0"/>
+              <a:t>Dreifuß-Takt 87 % der Zeit · Knie 60° · Hinterleib nie am Boden · keine Stürze · offen: Vorderbeine nur 21 % am Boden</a:t>
+            </a:r>
+            <a:endParaRPr lang="en-US" sz="1300" dirty="0"/>
           </a:p>
         </p:txBody>
       </p:sp>
@@ -8841,6 +9810,1113 @@
                 <a:ea typeface="Cambria" pitchFamily="34" charset="-122"/>
                 <a:cs typeface="Cambria" pitchFamily="34" charset="-120"/>
               </a:rPr>
+              <a:t>Was habe ich gelernt?</a:t>
+            </a:r>
+            <a:endParaRPr lang="en-US" sz="3200" dirty="0"/>
+          </a:p>
+        </p:txBody>
+      </p:sp>
+      <p:sp>
+        <p:nvSpPr>
+          <p:cNvPr id="3" name="learn0"/>
+          <p:cNvSpPr/>
+          <p:nvPr/>
+        </p:nvSpPr>
+        <p:spPr>
+          <a:xfrm>
+            <a:off x="548640" y="1325880"/>
+            <a:ext cx="5394960" cy="1371600"/>
+          </a:xfrm>
+          <a:prstGeom prst="roundRect">
+            <a:avLst>
+              <a:gd name="adj" fmla="val 5333"/>
+            </a:avLst>
+          </a:prstGeom>
+          <a:solidFill>
+            <a:schemeClr val="bg2"/>
+          </a:solidFill>
+          <a:ln w="12700">
+            <a:solidFill>
+              <a:schemeClr val="bg2"/>
+            </a:solidFill>
+            <a:prstDash val="solid"/>
+          </a:ln>
+        </p:spPr>
+      </p:sp>
+      <p:sp>
+        <p:nvSpPr>
+          <p:cNvPr id="4" name="Shape 2"/>
+          <p:cNvSpPr/>
+          <p:nvPr/>
+        </p:nvSpPr>
+        <p:spPr>
+          <a:xfrm>
+            <a:off x="777240" y="1737360"/>
+            <a:ext cx="502920" cy="502920"/>
+          </a:xfrm>
+          <a:prstGeom prst="ellipse">
+            <a:avLst/>
+          </a:prstGeom>
+          <a:solidFill>
+            <a:schemeClr val="accent1"/>
+          </a:solidFill>
+          <a:ln w="12700">
+            <a:solidFill>
+              <a:schemeClr val="accent1"/>
+            </a:solidFill>
+            <a:prstDash val="solid"/>
+          </a:ln>
+        </p:spPr>
+      </p:sp>
+      <p:sp>
+        <p:nvSpPr>
+          <p:cNvPr id="5" name="Text 3"/>
+          <p:cNvSpPr txBox="1"/>
+          <p:nvPr/>
+        </p:nvSpPr>
+        <p:spPr>
+          <a:xfrm>
+            <a:off x="777240" y="1737360"/>
+            <a:ext cx="502920" cy="502920"/>
+          </a:xfrm>
+          <a:prstGeom prst="rect">
+            <a:avLst/>
+          </a:prstGeom>
+          <a:noFill/>
+          <a:ln/>
+        </p:spPr>
+        <p:txBody>
+          <a:bodyPr wrap="square" lIns="0" tIns="0" rIns="0" bIns="0" rtlCol="0" anchor="ctr"/>
+          <a:lstStyle/>
+          <a:p>
+            <a:pPr algn="ctr" indent="0" marL="0">
+              <a:buNone/>
+            </a:pPr>
+            <a:r>
+              <a:rPr lang="en-US" sz="1500" b="1" dirty="0">
+                <a:solidFill>
+                  <a:schemeClr val="bg1"/>
+                </a:solidFill>
+              </a:rPr>
+              <a:t>1</a:t>
+            </a:r>
+            <a:endParaRPr lang="en-US" sz="1500" dirty="0"/>
+          </a:p>
+        </p:txBody>
+      </p:sp>
+      <p:sp>
+        <p:nvSpPr>
+          <p:cNvPr id="6" name="Text 4"/>
+          <p:cNvSpPr txBox="1"/>
+          <p:nvPr/>
+        </p:nvSpPr>
+        <p:spPr>
+          <a:xfrm>
+            <a:off x="1463040" y="1490472"/>
+            <a:ext cx="4297680" cy="411480"/>
+          </a:xfrm>
+          <a:prstGeom prst="rect">
+            <a:avLst/>
+          </a:prstGeom>
+          <a:noFill/>
+          <a:ln/>
+        </p:spPr>
+        <p:txBody>
+          <a:bodyPr wrap="square" lIns="0" tIns="0" rIns="0" bIns="0" rtlCol="0" anchor="t"/>
+          <a:lstStyle/>
+          <a:p>
+            <a:pPr indent="0" marL="0">
+              <a:buNone/>
+            </a:pPr>
+            <a:r>
+              <a:rPr lang="en-US" sz="1600" b="1" dirty="0">
+                <a:solidFill>
+                  <a:schemeClr val="tx2"/>
+                </a:solidFill>
+                <a:latin typeface="Calibri" pitchFamily="34" charset="0"/>
+                <a:ea typeface="Calibri" pitchFamily="34" charset="-122"/>
+                <a:cs typeface="Calibri" pitchFamily="34" charset="-120"/>
+              </a:rPr>
+              <a:t>Belohnung ist alles</a:t>
+            </a:r>
+            <a:endParaRPr lang="en-US" sz="1600" dirty="0"/>
+          </a:p>
+        </p:txBody>
+      </p:sp>
+      <p:sp>
+        <p:nvSpPr>
+          <p:cNvPr id="7" name="Text 5"/>
+          <p:cNvSpPr txBox="1"/>
+          <p:nvPr/>
+        </p:nvSpPr>
+        <p:spPr>
+          <a:xfrm>
+            <a:off x="1463040" y="1920240"/>
+            <a:ext cx="4297680" cy="731520"/>
+          </a:xfrm>
+          <a:prstGeom prst="rect">
+            <a:avLst/>
+          </a:prstGeom>
+          <a:noFill/>
+          <a:ln/>
+        </p:spPr>
+        <p:txBody>
+          <a:bodyPr wrap="square" lIns="0" tIns="0" rIns="0" bIns="0" rtlCol="0" anchor="t"/>
+          <a:lstStyle/>
+          <a:p>
+            <a:pPr indent="0" marL="0">
+              <a:buNone/>
+            </a:pPr>
+            <a:r>
+              <a:rPr lang="en-US" sz="1400" dirty="0">
+                <a:solidFill>
+                  <a:schemeClr val="tx1"/>
+                </a:solidFill>
+                <a:latin typeface="Calibri" pitchFamily="34" charset="0"/>
+                <a:ea typeface="Calibri" pitchFamily="34" charset="-122"/>
+                <a:cs typeface="Calibri" pitchFamily="34" charset="-120"/>
+              </a:rPr>
+              <a:t>Das Gehirn findet jedes Schlupfloch: Stillstehen, Handstand, „Planke“ – wenn es Punkte bringt</a:t>
+            </a:r>
+            <a:endParaRPr lang="en-US" sz="1400" dirty="0"/>
+          </a:p>
+        </p:txBody>
+      </p:sp>
+      <p:sp>
+        <p:nvSpPr>
+          <p:cNvPr id="8" name="learn1"/>
+          <p:cNvSpPr/>
+          <p:nvPr/>
+        </p:nvSpPr>
+        <p:spPr>
+          <a:xfrm>
+            <a:off x="6217920" y="1325880"/>
+            <a:ext cx="5394960" cy="1371600"/>
+          </a:xfrm>
+          <a:prstGeom prst="roundRect">
+            <a:avLst>
+              <a:gd name="adj" fmla="val 5333"/>
+            </a:avLst>
+          </a:prstGeom>
+          <a:solidFill>
+            <a:schemeClr val="bg2"/>
+          </a:solidFill>
+          <a:ln w="12700">
+            <a:solidFill>
+              <a:schemeClr val="bg2"/>
+            </a:solidFill>
+            <a:prstDash val="solid"/>
+          </a:ln>
+        </p:spPr>
+      </p:sp>
+      <p:sp>
+        <p:nvSpPr>
+          <p:cNvPr id="9" name="Shape 7"/>
+          <p:cNvSpPr/>
+          <p:nvPr/>
+        </p:nvSpPr>
+        <p:spPr>
+          <a:xfrm>
+            <a:off x="6446520" y="1737360"/>
+            <a:ext cx="502920" cy="502920"/>
+          </a:xfrm>
+          <a:prstGeom prst="ellipse">
+            <a:avLst/>
+          </a:prstGeom>
+          <a:solidFill>
+            <a:schemeClr val="accent2"/>
+          </a:solidFill>
+          <a:ln w="12700">
+            <a:solidFill>
+              <a:schemeClr val="accent2"/>
+            </a:solidFill>
+            <a:prstDash val="solid"/>
+          </a:ln>
+        </p:spPr>
+      </p:sp>
+      <p:sp>
+        <p:nvSpPr>
+          <p:cNvPr id="10" name="Text 8"/>
+          <p:cNvSpPr txBox="1"/>
+          <p:nvPr/>
+        </p:nvSpPr>
+        <p:spPr>
+          <a:xfrm>
+            <a:off x="6446520" y="1737360"/>
+            <a:ext cx="502920" cy="502920"/>
+          </a:xfrm>
+          <a:prstGeom prst="rect">
+            <a:avLst/>
+          </a:prstGeom>
+          <a:noFill/>
+          <a:ln/>
+        </p:spPr>
+        <p:txBody>
+          <a:bodyPr wrap="square" lIns="0" tIns="0" rIns="0" bIns="0" rtlCol="0" anchor="ctr"/>
+          <a:lstStyle/>
+          <a:p>
+            <a:pPr algn="ctr" indent="0" marL="0">
+              <a:buNone/>
+            </a:pPr>
+            <a:r>
+              <a:rPr lang="en-US" sz="1500" b="1" dirty="0">
+                <a:solidFill>
+                  <a:schemeClr val="bg1"/>
+                </a:solidFill>
+              </a:rPr>
+              <a:t>2</a:t>
+            </a:r>
+            <a:endParaRPr lang="en-US" sz="1500" dirty="0"/>
+          </a:p>
+        </p:txBody>
+      </p:sp>
+      <p:sp>
+        <p:nvSpPr>
+          <p:cNvPr id="11" name="Text 9"/>
+          <p:cNvSpPr txBox="1"/>
+          <p:nvPr/>
+        </p:nvSpPr>
+        <p:spPr>
+          <a:xfrm>
+            <a:off x="7132320" y="1490472"/>
+            <a:ext cx="4297680" cy="411480"/>
+          </a:xfrm>
+          <a:prstGeom prst="rect">
+            <a:avLst/>
+          </a:prstGeom>
+          <a:noFill/>
+          <a:ln/>
+        </p:spPr>
+        <p:txBody>
+          <a:bodyPr wrap="square" lIns="0" tIns="0" rIns="0" bIns="0" rtlCol="0" anchor="t"/>
+          <a:lstStyle/>
+          <a:p>
+            <a:pPr indent="0" marL="0">
+              <a:buNone/>
+            </a:pPr>
+            <a:r>
+              <a:rPr lang="en-US" sz="1600" b="1" dirty="0">
+                <a:solidFill>
+                  <a:schemeClr val="tx2"/>
+                </a:solidFill>
+                <a:latin typeface="Calibri" pitchFamily="34" charset="0"/>
+                <a:ea typeface="Calibri" pitchFamily="34" charset="-122"/>
+                <a:cs typeface="Calibri" pitchFamily="34" charset="-120"/>
+              </a:rPr>
+              <a:t>Erst der Körper, dann das Lernen</a:t>
+            </a:r>
+            <a:endParaRPr lang="en-US" sz="1600" dirty="0"/>
+          </a:p>
+        </p:txBody>
+      </p:sp>
+      <p:sp>
+        <p:nvSpPr>
+          <p:cNvPr id="12" name="Text 10"/>
+          <p:cNvSpPr txBox="1"/>
+          <p:nvPr/>
+        </p:nvSpPr>
+        <p:spPr>
+          <a:xfrm>
+            <a:off x="7132320" y="1920240"/>
+            <a:ext cx="4297680" cy="731520"/>
+          </a:xfrm>
+          <a:prstGeom prst="rect">
+            <a:avLst/>
+          </a:prstGeom>
+          <a:noFill/>
+          <a:ln/>
+        </p:spPr>
+        <p:txBody>
+          <a:bodyPr wrap="square" lIns="0" tIns="0" rIns="0" bIns="0" rtlCol="0" anchor="t"/>
+          <a:lstStyle/>
+          <a:p>
+            <a:pPr indent="0" marL="0">
+              <a:buNone/>
+            </a:pPr>
+            <a:r>
+              <a:rPr lang="en-US" sz="1400" dirty="0">
+                <a:solidFill>
+                  <a:schemeClr val="tx1"/>
+                </a:solidFill>
+                <a:latin typeface="Calibri" pitchFamily="34" charset="0"/>
+                <a:ea typeface="Calibri" pitchFamily="34" charset="-122"/>
+                <a:cs typeface="Calibri" pitchFamily="34" charset="-120"/>
+              </a:rPr>
+              <a:t>Falsche Masse, Geometrie oder Gelenke kann keine Regel ausgleichen</a:t>
+            </a:r>
+            <a:endParaRPr lang="en-US" sz="1400" dirty="0"/>
+          </a:p>
+        </p:txBody>
+      </p:sp>
+      <p:sp>
+        <p:nvSpPr>
+          <p:cNvPr id="13" name="learn2"/>
+          <p:cNvSpPr/>
+          <p:nvPr/>
+        </p:nvSpPr>
+        <p:spPr>
+          <a:xfrm>
+            <a:off x="548640" y="2898648"/>
+            <a:ext cx="5394960" cy="1371600"/>
+          </a:xfrm>
+          <a:prstGeom prst="roundRect">
+            <a:avLst>
+              <a:gd name="adj" fmla="val 5333"/>
+            </a:avLst>
+          </a:prstGeom>
+          <a:solidFill>
+            <a:schemeClr val="bg2"/>
+          </a:solidFill>
+          <a:ln w="12700">
+            <a:solidFill>
+              <a:schemeClr val="bg2"/>
+            </a:solidFill>
+            <a:prstDash val="solid"/>
+          </a:ln>
+        </p:spPr>
+      </p:sp>
+      <p:sp>
+        <p:nvSpPr>
+          <p:cNvPr id="14" name="Shape 12"/>
+          <p:cNvSpPr/>
+          <p:nvPr/>
+        </p:nvSpPr>
+        <p:spPr>
+          <a:xfrm>
+            <a:off x="777240" y="3310128"/>
+            <a:ext cx="502920" cy="502920"/>
+          </a:xfrm>
+          <a:prstGeom prst="ellipse">
+            <a:avLst/>
+          </a:prstGeom>
+          <a:solidFill>
+            <a:schemeClr val="accent1"/>
+          </a:solidFill>
+          <a:ln w="12700">
+            <a:solidFill>
+              <a:schemeClr val="accent1"/>
+            </a:solidFill>
+            <a:prstDash val="solid"/>
+          </a:ln>
+        </p:spPr>
+      </p:sp>
+      <p:sp>
+        <p:nvSpPr>
+          <p:cNvPr id="15" name="Text 13"/>
+          <p:cNvSpPr txBox="1"/>
+          <p:nvPr/>
+        </p:nvSpPr>
+        <p:spPr>
+          <a:xfrm>
+            <a:off x="777240" y="3310128"/>
+            <a:ext cx="502920" cy="502920"/>
+          </a:xfrm>
+          <a:prstGeom prst="rect">
+            <a:avLst/>
+          </a:prstGeom>
+          <a:noFill/>
+          <a:ln/>
+        </p:spPr>
+        <p:txBody>
+          <a:bodyPr wrap="square" lIns="0" tIns="0" rIns="0" bIns="0" rtlCol="0" anchor="ctr"/>
+          <a:lstStyle/>
+          <a:p>
+            <a:pPr algn="ctr" indent="0" marL="0">
+              <a:buNone/>
+            </a:pPr>
+            <a:r>
+              <a:rPr lang="en-US" sz="1500" b="1" dirty="0">
+                <a:solidFill>
+                  <a:schemeClr val="bg1"/>
+                </a:solidFill>
+              </a:rPr>
+              <a:t>3</a:t>
+            </a:r>
+            <a:endParaRPr lang="en-US" sz="1500" dirty="0"/>
+          </a:p>
+        </p:txBody>
+      </p:sp>
+      <p:sp>
+        <p:nvSpPr>
+          <p:cNvPr id="16" name="Text 14"/>
+          <p:cNvSpPr txBox="1"/>
+          <p:nvPr/>
+        </p:nvSpPr>
+        <p:spPr>
+          <a:xfrm>
+            <a:off x="1463040" y="3063240"/>
+            <a:ext cx="4297680" cy="411480"/>
+          </a:xfrm>
+          <a:prstGeom prst="rect">
+            <a:avLst/>
+          </a:prstGeom>
+          <a:noFill/>
+          <a:ln/>
+        </p:spPr>
+        <p:txBody>
+          <a:bodyPr wrap="square" lIns="0" tIns="0" rIns="0" bIns="0" rtlCol="0" anchor="t"/>
+          <a:lstStyle/>
+          <a:p>
+            <a:pPr indent="0" marL="0">
+              <a:buNone/>
+            </a:pPr>
+            <a:r>
+              <a:rPr lang="en-US" sz="1600" b="1" dirty="0">
+                <a:solidFill>
+                  <a:schemeClr val="tx2"/>
+                </a:solidFill>
+                <a:latin typeface="Calibri" pitchFamily="34" charset="0"/>
+                <a:ea typeface="Calibri" pitchFamily="34" charset="-122"/>
+                <a:cs typeface="Calibri" pitchFamily="34" charset="-120"/>
+              </a:rPr>
+              <a:t>Multiplizieren statt abziehen</a:t>
+            </a:r>
+            <a:endParaRPr lang="en-US" sz="1600" dirty="0"/>
+          </a:p>
+        </p:txBody>
+      </p:sp>
+      <p:sp>
+        <p:nvSpPr>
+          <p:cNvPr id="17" name="Text 15"/>
+          <p:cNvSpPr txBox="1"/>
+          <p:nvPr/>
+        </p:nvSpPr>
+        <p:spPr>
+          <a:xfrm>
+            <a:off x="1463040" y="3493008"/>
+            <a:ext cx="4297680" cy="731520"/>
+          </a:xfrm>
+          <a:prstGeom prst="rect">
+            <a:avLst/>
+          </a:prstGeom>
+          <a:noFill/>
+          <a:ln/>
+        </p:spPr>
+        <p:txBody>
+          <a:bodyPr wrap="square" lIns="0" tIns="0" rIns="0" bIns="0" rtlCol="0" anchor="t"/>
+          <a:lstStyle/>
+          <a:p>
+            <a:pPr indent="0" marL="0">
+              <a:buNone/>
+            </a:pPr>
+            <a:r>
+              <a:rPr lang="en-US" sz="1400" dirty="0">
+                <a:solidFill>
+                  <a:schemeClr val="tx1"/>
+                </a:solidFill>
+                <a:latin typeface="Calibri" pitchFamily="34" charset="0"/>
+                <a:ea typeface="Calibri" pitchFamily="34" charset="-122"/>
+                <a:cs typeface="Calibri" pitchFamily="34" charset="-120"/>
+              </a:rPr>
+              <a:t>Strafen verkleinern die Punkte – Stehen darf nie billiger sein als Laufen</a:t>
+            </a:r>
+            <a:endParaRPr lang="en-US" sz="1400" dirty="0"/>
+          </a:p>
+        </p:txBody>
+      </p:sp>
+      <p:sp>
+        <p:nvSpPr>
+          <p:cNvPr id="18" name="learn3"/>
+          <p:cNvSpPr/>
+          <p:nvPr/>
+        </p:nvSpPr>
+        <p:spPr>
+          <a:xfrm>
+            <a:off x="6217920" y="2898648"/>
+            <a:ext cx="5394960" cy="1371600"/>
+          </a:xfrm>
+          <a:prstGeom prst="roundRect">
+            <a:avLst>
+              <a:gd name="adj" fmla="val 5333"/>
+            </a:avLst>
+          </a:prstGeom>
+          <a:solidFill>
+            <a:schemeClr val="bg2"/>
+          </a:solidFill>
+          <a:ln w="12700">
+            <a:solidFill>
+              <a:schemeClr val="bg2"/>
+            </a:solidFill>
+            <a:prstDash val="solid"/>
+          </a:ln>
+        </p:spPr>
+      </p:sp>
+      <p:sp>
+        <p:nvSpPr>
+          <p:cNvPr id="19" name="Shape 17"/>
+          <p:cNvSpPr/>
+          <p:nvPr/>
+        </p:nvSpPr>
+        <p:spPr>
+          <a:xfrm>
+            <a:off x="6446520" y="3310128"/>
+            <a:ext cx="502920" cy="502920"/>
+          </a:xfrm>
+          <a:prstGeom prst="ellipse">
+            <a:avLst/>
+          </a:prstGeom>
+          <a:solidFill>
+            <a:schemeClr val="accent2"/>
+          </a:solidFill>
+          <a:ln w="12700">
+            <a:solidFill>
+              <a:schemeClr val="accent2"/>
+            </a:solidFill>
+            <a:prstDash val="solid"/>
+          </a:ln>
+        </p:spPr>
+      </p:sp>
+      <p:sp>
+        <p:nvSpPr>
+          <p:cNvPr id="20" name="Text 18"/>
+          <p:cNvSpPr txBox="1"/>
+          <p:nvPr/>
+        </p:nvSpPr>
+        <p:spPr>
+          <a:xfrm>
+            <a:off x="6446520" y="3310128"/>
+            <a:ext cx="502920" cy="502920"/>
+          </a:xfrm>
+          <a:prstGeom prst="rect">
+            <a:avLst/>
+          </a:prstGeom>
+          <a:noFill/>
+          <a:ln/>
+        </p:spPr>
+        <p:txBody>
+          <a:bodyPr wrap="square" lIns="0" tIns="0" rIns="0" bIns="0" rtlCol="0" anchor="ctr"/>
+          <a:lstStyle/>
+          <a:p>
+            <a:pPr algn="ctr" indent="0" marL="0">
+              <a:buNone/>
+            </a:pPr>
+            <a:r>
+              <a:rPr lang="en-US" sz="1500" b="1" dirty="0">
+                <a:solidFill>
+                  <a:schemeClr val="bg1"/>
+                </a:solidFill>
+              </a:rPr>
+              <a:t>4</a:t>
+            </a:r>
+            <a:endParaRPr lang="en-US" sz="1500" dirty="0"/>
+          </a:p>
+        </p:txBody>
+      </p:sp>
+      <p:sp>
+        <p:nvSpPr>
+          <p:cNvPr id="21" name="Text 19"/>
+          <p:cNvSpPr txBox="1"/>
+          <p:nvPr/>
+        </p:nvSpPr>
+        <p:spPr>
+          <a:xfrm>
+            <a:off x="7132320" y="3063240"/>
+            <a:ext cx="4297680" cy="411480"/>
+          </a:xfrm>
+          <a:prstGeom prst="rect">
+            <a:avLst/>
+          </a:prstGeom>
+          <a:noFill/>
+          <a:ln/>
+        </p:spPr>
+        <p:txBody>
+          <a:bodyPr wrap="square" lIns="0" tIns="0" rIns="0" bIns="0" rtlCol="0" anchor="t"/>
+          <a:lstStyle/>
+          <a:p>
+            <a:pPr indent="0" marL="0">
+              <a:buNone/>
+            </a:pPr>
+            <a:r>
+              <a:rPr lang="en-US" sz="1600" b="1" dirty="0">
+                <a:solidFill>
+                  <a:schemeClr val="tx2"/>
+                </a:solidFill>
+                <a:latin typeface="Calibri" pitchFamily="34" charset="0"/>
+                <a:ea typeface="Calibri" pitchFamily="34" charset="-122"/>
+                <a:cs typeface="Calibri" pitchFamily="34" charset="-120"/>
+              </a:rPr>
+              <a:t>Messen und zuschauen</a:t>
+            </a:r>
+            <a:endParaRPr lang="en-US" sz="1600" dirty="0"/>
+          </a:p>
+        </p:txBody>
+      </p:sp>
+      <p:sp>
+        <p:nvSpPr>
+          <p:cNvPr id="22" name="Text 20"/>
+          <p:cNvSpPr txBox="1"/>
+          <p:nvPr/>
+        </p:nvSpPr>
+        <p:spPr>
+          <a:xfrm>
+            <a:off x="7132320" y="3493008"/>
+            <a:ext cx="4297680" cy="731520"/>
+          </a:xfrm>
+          <a:prstGeom prst="rect">
+            <a:avLst/>
+          </a:prstGeom>
+          <a:noFill/>
+          <a:ln/>
+        </p:spPr>
+        <p:txBody>
+          <a:bodyPr wrap="square" lIns="0" tIns="0" rIns="0" bIns="0" rtlCol="0" anchor="t"/>
+          <a:lstStyle/>
+          <a:p>
+            <a:pPr indent="0" marL="0">
+              <a:buNone/>
+            </a:pPr>
+            <a:r>
+              <a:rPr lang="en-US" sz="1400" dirty="0">
+                <a:solidFill>
+                  <a:schemeClr val="tx1"/>
+                </a:solidFill>
+                <a:latin typeface="Calibri" pitchFamily="34" charset="0"/>
+                <a:ea typeface="Calibri" pitchFamily="34" charset="-122"/>
+                <a:cs typeface="Calibri" pitchFamily="34" charset="-120"/>
+              </a:rPr>
+              <a:t>Zahlen zeigen Trends, live zuschauen zeigt, was wirklich passiert</a:t>
+            </a:r>
+            <a:endParaRPr lang="en-US" sz="1400" dirty="0"/>
+          </a:p>
+        </p:txBody>
+      </p:sp>
+      <p:sp>
+        <p:nvSpPr>
+          <p:cNvPr id="23" name="learn4"/>
+          <p:cNvSpPr/>
+          <p:nvPr/>
+        </p:nvSpPr>
+        <p:spPr>
+          <a:xfrm>
+            <a:off x="548640" y="4471416"/>
+            <a:ext cx="5394960" cy="1371600"/>
+          </a:xfrm>
+          <a:prstGeom prst="roundRect">
+            <a:avLst>
+              <a:gd name="adj" fmla="val 5333"/>
+            </a:avLst>
+          </a:prstGeom>
+          <a:solidFill>
+            <a:schemeClr val="bg2"/>
+          </a:solidFill>
+          <a:ln w="12700">
+            <a:solidFill>
+              <a:schemeClr val="bg2"/>
+            </a:solidFill>
+            <a:prstDash val="solid"/>
+          </a:ln>
+        </p:spPr>
+      </p:sp>
+      <p:sp>
+        <p:nvSpPr>
+          <p:cNvPr id="24" name="Shape 22"/>
+          <p:cNvSpPr/>
+          <p:nvPr/>
+        </p:nvSpPr>
+        <p:spPr>
+          <a:xfrm>
+            <a:off x="777240" y="4882896"/>
+            <a:ext cx="502920" cy="502920"/>
+          </a:xfrm>
+          <a:prstGeom prst="ellipse">
+            <a:avLst/>
+          </a:prstGeom>
+          <a:solidFill>
+            <a:schemeClr val="accent1"/>
+          </a:solidFill>
+          <a:ln w="12700">
+            <a:solidFill>
+              <a:schemeClr val="accent1"/>
+            </a:solidFill>
+            <a:prstDash val="solid"/>
+          </a:ln>
+        </p:spPr>
+      </p:sp>
+      <p:sp>
+        <p:nvSpPr>
+          <p:cNvPr id="25" name="Text 23"/>
+          <p:cNvSpPr txBox="1"/>
+          <p:nvPr/>
+        </p:nvSpPr>
+        <p:spPr>
+          <a:xfrm>
+            <a:off x="777240" y="4882896"/>
+            <a:ext cx="502920" cy="502920"/>
+          </a:xfrm>
+          <a:prstGeom prst="rect">
+            <a:avLst/>
+          </a:prstGeom>
+          <a:noFill/>
+          <a:ln/>
+        </p:spPr>
+        <p:txBody>
+          <a:bodyPr wrap="square" lIns="0" tIns="0" rIns="0" bIns="0" rtlCol="0" anchor="ctr"/>
+          <a:lstStyle/>
+          <a:p>
+            <a:pPr algn="ctr" indent="0" marL="0">
+              <a:buNone/>
+            </a:pPr>
+            <a:r>
+              <a:rPr lang="en-US" sz="1500" b="1" dirty="0">
+                <a:solidFill>
+                  <a:schemeClr val="bg1"/>
+                </a:solidFill>
+              </a:rPr>
+              <a:t>5</a:t>
+            </a:r>
+            <a:endParaRPr lang="en-US" sz="1500" dirty="0"/>
+          </a:p>
+        </p:txBody>
+      </p:sp>
+      <p:sp>
+        <p:nvSpPr>
+          <p:cNvPr id="26" name="Text 24"/>
+          <p:cNvSpPr txBox="1"/>
+          <p:nvPr/>
+        </p:nvSpPr>
+        <p:spPr>
+          <a:xfrm>
+            <a:off x="1463040" y="4636008"/>
+            <a:ext cx="4297680" cy="411480"/>
+          </a:xfrm>
+          <a:prstGeom prst="rect">
+            <a:avLst/>
+          </a:prstGeom>
+          <a:noFill/>
+          <a:ln/>
+        </p:spPr>
+        <p:txBody>
+          <a:bodyPr wrap="square" lIns="0" tIns="0" rIns="0" bIns="0" rtlCol="0" anchor="t"/>
+          <a:lstStyle/>
+          <a:p>
+            <a:pPr indent="0" marL="0">
+              <a:buNone/>
+            </a:pPr>
+            <a:r>
+              <a:rPr lang="en-US" sz="1600" b="1" dirty="0">
+                <a:solidFill>
+                  <a:schemeClr val="tx2"/>
+                </a:solidFill>
+                <a:latin typeface="Calibri" pitchFamily="34" charset="0"/>
+                <a:ea typeface="Calibri" pitchFamily="34" charset="-122"/>
+                <a:cs typeface="Calibri" pitchFamily="34" charset="-120"/>
+              </a:rPr>
+              <a:t>Kleine Schritte</a:t>
+            </a:r>
+            <a:endParaRPr lang="en-US" sz="1600" dirty="0"/>
+          </a:p>
+        </p:txBody>
+      </p:sp>
+      <p:sp>
+        <p:nvSpPr>
+          <p:cNvPr id="27" name="Text 25"/>
+          <p:cNvSpPr txBox="1"/>
+          <p:nvPr/>
+        </p:nvSpPr>
+        <p:spPr>
+          <a:xfrm>
+            <a:off x="1463040" y="5065776"/>
+            <a:ext cx="4297680" cy="731520"/>
+          </a:xfrm>
+          <a:prstGeom prst="rect">
+            <a:avLst/>
+          </a:prstGeom>
+          <a:noFill/>
+          <a:ln/>
+        </p:spPr>
+        <p:txBody>
+          <a:bodyPr wrap="square" lIns="0" tIns="0" rIns="0" bIns="0" rtlCol="0" anchor="t"/>
+          <a:lstStyle/>
+          <a:p>
+            <a:pPr indent="0" marL="0">
+              <a:buNone/>
+            </a:pPr>
+            <a:r>
+              <a:rPr lang="en-US" sz="1400" dirty="0">
+                <a:solidFill>
+                  <a:schemeClr val="tx1"/>
+                </a:solidFill>
+                <a:latin typeface="Calibri" pitchFamily="34" charset="0"/>
+                <a:ea typeface="Calibri" pitchFamily="34" charset="-122"/>
+                <a:cs typeface="Calibri" pitchFamily="34" charset="-120"/>
+              </a:rPr>
+              <a:t>Eine Änderung pro Training; jeden Checkpoint behalten</a:t>
+            </a:r>
+            <a:endParaRPr lang="en-US" sz="1400" dirty="0"/>
+          </a:p>
+        </p:txBody>
+      </p:sp>
+      <p:sp>
+        <p:nvSpPr>
+          <p:cNvPr id="28" name="learn5"/>
+          <p:cNvSpPr/>
+          <p:nvPr/>
+        </p:nvSpPr>
+        <p:spPr>
+          <a:xfrm>
+            <a:off x="6217920" y="4471416"/>
+            <a:ext cx="5394960" cy="1371600"/>
+          </a:xfrm>
+          <a:prstGeom prst="roundRect">
+            <a:avLst>
+              <a:gd name="adj" fmla="val 5333"/>
+            </a:avLst>
+          </a:prstGeom>
+          <a:solidFill>
+            <a:schemeClr val="bg2"/>
+          </a:solidFill>
+          <a:ln w="12700">
+            <a:solidFill>
+              <a:schemeClr val="bg2"/>
+            </a:solidFill>
+            <a:prstDash val="solid"/>
+          </a:ln>
+        </p:spPr>
+      </p:sp>
+      <p:sp>
+        <p:nvSpPr>
+          <p:cNvPr id="29" name="Shape 27"/>
+          <p:cNvSpPr/>
+          <p:nvPr/>
+        </p:nvSpPr>
+        <p:spPr>
+          <a:xfrm>
+            <a:off x="6446520" y="4882896"/>
+            <a:ext cx="502920" cy="502920"/>
+          </a:xfrm>
+          <a:prstGeom prst="ellipse">
+            <a:avLst/>
+          </a:prstGeom>
+          <a:solidFill>
+            <a:schemeClr val="accent2"/>
+          </a:solidFill>
+          <a:ln w="12700">
+            <a:solidFill>
+              <a:schemeClr val="accent2"/>
+            </a:solidFill>
+            <a:prstDash val="solid"/>
+          </a:ln>
+        </p:spPr>
+      </p:sp>
+      <p:sp>
+        <p:nvSpPr>
+          <p:cNvPr id="30" name="Text 28"/>
+          <p:cNvSpPr txBox="1"/>
+          <p:nvPr/>
+        </p:nvSpPr>
+        <p:spPr>
+          <a:xfrm>
+            <a:off x="6446520" y="4882896"/>
+            <a:ext cx="502920" cy="502920"/>
+          </a:xfrm>
+          <a:prstGeom prst="rect">
+            <a:avLst/>
+          </a:prstGeom>
+          <a:noFill/>
+          <a:ln/>
+        </p:spPr>
+        <p:txBody>
+          <a:bodyPr wrap="square" lIns="0" tIns="0" rIns="0" bIns="0" rtlCol="0" anchor="ctr"/>
+          <a:lstStyle/>
+          <a:p>
+            <a:pPr algn="ctr" indent="0" marL="0">
+              <a:buNone/>
+            </a:pPr>
+            <a:r>
+              <a:rPr lang="en-US" sz="1500" b="1" dirty="0">
+                <a:solidFill>
+                  <a:schemeClr val="bg1"/>
+                </a:solidFill>
+              </a:rPr>
+              <a:t>6</a:t>
+            </a:r>
+            <a:endParaRPr lang="en-US" sz="1500" dirty="0"/>
+          </a:p>
+        </p:txBody>
+      </p:sp>
+      <p:sp>
+        <p:nvSpPr>
+          <p:cNvPr id="31" name="Text 29"/>
+          <p:cNvSpPr txBox="1"/>
+          <p:nvPr/>
+        </p:nvSpPr>
+        <p:spPr>
+          <a:xfrm>
+            <a:off x="7132320" y="4636008"/>
+            <a:ext cx="4297680" cy="411480"/>
+          </a:xfrm>
+          <a:prstGeom prst="rect">
+            <a:avLst/>
+          </a:prstGeom>
+          <a:noFill/>
+          <a:ln/>
+        </p:spPr>
+        <p:txBody>
+          <a:bodyPr wrap="square" lIns="0" tIns="0" rIns="0" bIns="0" rtlCol="0" anchor="t"/>
+          <a:lstStyle/>
+          <a:p>
+            <a:pPr indent="0" marL="0">
+              <a:buNone/>
+            </a:pPr>
+            <a:r>
+              <a:rPr lang="en-US" sz="1600" b="1" dirty="0">
+                <a:solidFill>
+                  <a:schemeClr val="tx2"/>
+                </a:solidFill>
+                <a:latin typeface="Calibri" pitchFamily="34" charset="0"/>
+                <a:ea typeface="Calibri" pitchFamily="34" charset="-122"/>
+                <a:cs typeface="Calibri" pitchFamily="34" charset="-120"/>
+              </a:rPr>
+              <a:t>Regeln gezielt einsetzen</a:t>
+            </a:r>
+            <a:endParaRPr lang="en-US" sz="1600" dirty="0"/>
+          </a:p>
+        </p:txBody>
+      </p:sp>
+      <p:sp>
+        <p:nvSpPr>
+          <p:cNvPr id="32" name="Text 30"/>
+          <p:cNvSpPr txBox="1"/>
+          <p:nvPr/>
+        </p:nvSpPr>
+        <p:spPr>
+          <a:xfrm>
+            <a:off x="7132320" y="5065776"/>
+            <a:ext cx="4297680" cy="731520"/>
+          </a:xfrm>
+          <a:prstGeom prst="rect">
+            <a:avLst/>
+          </a:prstGeom>
+          <a:noFill/>
+          <a:ln/>
+        </p:spPr>
+        <p:txBody>
+          <a:bodyPr wrap="square" lIns="0" tIns="0" rIns="0" bIns="0" rtlCol="0" anchor="t"/>
+          <a:lstStyle/>
+          <a:p>
+            <a:pPr indent="0" marL="0">
+              <a:buNone/>
+            </a:pPr>
+            <a:r>
+              <a:rPr lang="en-US" sz="1400" dirty="0">
+                <a:solidFill>
+                  <a:schemeClr val="tx1"/>
+                </a:solidFill>
+                <a:latin typeface="Calibri" pitchFamily="34" charset="0"/>
+                <a:ea typeface="Calibri" pitchFamily="34" charset="-122"/>
+                <a:cs typeface="Calibri" pitchFamily="34" charset="-120"/>
+              </a:rPr>
+              <a:t>Eine Geh-Regel im Sprint hat das Sprinten verhindert</a:t>
+            </a:r>
+            <a:endParaRPr lang="en-US" sz="1400" dirty="0"/>
+          </a:p>
+        </p:txBody>
+      </p:sp>
+      <p:sp>
+        <p:nvSpPr>
+          <p:cNvPr id="25" name="Slide Number Placeholder 0"/>
+          <p:cNvSpPr>
+            <a:spLocks noGrp="1"/>
+          </p:cNvSpPr>
+          <p:nvPr>
+            <p:ph type="sldNum" sz="quarter" idx="4294967295"/>
+          </p:nvPr>
+        </p:nvSpPr>
+        <p:spPr>
+          <a:xfrm>
+            <a:off x="11247120" y="6400800"/>
+            <a:ext cx="548640" cy="274320"/>
+          </a:xfrm>
+          <a:prstGeom prst="rect">
+            <a:avLst/>
+          </a:prstGeom>
+          <a:extLst>
+            <a:ext uri="{C572A759-6A51-4108-AA02-DFA0A04FC94B}">
+              <ma14:wrappingTextBoxFlag xmlns:ma14="http://schemas.microsoft.com/office/mac/drawingml/2011/main" val="0"/>
+            </a:ext>
+          </a:extLst>
+        </p:spPr>
+        <p:txBody>
+          <a:bodyPr/>
+          <a:lstStyle>
+            <a:lvl1pPr>
+              <a:defRPr sz="1000">
+                <a:solidFill>
+                  <a:srgbClr val="8FA89B"/>
+                </a:solidFill>
+              </a:defRPr>
+            </a:lvl1pPr>
+          </a:lstStyle>
+          <a:p>
+            <a:pPr algn="l"/>
+            <a:fld id="{F7021451-1387-4CA6-816F-3879F97B5CBC}" type="slidenum">
+              <a:rPr b="0" lang="en-US"/>
+              <a:t>8</a:t>
+            </a:fld>
+            <a:endParaRPr lang="en-US"/>
+          </a:p>
+        </p:txBody>
+      </p:sp>
+    </p:spTree>
+  </p:cSld>
+  <p:clrMapOvr>
+    <a:masterClrMapping/>
+  </p:clrMapOvr>
+</p:sld>
+</file>
+
+<file path=ppt/slides/slide9.xml><?xml version="1.0" encoding="utf-8"?>
+<p:sld xmlns:a="http://schemas.openxmlformats.org/drawingml/2006/main" xmlns:r="http://schemas.openxmlformats.org/officeDocument/2006/relationships" xmlns:p="http://schemas.openxmlformats.org/presentationml/2006/main">
+  <p:cSld name="Slide 9">
+    <p:spTree>
+      <p:nvGrpSpPr>
+        <p:cNvPr id="1" name=""/>
+        <p:cNvGrpSpPr/>
+        <p:nvPr/>
+      </p:nvGrpSpPr>
+      <p:grpSpPr>
+        <a:xfrm>
+          <a:off x="0" y="0"/>
+          <a:ext cx="0" cy="0"/>
+          <a:chOff x="0" y="0"/>
+          <a:chExt cx="0" cy="0"/>
+        </a:xfrm>
+      </p:grpSpPr>
+      <p:sp>
+        <p:nvSpPr>
+          <p:cNvPr id="2" name="Text 0"/>
+          <p:cNvSpPr/>
+          <p:nvPr>
+            <p:ph idx="100" type="title" hasCustomPrompt="1"/>
+          </p:nvPr>
+        </p:nvSpPr>
+        <p:spPr>
+          <a:xfrm>
+            <a:off x="548640" y="320040"/>
+            <a:ext cx="11064240" cy="777240"/>
+          </a:xfrm>
+          <a:prstGeom prst="rect">
+            <a:avLst/>
+          </a:prstGeom>
+          <a:noFill/>
+          <a:ln/>
+        </p:spPr>
+        <p:txBody>
+          <a:bodyPr wrap="square" rtlCol="0" anchor="ctr"/>
+          <a:lstStyle/>
+          <a:p>
+            <a:pPr algn="l" indent="0" marL="0">
+              <a:buNone/>
+            </a:pPr>
+            <a:r>
+              <a:rPr lang="en-US" sz="3200" b="1" dirty="0">
+                <a:solidFill>
+                  <a:schemeClr val="tx2"/>
+                </a:solidFill>
+                <a:latin typeface="Cambria" pitchFamily="34" charset="0"/>
+                <a:ea typeface="Cambria" pitchFamily="34" charset="-122"/>
+                <a:cs typeface="Cambria" pitchFamily="34" charset="-120"/>
+              </a:rPr>
               <a:t>Was ist schlecht gelaufen?</a:t>
             </a:r>
             <a:endParaRPr lang="en-US" sz="3200" dirty="0"/>
@@ -8849,7 +10925,7 @@
       </p:sp>
       <p:graphicFrame>
         <p:nvGraphicFramePr>
-          <p:cNvPr id="9" name="Table 0"/>
+          <p:cNvPr id="10" name="Table 0"/>
           <p:cNvGraphicFramePr>
             <a:graphicFrameLocks noGrp="1"/>
           </p:cNvGraphicFramePr>
@@ -9882,1113 +11958,6 @@
             <a:pPr algn="l"/>
             <a:fld id="{F7021451-1387-4CA6-816F-3879F97B5CBC}" type="slidenum">
               <a:rPr b="0" lang="en-US"/>
-              <a:t>8</a:t>
-            </a:fld>
-            <a:endParaRPr lang="en-US"/>
-          </a:p>
-        </p:txBody>
-      </p:sp>
-    </p:spTree>
-  </p:cSld>
-  <p:clrMapOvr>
-    <a:masterClrMapping/>
-  </p:clrMapOvr>
-</p:sld>
-</file>
-
-<file path=ppt/slides/slide9.xml><?xml version="1.0" encoding="utf-8"?>
-<p:sld xmlns:a="http://schemas.openxmlformats.org/drawingml/2006/main" xmlns:r="http://schemas.openxmlformats.org/officeDocument/2006/relationships" xmlns:p="http://schemas.openxmlformats.org/presentationml/2006/main">
-  <p:cSld name="Slide 9">
-    <p:spTree>
-      <p:nvGrpSpPr>
-        <p:cNvPr id="1" name=""/>
-        <p:cNvGrpSpPr/>
-        <p:nvPr/>
-      </p:nvGrpSpPr>
-      <p:grpSpPr>
-        <a:xfrm>
-          <a:off x="0" y="0"/>
-          <a:ext cx="0" cy="0"/>
-          <a:chOff x="0" y="0"/>
-          <a:chExt cx="0" cy="0"/>
-        </a:xfrm>
-      </p:grpSpPr>
-      <p:sp>
-        <p:nvSpPr>
-          <p:cNvPr id="2" name="Text 0"/>
-          <p:cNvSpPr/>
-          <p:nvPr>
-            <p:ph idx="100" type="title" hasCustomPrompt="1"/>
-          </p:nvPr>
-        </p:nvSpPr>
-        <p:spPr>
-          <a:xfrm>
-            <a:off x="548640" y="320040"/>
-            <a:ext cx="11064240" cy="777240"/>
-          </a:xfrm>
-          <a:prstGeom prst="rect">
-            <a:avLst/>
-          </a:prstGeom>
-          <a:noFill/>
-          <a:ln/>
-        </p:spPr>
-        <p:txBody>
-          <a:bodyPr wrap="square" rtlCol="0" anchor="ctr"/>
-          <a:lstStyle/>
-          <a:p>
-            <a:pPr algn="l" indent="0" marL="0">
-              <a:buNone/>
-            </a:pPr>
-            <a:r>
-              <a:rPr lang="en-US" sz="3200" b="1" dirty="0">
-                <a:solidFill>
-                  <a:schemeClr val="tx2"/>
-                </a:solidFill>
-                <a:latin typeface="Cambria" pitchFamily="34" charset="0"/>
-                <a:ea typeface="Cambria" pitchFamily="34" charset="-122"/>
-                <a:cs typeface="Cambria" pitchFamily="34" charset="-120"/>
-              </a:rPr>
-              <a:t>Was würde ich anders machen?</a:t>
-            </a:r>
-            <a:endParaRPr lang="en-US" sz="3200" dirty="0"/>
-          </a:p>
-        </p:txBody>
-      </p:sp>
-      <p:sp>
-        <p:nvSpPr>
-          <p:cNvPr id="3" name="diff0"/>
-          <p:cNvSpPr/>
-          <p:nvPr/>
-        </p:nvSpPr>
-        <p:spPr>
-          <a:xfrm>
-            <a:off x="548640" y="1371600"/>
-            <a:ext cx="3520440" cy="2011680"/>
-          </a:xfrm>
-          <a:prstGeom prst="roundRect">
-            <a:avLst>
-              <a:gd name="adj" fmla="val 3636"/>
-            </a:avLst>
-          </a:prstGeom>
-          <a:solidFill>
-            <a:schemeClr val="bg2"/>
-          </a:solidFill>
-          <a:ln w="12700">
-            <a:solidFill>
-              <a:schemeClr val="bg2"/>
-            </a:solidFill>
-            <a:prstDash val="solid"/>
-          </a:ln>
-        </p:spPr>
-      </p:sp>
-      <p:sp>
-        <p:nvSpPr>
-          <p:cNvPr id="4" name="Shape 2"/>
-          <p:cNvSpPr/>
-          <p:nvPr/>
-        </p:nvSpPr>
-        <p:spPr>
-          <a:xfrm>
-            <a:off x="777240" y="1600200"/>
-            <a:ext cx="502920" cy="502920"/>
-          </a:xfrm>
-          <a:prstGeom prst="ellipse">
-            <a:avLst/>
-          </a:prstGeom>
-          <a:solidFill>
-            <a:schemeClr val="accent1"/>
-          </a:solidFill>
-          <a:ln w="12700">
-            <a:solidFill>
-              <a:schemeClr val="accent1"/>
-            </a:solidFill>
-            <a:prstDash val="solid"/>
-          </a:ln>
-        </p:spPr>
-      </p:sp>
-      <p:sp>
-        <p:nvSpPr>
-          <p:cNvPr id="5" name="Text 3"/>
-          <p:cNvSpPr txBox="1"/>
-          <p:nvPr/>
-        </p:nvSpPr>
-        <p:spPr>
-          <a:xfrm>
-            <a:off x="777240" y="1600200"/>
-            <a:ext cx="502920" cy="502920"/>
-          </a:xfrm>
-          <a:prstGeom prst="rect">
-            <a:avLst/>
-          </a:prstGeom>
-          <a:noFill/>
-          <a:ln/>
-        </p:spPr>
-        <p:txBody>
-          <a:bodyPr wrap="square" lIns="0" tIns="0" rIns="0" bIns="0" rtlCol="0" anchor="ctr"/>
-          <a:lstStyle/>
-          <a:p>
-            <a:pPr algn="ctr" indent="0" marL="0">
-              <a:buNone/>
-            </a:pPr>
-            <a:r>
-              <a:rPr lang="en-US" sz="1500" b="1" dirty="0">
-                <a:solidFill>
-                  <a:schemeClr val="bg1"/>
-                </a:solidFill>
-              </a:rPr>
-              <a:t>→</a:t>
-            </a:r>
-            <a:endParaRPr lang="en-US" sz="1500" dirty="0"/>
-          </a:p>
-        </p:txBody>
-      </p:sp>
-      <p:sp>
-        <p:nvSpPr>
-          <p:cNvPr id="6" name="Text 4"/>
-          <p:cNvSpPr txBox="1"/>
-          <p:nvPr/>
-        </p:nvSpPr>
-        <p:spPr>
-          <a:xfrm>
-            <a:off x="1463040" y="1645920"/>
-            <a:ext cx="2468880" cy="457200"/>
-          </a:xfrm>
-          <a:prstGeom prst="rect">
-            <a:avLst/>
-          </a:prstGeom>
-          <a:noFill/>
-          <a:ln/>
-        </p:spPr>
-        <p:txBody>
-          <a:bodyPr wrap="square" lIns="0" tIns="0" rIns="0" bIns="0" rtlCol="0" anchor="t"/>
-          <a:lstStyle/>
-          <a:p>
-            <a:pPr indent="0" marL="0">
-              <a:buNone/>
-            </a:pPr>
-            <a:r>
-              <a:rPr lang="en-US" sz="1600" b="1" dirty="0">
-                <a:solidFill>
-                  <a:schemeClr val="tx2"/>
-                </a:solidFill>
-                <a:latin typeface="Calibri" pitchFamily="34" charset="0"/>
-                <a:ea typeface="Calibri" pitchFamily="34" charset="-122"/>
-                <a:cs typeface="Calibri" pitchFamily="34" charset="-120"/>
-              </a:rPr>
-              <a:t>Körper zuerst prüfen</a:t>
-            </a:r>
-            <a:endParaRPr lang="en-US" sz="1600" dirty="0"/>
-          </a:p>
-        </p:txBody>
-      </p:sp>
-      <p:sp>
-        <p:nvSpPr>
-          <p:cNvPr id="7" name="Text 5"/>
-          <p:cNvSpPr txBox="1"/>
-          <p:nvPr/>
-        </p:nvSpPr>
-        <p:spPr>
-          <a:xfrm>
-            <a:off x="777240" y="2240280"/>
-            <a:ext cx="3108960" cy="1051560"/>
-          </a:xfrm>
-          <a:prstGeom prst="rect">
-            <a:avLst/>
-          </a:prstGeom>
-          <a:noFill/>
-          <a:ln/>
-        </p:spPr>
-        <p:txBody>
-          <a:bodyPr wrap="square" lIns="0" tIns="0" rIns="0" bIns="0" rtlCol="0" anchor="t"/>
-          <a:lstStyle/>
-          <a:p>
-            <a:pPr indent="0" marL="0">
-              <a:buNone/>
-            </a:pPr>
-            <a:r>
-              <a:rPr lang="en-US" sz="1400" dirty="0">
-                <a:solidFill>
-                  <a:schemeClr val="tx1"/>
-                </a:solidFill>
-                <a:latin typeface="Calibri" pitchFamily="34" charset="0"/>
-                <a:ea typeface="Calibri" pitchFamily="34" charset="-122"/>
-                <a:cs typeface="Calibri" pitchFamily="34" charset="-120"/>
-              </a:rPr>
-              <a:t>Masse, Geometrie, Reichweite der Glieder vor dem ersten Training messen</a:t>
-            </a:r>
-            <a:endParaRPr lang="en-US" sz="1400" dirty="0"/>
-          </a:p>
-        </p:txBody>
-      </p:sp>
-      <p:sp>
-        <p:nvSpPr>
-          <p:cNvPr id="8" name="diff1"/>
-          <p:cNvSpPr/>
-          <p:nvPr/>
-        </p:nvSpPr>
-        <p:spPr>
-          <a:xfrm>
-            <a:off x="4297680" y="1371600"/>
-            <a:ext cx="3520440" cy="2011680"/>
-          </a:xfrm>
-          <a:prstGeom prst="roundRect">
-            <a:avLst>
-              <a:gd name="adj" fmla="val 3636"/>
-            </a:avLst>
-          </a:prstGeom>
-          <a:solidFill>
-            <a:schemeClr val="bg2"/>
-          </a:solidFill>
-          <a:ln w="12700">
-            <a:solidFill>
-              <a:schemeClr val="bg2"/>
-            </a:solidFill>
-            <a:prstDash val="solid"/>
-          </a:ln>
-        </p:spPr>
-      </p:sp>
-      <p:sp>
-        <p:nvSpPr>
-          <p:cNvPr id="9" name="Shape 7"/>
-          <p:cNvSpPr/>
-          <p:nvPr/>
-        </p:nvSpPr>
-        <p:spPr>
-          <a:xfrm>
-            <a:off x="4526280" y="1600200"/>
-            <a:ext cx="502920" cy="502920"/>
-          </a:xfrm>
-          <a:prstGeom prst="ellipse">
-            <a:avLst/>
-          </a:prstGeom>
-          <a:solidFill>
-            <a:schemeClr val="accent1"/>
-          </a:solidFill>
-          <a:ln w="12700">
-            <a:solidFill>
-              <a:schemeClr val="accent1"/>
-            </a:solidFill>
-            <a:prstDash val="solid"/>
-          </a:ln>
-        </p:spPr>
-      </p:sp>
-      <p:sp>
-        <p:nvSpPr>
-          <p:cNvPr id="10" name="Text 8"/>
-          <p:cNvSpPr txBox="1"/>
-          <p:nvPr/>
-        </p:nvSpPr>
-        <p:spPr>
-          <a:xfrm>
-            <a:off x="4526280" y="1600200"/>
-            <a:ext cx="502920" cy="502920"/>
-          </a:xfrm>
-          <a:prstGeom prst="rect">
-            <a:avLst/>
-          </a:prstGeom>
-          <a:noFill/>
-          <a:ln/>
-        </p:spPr>
-        <p:txBody>
-          <a:bodyPr wrap="square" lIns="0" tIns="0" rIns="0" bIns="0" rtlCol="0" anchor="ctr"/>
-          <a:lstStyle/>
-          <a:p>
-            <a:pPr algn="ctr" indent="0" marL="0">
-              <a:buNone/>
-            </a:pPr>
-            <a:r>
-              <a:rPr lang="en-US" sz="1500" b="1" dirty="0">
-                <a:solidFill>
-                  <a:schemeClr val="bg1"/>
-                </a:solidFill>
-              </a:rPr>
-              <a:t>→</a:t>
-            </a:r>
-            <a:endParaRPr lang="en-US" sz="1500" dirty="0"/>
-          </a:p>
-        </p:txBody>
-      </p:sp>
-      <p:sp>
-        <p:nvSpPr>
-          <p:cNvPr id="11" name="Text 9"/>
-          <p:cNvSpPr txBox="1"/>
-          <p:nvPr/>
-        </p:nvSpPr>
-        <p:spPr>
-          <a:xfrm>
-            <a:off x="5212080" y="1645920"/>
-            <a:ext cx="2468880" cy="457200"/>
-          </a:xfrm>
-          <a:prstGeom prst="rect">
-            <a:avLst/>
-          </a:prstGeom>
-          <a:noFill/>
-          <a:ln/>
-        </p:spPr>
-        <p:txBody>
-          <a:bodyPr wrap="square" lIns="0" tIns="0" rIns="0" bIns="0" rtlCol="0" anchor="t"/>
-          <a:lstStyle/>
-          <a:p>
-            <a:pPr indent="0" marL="0">
-              <a:buNone/>
-            </a:pPr>
-            <a:r>
-              <a:rPr lang="en-US" sz="1600" b="1" dirty="0">
-                <a:solidFill>
-                  <a:schemeClr val="tx2"/>
-                </a:solidFill>
-                <a:latin typeface="Calibri" pitchFamily="34" charset="0"/>
-                <a:ea typeface="Calibri" pitchFamily="34" charset="-122"/>
-                <a:cs typeface="Calibri" pitchFamily="34" charset="-120"/>
-              </a:rPr>
-              <a:t>Belohnung vorher testen</a:t>
-            </a:r>
-            <a:endParaRPr lang="en-US" sz="1600" dirty="0"/>
-          </a:p>
-        </p:txBody>
-      </p:sp>
-      <p:sp>
-        <p:nvSpPr>
-          <p:cNvPr id="12" name="Text 10"/>
-          <p:cNvSpPr txBox="1"/>
-          <p:nvPr/>
-        </p:nvSpPr>
-        <p:spPr>
-          <a:xfrm>
-            <a:off x="4526280" y="2240280"/>
-            <a:ext cx="3108960" cy="1051560"/>
-          </a:xfrm>
-          <a:prstGeom prst="rect">
-            <a:avLst/>
-          </a:prstGeom>
-          <a:noFill/>
-          <a:ln/>
-        </p:spPr>
-        <p:txBody>
-          <a:bodyPr wrap="square" lIns="0" tIns="0" rIns="0" bIns="0" rtlCol="0" anchor="t"/>
-          <a:lstStyle/>
-          <a:p>
-            <a:pPr indent="0" marL="0">
-              <a:buNone/>
-            </a:pPr>
-            <a:r>
-              <a:rPr lang="en-US" sz="1400" dirty="0">
-                <a:solidFill>
-                  <a:schemeClr val="tx1"/>
-                </a:solidFill>
-                <a:latin typeface="Calibri" pitchFamily="34" charset="0"/>
-                <a:ea typeface="Calibri" pitchFamily="34" charset="-122"/>
-                <a:cs typeface="Calibri" pitchFamily="34" charset="-120"/>
-              </a:rPr>
-              <a:t>Mit einfachen Skript-Figuren prüfen, ob Stehen oder Schlupflöcher sich lohnen</a:t>
-            </a:r>
-            <a:endParaRPr lang="en-US" sz="1400" dirty="0"/>
-          </a:p>
-        </p:txBody>
-      </p:sp>
-      <p:sp>
-        <p:nvSpPr>
-          <p:cNvPr id="13" name="diff2"/>
-          <p:cNvSpPr/>
-          <p:nvPr/>
-        </p:nvSpPr>
-        <p:spPr>
-          <a:xfrm>
-            <a:off x="8046720" y="1371600"/>
-            <a:ext cx="3520440" cy="2011680"/>
-          </a:xfrm>
-          <a:prstGeom prst="roundRect">
-            <a:avLst>
-              <a:gd name="adj" fmla="val 3636"/>
-            </a:avLst>
-          </a:prstGeom>
-          <a:solidFill>
-            <a:schemeClr val="bg2"/>
-          </a:solidFill>
-          <a:ln w="12700">
-            <a:solidFill>
-              <a:schemeClr val="bg2"/>
-            </a:solidFill>
-            <a:prstDash val="solid"/>
-          </a:ln>
-        </p:spPr>
-      </p:sp>
-      <p:sp>
-        <p:nvSpPr>
-          <p:cNvPr id="14" name="Shape 12"/>
-          <p:cNvSpPr/>
-          <p:nvPr/>
-        </p:nvSpPr>
-        <p:spPr>
-          <a:xfrm>
-            <a:off x="8275320" y="1600200"/>
-            <a:ext cx="502920" cy="502920"/>
-          </a:xfrm>
-          <a:prstGeom prst="ellipse">
-            <a:avLst/>
-          </a:prstGeom>
-          <a:solidFill>
-            <a:schemeClr val="accent1"/>
-          </a:solidFill>
-          <a:ln w="12700">
-            <a:solidFill>
-              <a:schemeClr val="accent1"/>
-            </a:solidFill>
-            <a:prstDash val="solid"/>
-          </a:ln>
-        </p:spPr>
-      </p:sp>
-      <p:sp>
-        <p:nvSpPr>
-          <p:cNvPr id="15" name="Text 13"/>
-          <p:cNvSpPr txBox="1"/>
-          <p:nvPr/>
-        </p:nvSpPr>
-        <p:spPr>
-          <a:xfrm>
-            <a:off x="8275320" y="1600200"/>
-            <a:ext cx="502920" cy="502920"/>
-          </a:xfrm>
-          <a:prstGeom prst="rect">
-            <a:avLst/>
-          </a:prstGeom>
-          <a:noFill/>
-          <a:ln/>
-        </p:spPr>
-        <p:txBody>
-          <a:bodyPr wrap="square" lIns="0" tIns="0" rIns="0" bIns="0" rtlCol="0" anchor="ctr"/>
-          <a:lstStyle/>
-          <a:p>
-            <a:pPr algn="ctr" indent="0" marL="0">
-              <a:buNone/>
-            </a:pPr>
-            <a:r>
-              <a:rPr lang="en-US" sz="1500" b="1" dirty="0">
-                <a:solidFill>
-                  <a:schemeClr val="bg1"/>
-                </a:solidFill>
-              </a:rPr>
-              <a:t>→</a:t>
-            </a:r>
-            <a:endParaRPr lang="en-US" sz="1500" dirty="0"/>
-          </a:p>
-        </p:txBody>
-      </p:sp>
-      <p:sp>
-        <p:nvSpPr>
-          <p:cNvPr id="16" name="Text 14"/>
-          <p:cNvSpPr txBox="1"/>
-          <p:nvPr/>
-        </p:nvSpPr>
-        <p:spPr>
-          <a:xfrm>
-            <a:off x="8961120" y="1645920"/>
-            <a:ext cx="2468880" cy="457200"/>
-          </a:xfrm>
-          <a:prstGeom prst="rect">
-            <a:avLst/>
-          </a:prstGeom>
-          <a:noFill/>
-          <a:ln/>
-        </p:spPr>
-        <p:txBody>
-          <a:bodyPr wrap="square" lIns="0" tIns="0" rIns="0" bIns="0" rtlCol="0" anchor="t"/>
-          <a:lstStyle/>
-          <a:p>
-            <a:pPr indent="0" marL="0">
-              <a:buNone/>
-            </a:pPr>
-            <a:r>
-              <a:rPr lang="en-US" sz="1600" b="1" dirty="0">
-                <a:solidFill>
-                  <a:schemeClr val="tx2"/>
-                </a:solidFill>
-                <a:latin typeface="Calibri" pitchFamily="34" charset="0"/>
-                <a:ea typeface="Calibri" pitchFamily="34" charset="-122"/>
-                <a:cs typeface="Calibri" pitchFamily="34" charset="-120"/>
-              </a:rPr>
-              <a:t>Vorbild früher nutzen</a:t>
-            </a:r>
-            <a:endParaRPr lang="en-US" sz="1600" dirty="0"/>
-          </a:p>
-        </p:txBody>
-      </p:sp>
-      <p:sp>
-        <p:nvSpPr>
-          <p:cNvPr id="17" name="Text 15"/>
-          <p:cNvSpPr txBox="1"/>
-          <p:nvPr/>
-        </p:nvSpPr>
-        <p:spPr>
-          <a:xfrm>
-            <a:off x="8275320" y="2240280"/>
-            <a:ext cx="3108960" cy="1051560"/>
-          </a:xfrm>
-          <a:prstGeom prst="rect">
-            <a:avLst/>
-          </a:prstGeom>
-          <a:noFill/>
-          <a:ln/>
-        </p:spPr>
-        <p:txBody>
-          <a:bodyPr wrap="square" lIns="0" tIns="0" rIns="0" bIns="0" rtlCol="0" anchor="t"/>
-          <a:lstStyle/>
-          <a:p>
-            <a:pPr indent="0" marL="0">
-              <a:buNone/>
-            </a:pPr>
-            <a:r>
-              <a:rPr lang="en-US" sz="1400" dirty="0">
-                <a:solidFill>
-                  <a:schemeClr val="tx1"/>
-                </a:solidFill>
-                <a:latin typeface="Calibri" pitchFamily="34" charset="0"/>
-                <a:ea typeface="Calibri" pitchFamily="34" charset="-122"/>
-                <a:cs typeface="Calibri" pitchFamily="34" charset="-120"/>
-              </a:rPr>
-              <a:t>Eine Referenz-Bewegung (z. B. der Wolf) von Anfang an als Ziel</a:t>
-            </a:r>
-            <a:endParaRPr lang="en-US" sz="1400" dirty="0"/>
-          </a:p>
-        </p:txBody>
-      </p:sp>
-      <p:sp>
-        <p:nvSpPr>
-          <p:cNvPr id="18" name="diff3"/>
-          <p:cNvSpPr/>
-          <p:nvPr/>
-        </p:nvSpPr>
-        <p:spPr>
-          <a:xfrm>
-            <a:off x="548640" y="3657600"/>
-            <a:ext cx="3520440" cy="2011680"/>
-          </a:xfrm>
-          <a:prstGeom prst="roundRect">
-            <a:avLst>
-              <a:gd name="adj" fmla="val 3636"/>
-            </a:avLst>
-          </a:prstGeom>
-          <a:solidFill>
-            <a:schemeClr val="bg2"/>
-          </a:solidFill>
-          <a:ln w="12700">
-            <a:solidFill>
-              <a:schemeClr val="bg2"/>
-            </a:solidFill>
-            <a:prstDash val="solid"/>
-          </a:ln>
-        </p:spPr>
-      </p:sp>
-      <p:sp>
-        <p:nvSpPr>
-          <p:cNvPr id="19" name="Shape 17"/>
-          <p:cNvSpPr/>
-          <p:nvPr/>
-        </p:nvSpPr>
-        <p:spPr>
-          <a:xfrm>
-            <a:off x="777240" y="3886200"/>
-            <a:ext cx="502920" cy="502920"/>
-          </a:xfrm>
-          <a:prstGeom prst="ellipse">
-            <a:avLst/>
-          </a:prstGeom>
-          <a:solidFill>
-            <a:schemeClr val="accent2"/>
-          </a:solidFill>
-          <a:ln w="12700">
-            <a:solidFill>
-              <a:schemeClr val="accent2"/>
-            </a:solidFill>
-            <a:prstDash val="solid"/>
-          </a:ln>
-        </p:spPr>
-      </p:sp>
-      <p:sp>
-        <p:nvSpPr>
-          <p:cNvPr id="20" name="Text 18"/>
-          <p:cNvSpPr txBox="1"/>
-          <p:nvPr/>
-        </p:nvSpPr>
-        <p:spPr>
-          <a:xfrm>
-            <a:off x="777240" y="3886200"/>
-            <a:ext cx="502920" cy="502920"/>
-          </a:xfrm>
-          <a:prstGeom prst="rect">
-            <a:avLst/>
-          </a:prstGeom>
-          <a:noFill/>
-          <a:ln/>
-        </p:spPr>
-        <p:txBody>
-          <a:bodyPr wrap="square" lIns="0" tIns="0" rIns="0" bIns="0" rtlCol="0" anchor="ctr"/>
-          <a:lstStyle/>
-          <a:p>
-            <a:pPr algn="ctr" indent="0" marL="0">
-              <a:buNone/>
-            </a:pPr>
-            <a:r>
-              <a:rPr lang="en-US" sz="1500" b="1" dirty="0">
-                <a:solidFill>
-                  <a:schemeClr val="bg1"/>
-                </a:solidFill>
-              </a:rPr>
-              <a:t>→</a:t>
-            </a:r>
-            <a:endParaRPr lang="en-US" sz="1500" dirty="0"/>
-          </a:p>
-        </p:txBody>
-      </p:sp>
-      <p:sp>
-        <p:nvSpPr>
-          <p:cNvPr id="21" name="Text 19"/>
-          <p:cNvSpPr txBox="1"/>
-          <p:nvPr/>
-        </p:nvSpPr>
-        <p:spPr>
-          <a:xfrm>
-            <a:off x="1463040" y="3931920"/>
-            <a:ext cx="2468880" cy="457200"/>
-          </a:xfrm>
-          <a:prstGeom prst="rect">
-            <a:avLst/>
-          </a:prstGeom>
-          <a:noFill/>
-          <a:ln/>
-        </p:spPr>
-        <p:txBody>
-          <a:bodyPr wrap="square" lIns="0" tIns="0" rIns="0" bIns="0" rtlCol="0" anchor="t"/>
-          <a:lstStyle/>
-          <a:p>
-            <a:pPr indent="0" marL="0">
-              <a:buNone/>
-            </a:pPr>
-            <a:r>
-              <a:rPr lang="en-US" sz="1600" b="1" dirty="0">
-                <a:solidFill>
-                  <a:schemeClr val="tx2"/>
-                </a:solidFill>
-                <a:latin typeface="Calibri" pitchFamily="34" charset="0"/>
-                <a:ea typeface="Calibri" pitchFamily="34" charset="-122"/>
-                <a:cs typeface="Calibri" pitchFamily="34" charset="-120"/>
-              </a:rPr>
-              <a:t>Ziele messbar festlegen</a:t>
-            </a:r>
-            <a:endParaRPr lang="en-US" sz="1600" dirty="0"/>
-          </a:p>
-        </p:txBody>
-      </p:sp>
-      <p:sp>
-        <p:nvSpPr>
-          <p:cNvPr id="22" name="Text 20"/>
-          <p:cNvSpPr txBox="1"/>
-          <p:nvPr/>
-        </p:nvSpPr>
-        <p:spPr>
-          <a:xfrm>
-            <a:off x="777240" y="4526280"/>
-            <a:ext cx="3108960" cy="1051560"/>
-          </a:xfrm>
-          <a:prstGeom prst="rect">
-            <a:avLst/>
-          </a:prstGeom>
-          <a:noFill/>
-          <a:ln/>
-        </p:spPr>
-        <p:txBody>
-          <a:bodyPr wrap="square" lIns="0" tIns="0" rIns="0" bIns="0" rtlCol="0" anchor="t"/>
-          <a:lstStyle/>
-          <a:p>
-            <a:pPr indent="0" marL="0">
-              <a:buNone/>
-            </a:pPr>
-            <a:r>
-              <a:rPr lang="en-US" sz="1400" dirty="0">
-                <a:solidFill>
-                  <a:schemeClr val="tx1"/>
-                </a:solidFill>
-                <a:latin typeface="Calibri" pitchFamily="34" charset="0"/>
-                <a:ea typeface="Calibri" pitchFamily="34" charset="-122"/>
-                <a:cs typeface="Calibri" pitchFamily="34" charset="-120"/>
-              </a:rPr>
-              <a:t>Tempo, Takt, Haltung als feste Tests vor jedem Training</a:t>
-            </a:r>
-            <a:endParaRPr lang="en-US" sz="1400" dirty="0"/>
-          </a:p>
-        </p:txBody>
-      </p:sp>
-      <p:sp>
-        <p:nvSpPr>
-          <p:cNvPr id="23" name="diff4"/>
-          <p:cNvSpPr/>
-          <p:nvPr/>
-        </p:nvSpPr>
-        <p:spPr>
-          <a:xfrm>
-            <a:off x="4297680" y="3657600"/>
-            <a:ext cx="3520440" cy="2011680"/>
-          </a:xfrm>
-          <a:prstGeom prst="roundRect">
-            <a:avLst>
-              <a:gd name="adj" fmla="val 3636"/>
-            </a:avLst>
-          </a:prstGeom>
-          <a:solidFill>
-            <a:schemeClr val="bg2"/>
-          </a:solidFill>
-          <a:ln w="12700">
-            <a:solidFill>
-              <a:schemeClr val="bg2"/>
-            </a:solidFill>
-            <a:prstDash val="solid"/>
-          </a:ln>
-        </p:spPr>
-      </p:sp>
-      <p:sp>
-        <p:nvSpPr>
-          <p:cNvPr id="24" name="Shape 22"/>
-          <p:cNvSpPr/>
-          <p:nvPr/>
-        </p:nvSpPr>
-        <p:spPr>
-          <a:xfrm>
-            <a:off x="4526280" y="3886200"/>
-            <a:ext cx="502920" cy="502920"/>
-          </a:xfrm>
-          <a:prstGeom prst="ellipse">
-            <a:avLst/>
-          </a:prstGeom>
-          <a:solidFill>
-            <a:schemeClr val="accent2"/>
-          </a:solidFill>
-          <a:ln w="12700">
-            <a:solidFill>
-              <a:schemeClr val="accent2"/>
-            </a:solidFill>
-            <a:prstDash val="solid"/>
-          </a:ln>
-        </p:spPr>
-      </p:sp>
-      <p:sp>
-        <p:nvSpPr>
-          <p:cNvPr id="25" name="Text 23"/>
-          <p:cNvSpPr txBox="1"/>
-          <p:nvPr/>
-        </p:nvSpPr>
-        <p:spPr>
-          <a:xfrm>
-            <a:off x="4526280" y="3886200"/>
-            <a:ext cx="502920" cy="502920"/>
-          </a:xfrm>
-          <a:prstGeom prst="rect">
-            <a:avLst/>
-          </a:prstGeom>
-          <a:noFill/>
-          <a:ln/>
-        </p:spPr>
-        <p:txBody>
-          <a:bodyPr wrap="square" lIns="0" tIns="0" rIns="0" bIns="0" rtlCol="0" anchor="ctr"/>
-          <a:lstStyle/>
-          <a:p>
-            <a:pPr algn="ctr" indent="0" marL="0">
-              <a:buNone/>
-            </a:pPr>
-            <a:r>
-              <a:rPr lang="en-US" sz="1500" b="1" dirty="0">
-                <a:solidFill>
-                  <a:schemeClr val="bg1"/>
-                </a:solidFill>
-              </a:rPr>
-              <a:t>→</a:t>
-            </a:r>
-            <a:endParaRPr lang="en-US" sz="1500" dirty="0"/>
-          </a:p>
-        </p:txBody>
-      </p:sp>
-      <p:sp>
-        <p:nvSpPr>
-          <p:cNvPr id="26" name="Text 24"/>
-          <p:cNvSpPr txBox="1"/>
-          <p:nvPr/>
-        </p:nvSpPr>
-        <p:spPr>
-          <a:xfrm>
-            <a:off x="5212080" y="3931920"/>
-            <a:ext cx="2468880" cy="457200"/>
-          </a:xfrm>
-          <a:prstGeom prst="rect">
-            <a:avLst/>
-          </a:prstGeom>
-          <a:noFill/>
-          <a:ln/>
-        </p:spPr>
-        <p:txBody>
-          <a:bodyPr wrap="square" lIns="0" tIns="0" rIns="0" bIns="0" rtlCol="0" anchor="t"/>
-          <a:lstStyle/>
-          <a:p>
-            <a:pPr indent="0" marL="0">
-              <a:buNone/>
-            </a:pPr>
-            <a:r>
-              <a:rPr lang="en-US" sz="1600" b="1" dirty="0">
-                <a:solidFill>
-                  <a:schemeClr val="tx2"/>
-                </a:solidFill>
-                <a:latin typeface="Calibri" pitchFamily="34" charset="0"/>
-                <a:ea typeface="Calibri" pitchFamily="34" charset="-122"/>
-                <a:cs typeface="Calibri" pitchFamily="34" charset="-120"/>
-              </a:rPr>
-              <a:t>Stärkere Hardware</a:t>
-            </a:r>
-            <a:endParaRPr lang="en-US" sz="1600" dirty="0"/>
-          </a:p>
-        </p:txBody>
-      </p:sp>
-      <p:sp>
-        <p:nvSpPr>
-          <p:cNvPr id="27" name="Text 25"/>
-          <p:cNvSpPr txBox="1"/>
-          <p:nvPr/>
-        </p:nvSpPr>
-        <p:spPr>
-          <a:xfrm>
-            <a:off x="4526280" y="4526280"/>
-            <a:ext cx="3108960" cy="1051560"/>
-          </a:xfrm>
-          <a:prstGeom prst="rect">
-            <a:avLst/>
-          </a:prstGeom>
-          <a:noFill/>
-          <a:ln/>
-        </p:spPr>
-        <p:txBody>
-          <a:bodyPr wrap="square" lIns="0" tIns="0" rIns="0" bIns="0" rtlCol="0" anchor="t"/>
-          <a:lstStyle/>
-          <a:p>
-            <a:pPr indent="0" marL="0">
-              <a:buNone/>
-            </a:pPr>
-            <a:r>
-              <a:rPr lang="en-US" sz="1400" dirty="0">
-                <a:solidFill>
-                  <a:schemeClr val="tx1"/>
-                </a:solidFill>
-                <a:latin typeface="Calibri" pitchFamily="34" charset="0"/>
-                <a:ea typeface="Calibri" pitchFamily="34" charset="-122"/>
-                <a:cs typeface="Calibri" pitchFamily="34" charset="-120"/>
-              </a:rPr>
-              <a:t>Rechner mit Grafikkarte oder Cloud: Rendern 10–20× schneller, nichts schläft ein</a:t>
-            </a:r>
-            <a:endParaRPr lang="en-US" sz="1400" dirty="0"/>
-          </a:p>
-        </p:txBody>
-      </p:sp>
-      <p:sp>
-        <p:nvSpPr>
-          <p:cNvPr id="28" name="diff5"/>
-          <p:cNvSpPr/>
-          <p:nvPr/>
-        </p:nvSpPr>
-        <p:spPr>
-          <a:xfrm>
-            <a:off x="8046720" y="3657600"/>
-            <a:ext cx="3520440" cy="2011680"/>
-          </a:xfrm>
-          <a:prstGeom prst="roundRect">
-            <a:avLst>
-              <a:gd name="adj" fmla="val 3636"/>
-            </a:avLst>
-          </a:prstGeom>
-          <a:solidFill>
-            <a:schemeClr val="bg2"/>
-          </a:solidFill>
-          <a:ln w="12700">
-            <a:solidFill>
-              <a:schemeClr val="bg2"/>
-            </a:solidFill>
-            <a:prstDash val="solid"/>
-          </a:ln>
-        </p:spPr>
-      </p:sp>
-      <p:sp>
-        <p:nvSpPr>
-          <p:cNvPr id="29" name="Shape 27"/>
-          <p:cNvSpPr/>
-          <p:nvPr/>
-        </p:nvSpPr>
-        <p:spPr>
-          <a:xfrm>
-            <a:off x="8275320" y="3886200"/>
-            <a:ext cx="502920" cy="502920"/>
-          </a:xfrm>
-          <a:prstGeom prst="ellipse">
-            <a:avLst/>
-          </a:prstGeom>
-          <a:solidFill>
-            <a:schemeClr val="accent2"/>
-          </a:solidFill>
-          <a:ln w="12700">
-            <a:solidFill>
-              <a:schemeClr val="accent2"/>
-            </a:solidFill>
-            <a:prstDash val="solid"/>
-          </a:ln>
-        </p:spPr>
-      </p:sp>
-      <p:sp>
-        <p:nvSpPr>
-          <p:cNvPr id="30" name="Text 28"/>
-          <p:cNvSpPr txBox="1"/>
-          <p:nvPr/>
-        </p:nvSpPr>
-        <p:spPr>
-          <a:xfrm>
-            <a:off x="8275320" y="3886200"/>
-            <a:ext cx="502920" cy="502920"/>
-          </a:xfrm>
-          <a:prstGeom prst="rect">
-            <a:avLst/>
-          </a:prstGeom>
-          <a:noFill/>
-          <a:ln/>
-        </p:spPr>
-        <p:txBody>
-          <a:bodyPr wrap="square" lIns="0" tIns="0" rIns="0" bIns="0" rtlCol="0" anchor="ctr"/>
-          <a:lstStyle/>
-          <a:p>
-            <a:pPr algn="ctr" indent="0" marL="0">
-              <a:buNone/>
-            </a:pPr>
-            <a:r>
-              <a:rPr lang="en-US" sz="1500" b="1" dirty="0">
-                <a:solidFill>
-                  <a:schemeClr val="bg1"/>
-                </a:solidFill>
-              </a:rPr>
-              <a:t>→</a:t>
-            </a:r>
-            <a:endParaRPr lang="en-US" sz="1500" dirty="0"/>
-          </a:p>
-        </p:txBody>
-      </p:sp>
-      <p:sp>
-        <p:nvSpPr>
-          <p:cNvPr id="31" name="Text 29"/>
-          <p:cNvSpPr txBox="1"/>
-          <p:nvPr/>
-        </p:nvSpPr>
-        <p:spPr>
-          <a:xfrm>
-            <a:off x="8961120" y="3931920"/>
-            <a:ext cx="2468880" cy="457200"/>
-          </a:xfrm>
-          <a:prstGeom prst="rect">
-            <a:avLst/>
-          </a:prstGeom>
-          <a:noFill/>
-          <a:ln/>
-        </p:spPr>
-        <p:txBody>
-          <a:bodyPr wrap="square" lIns="0" tIns="0" rIns="0" bIns="0" rtlCol="0" anchor="t"/>
-          <a:lstStyle/>
-          <a:p>
-            <a:pPr indent="0" marL="0">
-              <a:buNone/>
-            </a:pPr>
-            <a:r>
-              <a:rPr lang="en-US" sz="1600" b="1" dirty="0">
-                <a:solidFill>
-                  <a:schemeClr val="tx2"/>
-                </a:solidFill>
-                <a:latin typeface="Calibri" pitchFamily="34" charset="0"/>
-                <a:ea typeface="Calibri" pitchFamily="34" charset="-122"/>
-                <a:cs typeface="Calibri" pitchFamily="34" charset="-120"/>
-              </a:rPr>
-              <a:t>Weniger auf einmal</a:t>
-            </a:r>
-            <a:endParaRPr lang="en-US" sz="1600" dirty="0"/>
-          </a:p>
-        </p:txBody>
-      </p:sp>
-      <p:sp>
-        <p:nvSpPr>
-          <p:cNvPr id="32" name="Text 30"/>
-          <p:cNvSpPr txBox="1"/>
-          <p:nvPr/>
-        </p:nvSpPr>
-        <p:spPr>
-          <a:xfrm>
-            <a:off x="8275320" y="4526280"/>
-            <a:ext cx="3108960" cy="1051560"/>
-          </a:xfrm>
-          <a:prstGeom prst="rect">
-            <a:avLst/>
-          </a:prstGeom>
-          <a:noFill/>
-          <a:ln/>
-        </p:spPr>
-        <p:txBody>
-          <a:bodyPr wrap="square" lIns="0" tIns="0" rIns="0" bIns="0" rtlCol="0" anchor="t"/>
-          <a:lstStyle/>
-          <a:p>
-            <a:pPr indent="0" marL="0">
-              <a:buNone/>
-            </a:pPr>
-            <a:r>
-              <a:rPr lang="en-US" sz="1400" dirty="0">
-                <a:solidFill>
-                  <a:schemeClr val="tx1"/>
-                </a:solidFill>
-                <a:latin typeface="Calibri" pitchFamily="34" charset="0"/>
-                <a:ea typeface="Calibri" pitchFamily="34" charset="-122"/>
-                <a:cs typeface="Calibri" pitchFamily="34" charset="-120"/>
-              </a:rPr>
-              <a:t>Erst ein Tier fertig, dann das zweite; weniger Ideen parallel</a:t>
-            </a:r>
-            <a:endParaRPr lang="en-US" sz="1400" dirty="0"/>
-          </a:p>
-        </p:txBody>
-      </p:sp>
-      <p:sp>
-        <p:nvSpPr>
-          <p:cNvPr id="25" name="Slide Number Placeholder 0"/>
-          <p:cNvSpPr>
-            <a:spLocks noGrp="1"/>
-          </p:cNvSpPr>
-          <p:nvPr>
-            <p:ph type="sldNum" sz="quarter" idx="4294967295"/>
-          </p:nvPr>
-        </p:nvSpPr>
-        <p:spPr>
-          <a:xfrm>
-            <a:off x="11247120" y="6400800"/>
-            <a:ext cx="548640" cy="274320"/>
-          </a:xfrm>
-          <a:prstGeom prst="rect">
-            <a:avLst/>
-          </a:prstGeom>
-          <a:extLst>
-            <a:ext uri="{C572A759-6A51-4108-AA02-DFA0A04FC94B}">
-              <ma14:wrappingTextBoxFlag xmlns:ma14="http://schemas.microsoft.com/office/mac/drawingml/2011/main" val="0"/>
-            </a:ext>
-          </a:extLst>
-        </p:spPr>
-        <p:txBody>
-          <a:bodyPr/>
-          <a:lstStyle>
-            <a:lvl1pPr>
-              <a:defRPr sz="1000">
-                <a:solidFill>
-                  <a:srgbClr val="8FA89B"/>
-                </a:solidFill>
-              </a:defRPr>
-            </a:lvl1pPr>
-          </a:lstStyle>
-          <a:p>
-            <a:pPr algn="l"/>
-            <a:fld id="{F7021451-1387-4CA6-816F-3879F97B5CBC}" type="slidenum">
-              <a:rPr b="0" lang="en-US"/>
               <a:t>9</a:t>
             </a:fld>
             <a:endParaRPr lang="en-US"/>

</xml_diff>

<commit_message>
10-minute deck: DC results slide in the same style as the Myrranox (physics body, key figures, path to the big-cat gait)
Co-Authored-By: Claude Opus 5.5 <noreply@anthropic.com>
</commit_message>
<xml_diff>
--- a/docs/presentation/Endemic_Creatures_RL_10min.pptx
+++ b/docs/presentation/Endemic_Creatures_RL_10min.pptx
@@ -117,26 +117,26 @@
   <p:extLst>
     <p:ext uri="{521415D9-36F7-43E2-AB2F-B90AF26B5E84}">
       <p14:sectionLst xmlns:p14="http://schemas.microsoft.com/office/powerpoint/2010/main">
-        <p14:section name="Einstieg" id="{d1167562-039a-5936-e233-6be23282bad2}">
+        <p14:section name="Einstieg" id="{e0a2fda9-4186-dc32-eb68-c9e665badc98}">
           <p14:sldIdLst>
             <p14:sldId id="256"/>
             <p14:sldId id="257"/>
           </p14:sldIdLst>
         </p14:section>
-        <p14:section name="Vorgehen" id="{2b8000d8-c156-c0fd-7e09-89f6359b19e7}">
+        <p14:section name="Vorgehen" id="{1091f5d6-391d-6e05-da3d-b9068674ce7a}">
           <p14:sldIdLst>
             <p14:sldId id="258"/>
             <p14:sldId id="259"/>
           </p14:sldIdLst>
         </p14:section>
-        <p14:section name="Lernen" id="{42e867a3-a040-f4ee-0abe-86f35587cca0}">
+        <p14:section name="Lernen" id="{b910f83e-f183-3814-b508-ea952a160ad6}">
           <p14:sldIdLst>
             <p14:sldId id="260"/>
             <p14:sldId id="261"/>
             <p14:sldId id="262"/>
           </p14:sldIdLst>
         </p14:section>
-        <p14:section name="Rückblick" id="{74488e48-7b7b-7685-6862-892f2f4cb3cb}">
+        <p14:section name="Rückblick" id="{8d7f784a-80d8-43ac-72b0-4459f8a79792}">
           <p14:sldIdLst>
             <p14:sldId id="263"/>
             <p14:sldId id="264"/>
@@ -1164,7 +1164,7 @@
           <a:p>
             <a:r>
               <a:rPr lang="en-US" dirty="0"/>
-              <a:t>ca. 40 s. Kurz die Zahlen; Bild: alter DC-Physik-Körper (Blöcke) gegen den neuen aus 218 Teilen.</a:t>
+              <a:t>ca. 45 s. Der DC brauchte zwölf Versionen: Schlupflöcher wie Handstand und Planke, dann der Körper aus 218 Teilen nach dem echten Modell und der Wolf als Vorbild. Am Ende flüssiger Gang, Sprint bis 4 m/s und sicheres Bremsen.</a:t>
             </a:r>
             <a:endParaRPr lang="en-US" dirty="0"/>
           </a:p>
@@ -7342,26 +7342,89 @@
                 <a:ea typeface="Cambria" pitchFamily="34" charset="-122"/>
                 <a:cs typeface="Cambria" pitchFamily="34" charset="-120"/>
               </a:rPr>
-              <a:t>Was ist herausgekommen? Überblick und DC</a:t>
+              <a:t>Was ist herausgekommen? DC</a:t>
             </a:r>
             <a:endParaRPr lang="en-US" sz="3200" dirty="0"/>
           </a:p>
         </p:txBody>
       </p:sp>
-      <p:sp>
-        <p:nvSpPr>
-          <p:cNvPr id="3" name="stat0"/>
+      <p:pic>
+        <p:nvPicPr>
+          <p:cNvPr id="3" name="dc_body" descr="C:\Users\thoma\PycharmProjects\Reinforcement_Learning_Creature\docs\presentation\src\dc_physics_body_v12_deck.jpg">    </p:cNvPr>
+          <p:cNvPicPr>
+            <a:picLocks noChangeAspect="1"/>
+          </p:cNvPicPr>
+          <p:nvPr/>
+        </p:nvPicPr>
+        <p:blipFill>
+          <a:blip r:embed="rId1"/>
+          <a:stretch>
+            <a:fillRect/>
+          </a:stretch>
+        </p:blipFill>
+        <p:spPr>
+          <a:xfrm>
+            <a:off x="548640" y="1325880"/>
+            <a:ext cx="5120640" cy="4389120"/>
+          </a:xfrm>
+          <a:prstGeom prst="rect">
+            <a:avLst/>
+          </a:prstGeom>
+        </p:spPr>
+      </p:pic>
+      <p:sp>
+        <p:nvSpPr>
+          <p:cNvPr id="4" name="Text 1"/>
+          <p:cNvSpPr txBox="1"/>
+          <p:nvPr/>
+        </p:nvSpPr>
+        <p:spPr>
+          <a:xfrm>
+            <a:off x="548640" y="5760720"/>
+            <a:ext cx="5120640" cy="365760"/>
+          </a:xfrm>
+          <a:prstGeom prst="rect">
+            <a:avLst/>
+          </a:prstGeom>
+          <a:noFill/>
+          <a:ln/>
+        </p:spPr>
+        <p:txBody>
+          <a:bodyPr wrap="square" lIns="0" tIns="0" rIns="0" bIns="0" rtlCol="0" anchor="t"/>
+          <a:lstStyle/>
+          <a:p>
+            <a:pPr indent="0" marL="0">
+              <a:buNone/>
+            </a:pPr>
+            <a:r>
+              <a:rPr lang="en-US" sz="1300" i="1" dirty="0">
+                <a:solidFill>
+                  <a:schemeClr val="tx2"/>
+                </a:solidFill>
+                <a:latin typeface="Calibri" pitchFamily="34" charset="0"/>
+                <a:ea typeface="Calibri" pitchFamily="34" charset="-122"/>
+                <a:cs typeface="Calibri" pitchFamily="34" charset="-120"/>
+              </a:rPr>
+              <a:t>Physik-Körper aus dem Detail-Modell: 218 Teile, mit Stacheln</a:t>
+            </a:r>
+            <a:endParaRPr lang="en-US" sz="1300" dirty="0"/>
+          </a:p>
+        </p:txBody>
+      </p:sp>
+      <p:sp>
+        <p:nvSpPr>
+          <p:cNvPr id="5" name="dc_stat0"/>
           <p:cNvSpPr/>
           <p:nvPr/>
         </p:nvSpPr>
         <p:spPr>
           <a:xfrm>
-            <a:off x="548640" y="1325880"/>
-            <a:ext cx="1783080" cy="1737360"/>
+            <a:off x="5989320" y="1325880"/>
+            <a:ext cx="1298448" cy="1600200"/>
           </a:xfrm>
           <a:prstGeom prst="roundRect">
             <a:avLst>
-              <a:gd name="adj" fmla="val 4211"/>
+              <a:gd name="adj" fmla="val 5634"/>
             </a:avLst>
           </a:prstGeom>
           <a:solidFill>
@@ -7377,14 +7440,14 @@
       </p:sp>
       <p:sp>
         <p:nvSpPr>
-          <p:cNvPr id="4" name="Text 2"/>
+          <p:cNvPr id="6" name="Text 3"/>
           <p:cNvSpPr txBox="1"/>
           <p:nvPr/>
         </p:nvSpPr>
         <p:spPr>
           <a:xfrm>
-            <a:off x="685800" y="1417320"/>
-            <a:ext cx="1554480" cy="731520"/>
+            <a:off x="6035040" y="1463040"/>
+            <a:ext cx="1207008" cy="502920"/>
           </a:xfrm>
           <a:prstGeom prst="rect">
             <a:avLst/>
@@ -7400,30 +7463,30 @@
               <a:buNone/>
             </a:pPr>
             <a:r>
-              <a:rPr lang="en-US" sz="3400" b="1" dirty="0">
-                <a:solidFill>
-                  <a:schemeClr val="accent1"/>
+              <a:rPr lang="en-US" sz="1900" b="1" dirty="0">
+                <a:solidFill>
+                  <a:schemeClr val="accent4"/>
                 </a:solidFill>
                 <a:latin typeface="Cambria" pitchFamily="34" charset="0"/>
                 <a:ea typeface="Cambria" pitchFamily="34" charset="-122"/>
                 <a:cs typeface="Cambria" pitchFamily="34" charset="-120"/>
               </a:rPr>
-              <a:t>12</a:t>
-            </a:r>
-            <a:endParaRPr lang="en-US" sz="3400" dirty="0"/>
-          </a:p>
-        </p:txBody>
-      </p:sp>
-      <p:sp>
-        <p:nvSpPr>
-          <p:cNvPr id="5" name="Text 3"/>
+              <a:t>0,59 m/s</a:t>
+            </a:r>
+            <a:endParaRPr lang="en-US" sz="1900" dirty="0"/>
+          </a:p>
+        </p:txBody>
+      </p:sp>
+      <p:sp>
+        <p:nvSpPr>
+          <p:cNvPr id="7" name="Text 4"/>
           <p:cNvSpPr txBox="1"/>
           <p:nvPr/>
         </p:nvSpPr>
         <p:spPr>
           <a:xfrm>
-            <a:off x="640080" y="2240280"/>
-            <a:ext cx="1600200" cy="731520"/>
+            <a:off x="6035040" y="2057400"/>
+            <a:ext cx="1207008" cy="777240"/>
           </a:xfrm>
           <a:prstGeom prst="rect">
             <a:avLst/>
@@ -7439,7 +7502,7 @@
               <a:buNone/>
             </a:pPr>
             <a:r>
-              <a:rPr lang="en-US" sz="1300" dirty="0">
+              <a:rPr lang="en-US" sz="1200" dirty="0">
                 <a:solidFill>
                   <a:schemeClr val="tx2"/>
                 </a:solidFill>
@@ -7447,16 +7510,16 @@
                 <a:ea typeface="Calibri" pitchFamily="34" charset="-122"/>
                 <a:cs typeface="Calibri" pitchFamily="34" charset="-120"/>
               </a:rPr>
-              <a:t>Versionen des</a:t>
-            </a:r>
-            <a:endParaRPr lang="en-US" sz="1300" dirty="0"/>
+              <a:t>Gehen</a:t>
+            </a:r>
+            <a:endParaRPr lang="en-US" sz="1200" dirty="0"/>
           </a:p>
           <a:p>
             <a:pPr algn="ctr" indent="0" marL="0">
               <a:buNone/>
             </a:pPr>
             <a:r>
-              <a:rPr lang="en-US" sz="1300" dirty="0">
+              <a:rPr lang="en-US" sz="1200" dirty="0">
                 <a:solidFill>
                   <a:schemeClr val="tx2"/>
                 </a:solidFill>
@@ -7464,26 +7527,26 @@
                 <a:ea typeface="Calibri" pitchFamily="34" charset="-122"/>
                 <a:cs typeface="Calibri" pitchFamily="34" charset="-120"/>
               </a:rPr>
-              <a:t>Laufgehirns</a:t>
-            </a:r>
-            <a:endParaRPr lang="en-US" sz="1300" dirty="0"/>
-          </a:p>
-        </p:txBody>
-      </p:sp>
-      <p:sp>
-        <p:nvSpPr>
-          <p:cNvPr id="6" name="stat1"/>
+              <a:t>(Befehl 0,6)</a:t>
+            </a:r>
+            <a:endParaRPr lang="en-US" sz="1200" dirty="0"/>
+          </a:p>
+        </p:txBody>
+      </p:sp>
+      <p:sp>
+        <p:nvSpPr>
+          <p:cNvPr id="8" name="dc_stat1"/>
           <p:cNvSpPr/>
           <p:nvPr/>
         </p:nvSpPr>
         <p:spPr>
           <a:xfrm>
-            <a:off x="2468880" y="1325880"/>
-            <a:ext cx="1783080" cy="1737360"/>
+            <a:off x="7406640" y="1325880"/>
+            <a:ext cx="1298448" cy="1600200"/>
           </a:xfrm>
           <a:prstGeom prst="roundRect">
             <a:avLst>
-              <a:gd name="adj" fmla="val 4211"/>
+              <a:gd name="adj" fmla="val 5634"/>
             </a:avLst>
           </a:prstGeom>
           <a:solidFill>
@@ -7499,14 +7562,14 @@
       </p:sp>
       <p:sp>
         <p:nvSpPr>
-          <p:cNvPr id="7" name="Text 5"/>
+          <p:cNvPr id="9" name="Text 6"/>
           <p:cNvSpPr txBox="1"/>
           <p:nvPr/>
         </p:nvSpPr>
         <p:spPr>
           <a:xfrm>
-            <a:off x="2606040" y="1417320"/>
-            <a:ext cx="1554480" cy="731520"/>
+            <a:off x="7452360" y="1463040"/>
+            <a:ext cx="1207008" cy="502920"/>
           </a:xfrm>
           <a:prstGeom prst="rect">
             <a:avLst/>
@@ -7522,30 +7585,30 @@
               <a:buNone/>
             </a:pPr>
             <a:r>
-              <a:rPr lang="en-US" sz="3400" b="1" dirty="0">
-                <a:solidFill>
-                  <a:schemeClr val="accent2"/>
+              <a:rPr lang="en-US" sz="1900" b="1" dirty="0">
+                <a:solidFill>
+                  <a:schemeClr val="accent1"/>
                 </a:solidFill>
                 <a:latin typeface="Cambria" pitchFamily="34" charset="0"/>
                 <a:ea typeface="Cambria" pitchFamily="34" charset="-122"/>
                 <a:cs typeface="Cambria" pitchFamily="34" charset="-120"/>
               </a:rPr>
-              <a:t>≈ 50</a:t>
-            </a:r>
-            <a:endParaRPr lang="en-US" sz="3400" dirty="0"/>
-          </a:p>
-        </p:txBody>
-      </p:sp>
-      <p:sp>
-        <p:nvSpPr>
-          <p:cNvPr id="8" name="Text 6"/>
+              <a:t>4,1 m/s</a:t>
+            </a:r>
+            <a:endParaRPr lang="en-US" sz="1900" dirty="0"/>
+          </a:p>
+        </p:txBody>
+      </p:sp>
+      <p:sp>
+        <p:nvSpPr>
+          <p:cNvPr id="10" name="Text 7"/>
           <p:cNvSpPr txBox="1"/>
           <p:nvPr/>
         </p:nvSpPr>
         <p:spPr>
           <a:xfrm>
-            <a:off x="2560320" y="2240280"/>
-            <a:ext cx="1600200" cy="731520"/>
+            <a:off x="7452360" y="2057400"/>
+            <a:ext cx="1207008" cy="777240"/>
           </a:xfrm>
           <a:prstGeom prst="rect">
             <a:avLst/>
@@ -7561,7 +7624,7 @@
               <a:buNone/>
             </a:pPr>
             <a:r>
-              <a:rPr lang="en-US" sz="1300" dirty="0">
+              <a:rPr lang="en-US" sz="1200" dirty="0">
                 <a:solidFill>
                   <a:schemeClr val="tx2"/>
                 </a:solidFill>
@@ -7569,16 +7632,16 @@
                 <a:ea typeface="Calibri" pitchFamily="34" charset="-122"/>
                 <a:cs typeface="Calibri" pitchFamily="34" charset="-120"/>
               </a:rPr>
-              <a:t>trainierte</a:t>
-            </a:r>
-            <a:endParaRPr lang="en-US" sz="1300" dirty="0"/>
+              <a:t>Sprint-</a:t>
+            </a:r>
+            <a:endParaRPr lang="en-US" sz="1200" dirty="0"/>
           </a:p>
           <a:p>
             <a:pPr algn="ctr" indent="0" marL="0">
               <a:buNone/>
             </a:pPr>
             <a:r>
-              <a:rPr lang="en-US" sz="1300" dirty="0">
+              <a:rPr lang="en-US" sz="1200" dirty="0">
                 <a:solidFill>
                   <a:schemeClr val="tx2"/>
                 </a:solidFill>
@@ -7586,26 +7649,26 @@
                 <a:ea typeface="Calibri" pitchFamily="34" charset="-122"/>
                 <a:cs typeface="Calibri" pitchFamily="34" charset="-120"/>
               </a:rPr>
-              <a:t>Gehirne</a:t>
-            </a:r>
-            <a:endParaRPr lang="en-US" sz="1300" dirty="0"/>
-          </a:p>
-        </p:txBody>
-      </p:sp>
-      <p:sp>
-        <p:nvSpPr>
-          <p:cNvPr id="9" name="stat2"/>
+              <a:t>Spitze</a:t>
+            </a:r>
+            <a:endParaRPr lang="en-US" sz="1200" dirty="0"/>
+          </a:p>
+        </p:txBody>
+      </p:sp>
+      <p:sp>
+        <p:nvSpPr>
+          <p:cNvPr id="11" name="dc_stat2"/>
           <p:cNvSpPr/>
           <p:nvPr/>
         </p:nvSpPr>
         <p:spPr>
           <a:xfrm>
-            <a:off x="4389120" y="1325880"/>
-            <a:ext cx="1783080" cy="1737360"/>
+            <a:off x="8823960" y="1325880"/>
+            <a:ext cx="1298448" cy="1600200"/>
           </a:xfrm>
           <a:prstGeom prst="roundRect">
             <a:avLst>
-              <a:gd name="adj" fmla="val 4211"/>
+              <a:gd name="adj" fmla="val 5634"/>
             </a:avLst>
           </a:prstGeom>
           <a:solidFill>
@@ -7621,14 +7684,14 @@
       </p:sp>
       <p:sp>
         <p:nvSpPr>
-          <p:cNvPr id="10" name="Text 8"/>
+          <p:cNvPr id="12" name="Text 9"/>
           <p:cNvSpPr txBox="1"/>
           <p:nvPr/>
         </p:nvSpPr>
         <p:spPr>
           <a:xfrm>
-            <a:off x="4526280" y="1417320"/>
-            <a:ext cx="1554480" cy="731520"/>
+            <a:off x="8869680" y="1463040"/>
+            <a:ext cx="1207008" cy="502920"/>
           </a:xfrm>
           <a:prstGeom prst="rect">
             <a:avLst/>
@@ -7644,30 +7707,30 @@
               <a:buNone/>
             </a:pPr>
             <a:r>
-              <a:rPr lang="en-US" sz="3400" b="1" dirty="0">
-                <a:solidFill>
-                  <a:schemeClr val="accent1"/>
+              <a:rPr lang="en-US" sz="1900" b="1" dirty="0">
+                <a:solidFill>
+                  <a:schemeClr val="accent4"/>
                 </a:solidFill>
                 <a:latin typeface="Cambria" pitchFamily="34" charset="0"/>
                 <a:ea typeface="Cambria" pitchFamily="34" charset="-122"/>
                 <a:cs typeface="Cambria" pitchFamily="34" charset="-120"/>
               </a:rPr>
-              <a:t>218</a:t>
-            </a:r>
-            <a:endParaRPr lang="en-US" sz="3400" dirty="0"/>
-          </a:p>
-        </p:txBody>
-      </p:sp>
-      <p:sp>
-        <p:nvSpPr>
-          <p:cNvPr id="11" name="Text 9"/>
+              <a:t>±1 %</a:t>
+            </a:r>
+            <a:endParaRPr lang="en-US" sz="1900" dirty="0"/>
+          </a:p>
+        </p:txBody>
+      </p:sp>
+      <p:sp>
+        <p:nvSpPr>
+          <p:cNvPr id="13" name="Text 10"/>
           <p:cNvSpPr txBox="1"/>
           <p:nvPr/>
         </p:nvSpPr>
         <p:spPr>
           <a:xfrm>
-            <a:off x="4480560" y="2240280"/>
-            <a:ext cx="1600200" cy="731520"/>
+            <a:off x="8869680" y="2057400"/>
+            <a:ext cx="1207008" cy="777240"/>
           </a:xfrm>
           <a:prstGeom prst="rect">
             <a:avLst/>
@@ -7683,7 +7746,7 @@
               <a:buNone/>
             </a:pPr>
             <a:r>
-              <a:rPr lang="en-US" sz="1300" dirty="0">
+              <a:rPr lang="en-US" sz="1200" dirty="0">
                 <a:solidFill>
                   <a:schemeClr val="tx2"/>
                 </a:solidFill>
@@ -7691,16 +7754,16 @@
                 <a:ea typeface="Calibri" pitchFamily="34" charset="-122"/>
                 <a:cs typeface="Calibri" pitchFamily="34" charset="-120"/>
               </a:rPr>
-              <a:t>Physik-Teile im</a:t>
-            </a:r>
-            <a:endParaRPr lang="en-US" sz="1300" dirty="0"/>
+              <a:t>Takt-Schwankung</a:t>
+            </a:r>
+            <a:endParaRPr lang="en-US" sz="1200" dirty="0"/>
           </a:p>
           <a:p>
             <a:pPr algn="ctr" indent="0" marL="0">
               <a:buNone/>
             </a:pPr>
             <a:r>
-              <a:rPr lang="en-US" sz="1300" dirty="0">
+              <a:rPr lang="en-US" sz="1200" dirty="0">
                 <a:solidFill>
                   <a:schemeClr val="tx2"/>
                 </a:solidFill>
@@ -7708,1095 +7771,49 @@
                 <a:ea typeface="Calibri" pitchFamily="34" charset="-122"/>
                 <a:cs typeface="Calibri" pitchFamily="34" charset="-120"/>
               </a:rPr>
-              <a:t>DC-Körper</a:t>
-            </a:r>
-            <a:endParaRPr lang="en-US" sz="1300" dirty="0"/>
-          </a:p>
-        </p:txBody>
-      </p:sp>
-      <p:pic>
-        <p:nvPicPr>
-          <p:cNvPr id="12" name="body" descr="C:\Users\thoma\PycharmProjects\Reinforcement_Learning_Creature\docs\figures\dc_physics_body_v11_vs_v12.jpg">    </p:cNvPr>
-          <p:cNvPicPr>
-            <a:picLocks noChangeAspect="1"/>
-          </p:cNvPicPr>
-          <p:nvPr/>
-        </p:nvPicPr>
-        <p:blipFill>
-          <a:blip r:embed="rId1"/>
-          <a:srcRect l="0" r="0" t="0" b="0"/>
-          <a:stretch/>
-        </p:blipFill>
-        <p:spPr>
-          <a:xfrm>
-            <a:off x="548640" y="3246120"/>
-            <a:ext cx="5577840" cy="2834640"/>
-          </a:xfrm>
-          <a:prstGeom prst="rect">
-            <a:avLst/>
-          </a:prstGeom>
-        </p:spPr>
-      </p:pic>
-      <p:graphicFrame>
-        <p:nvGraphicFramePr>
-          <p:cNvPr id="7" name="Table 0"/>
-          <p:cNvGraphicFramePr>
-            <a:graphicFrameLocks noGrp="1"/>
-          </p:cNvGraphicFramePr>
-          <p:nvPr>
-            <p:extLst>
-              <p:ext uri="{D42A27DB-BD31-4B8C-83A1-F6EECF244321}">
-                <p14:modId xmlns:p14="http://schemas.microsoft.com/office/powerpoint/2010/main" val="1579011935"/>
-              </p:ext>
-            </p:extLst>
-          </p:nvPr>
-        </p:nvGraphicFramePr>
-        <p:xfrm>
-          <a:off x="6400800" y="1325880"/>
-          <a:ext cx="5212080" cy="914400"/>
-        </p:xfrm>
-        <a:graphic>
-          <a:graphicData uri="http://schemas.openxmlformats.org/drawingml/2006/table">
-            <a:tbl>
-              <a:tblPr/>
-              <a:tblGrid>
-                <a:gridCol w="1463040"/>
-                <a:gridCol w="1874520"/>
-                <a:gridCol w="1874520"/>
-              </a:tblGrid>
-              <a:tr h="502920">
-                <a:tc>
-                  <a:txBody>
-                    <a:bodyPr/>
-                    <a:lstStyle/>
-                    <a:p>
-                      <a:pPr indent="0" marL="0">
-                        <a:buNone/>
-                      </a:pPr>
-                      <a:endParaRPr lang="en-US" sz="1400" dirty="0">
-                        <a:latin typeface="Calibri" charset="0"/>
-                        <a:ea typeface="Calibri" charset="0"/>
-                        <a:cs typeface="Calibri" charset="0"/>
-                      </a:endParaRPr>
-                    </a:p>
-                  </a:txBody>
-                  <a:tcPr marL="109728" marR="109728" marT="45720" marB="45720" anchor="ctr">
-                    <a:lnL w="6350" cap="flat" cmpd="sng" algn="ctr">
-                      <a:solidFill>
-                        <a:srgbClr val="D5DDD8"/>
-                      </a:solidFill>
-                      <a:prstDash val="solid"/>
-                      <a:round/>
-                      <a:headEnd type="none" w="med" len="med"/>
-                      <a:tailEnd type="none" w="med" len="med"/>
-                    </a:lnL>
-                    <a:lnR w="6350" cap="flat" cmpd="sng" algn="ctr">
-                      <a:solidFill>
-                        <a:srgbClr val="D5DDD8"/>
-                      </a:solidFill>
-                      <a:prstDash val="solid"/>
-                      <a:round/>
-                      <a:headEnd type="none" w="med" len="med"/>
-                      <a:tailEnd type="none" w="med" len="med"/>
-                    </a:lnR>
-                    <a:lnT w="6350" cap="flat" cmpd="sng" algn="ctr">
-                      <a:solidFill>
-                        <a:srgbClr val="D5DDD8"/>
-                      </a:solidFill>
-                      <a:prstDash val="solid"/>
-                      <a:round/>
-                      <a:headEnd type="none" w="med" len="med"/>
-                      <a:tailEnd type="none" w="med" len="med"/>
-                    </a:lnT>
-                    <a:lnB w="6350" cap="flat" cmpd="sng" algn="ctr">
-                      <a:solidFill>
-                        <a:srgbClr val="D5DDD8"/>
-                      </a:solidFill>
-                      <a:prstDash val="solid"/>
-                      <a:round/>
-                      <a:headEnd type="none" w="med" len="med"/>
-                      <a:tailEnd type="none" w="med" len="med"/>
-                    </a:lnB>
-                    <a:solidFill>
-                      <a:srgbClr val="1F3A35"/>
-                    </a:solidFill>
-                  </a:tcPr>
-                </a:tc>
-                <a:tc>
-                  <a:txBody>
-                    <a:bodyPr/>
-                    <a:lstStyle/>
-                    <a:p>
-                      <a:pPr indent="0" marL="0">
-                        <a:buNone/>
-                      </a:pPr>
-                      <a:r>
-                        <a:rPr lang="en-US" sz="1400" b="1" dirty="0">
-                          <a:solidFill>
-                            <a:srgbClr val="FFFFFF"/>
-                          </a:solidFill>
-                          <a:latin typeface="Calibri" pitchFamily="34" charset="0"/>
-                          <a:ea typeface="Calibri" pitchFamily="34" charset="-122"/>
-                          <a:cs typeface="Calibri" pitchFamily="34" charset="-120"/>
-                        </a:rPr>
-                        <a:t>Myrranox v10</a:t>
-                      </a:r>
-                      <a:endParaRPr lang="en-US" sz="1400" dirty="0">
-                        <a:latin typeface="Calibri" charset="0"/>
-                        <a:ea typeface="Calibri" charset="0"/>
-                        <a:cs typeface="Calibri" charset="0"/>
-                      </a:endParaRPr>
-                    </a:p>
-                  </a:txBody>
-                  <a:tcPr marL="109728" marR="109728" marT="45720" marB="45720" anchor="ctr">
-                    <a:lnL w="6350" cap="flat" cmpd="sng" algn="ctr">
-                      <a:solidFill>
-                        <a:srgbClr val="D5DDD8"/>
-                      </a:solidFill>
-                      <a:prstDash val="solid"/>
-                      <a:round/>
-                      <a:headEnd type="none" w="med" len="med"/>
-                      <a:tailEnd type="none" w="med" len="med"/>
-                    </a:lnL>
-                    <a:lnR w="6350" cap="flat" cmpd="sng" algn="ctr">
-                      <a:solidFill>
-                        <a:srgbClr val="D5DDD8"/>
-                      </a:solidFill>
-                      <a:prstDash val="solid"/>
-                      <a:round/>
-                      <a:headEnd type="none" w="med" len="med"/>
-                      <a:tailEnd type="none" w="med" len="med"/>
-                    </a:lnR>
-                    <a:lnT w="6350" cap="flat" cmpd="sng" algn="ctr">
-                      <a:solidFill>
-                        <a:srgbClr val="D5DDD8"/>
-                      </a:solidFill>
-                      <a:prstDash val="solid"/>
-                      <a:round/>
-                      <a:headEnd type="none" w="med" len="med"/>
-                      <a:tailEnd type="none" w="med" len="med"/>
-                    </a:lnT>
-                    <a:lnB w="6350" cap="flat" cmpd="sng" algn="ctr">
-                      <a:solidFill>
-                        <a:srgbClr val="D5DDD8"/>
-                      </a:solidFill>
-                      <a:prstDash val="solid"/>
-                      <a:round/>
-                      <a:headEnd type="none" w="med" len="med"/>
-                      <a:tailEnd type="none" w="med" len="med"/>
-                    </a:lnB>
-                    <a:solidFill>
-                      <a:srgbClr val="1F3A35"/>
-                    </a:solidFill>
-                  </a:tcPr>
-                </a:tc>
-                <a:tc>
-                  <a:txBody>
-                    <a:bodyPr/>
-                    <a:lstStyle/>
-                    <a:p>
-                      <a:pPr indent="0" marL="0">
-                        <a:buNone/>
-                      </a:pPr>
-                      <a:r>
-                        <a:rPr lang="en-US" sz="1400" b="1" dirty="0">
-                          <a:solidFill>
-                            <a:srgbClr val="FFFFFF"/>
-                          </a:solidFill>
-                          <a:latin typeface="Calibri" pitchFamily="34" charset="0"/>
-                          <a:ea typeface="Calibri" pitchFamily="34" charset="-122"/>
-                          <a:cs typeface="Calibri" pitchFamily="34" charset="-120"/>
-                        </a:rPr>
-                        <a:t>DC v12z</a:t>
-                      </a:r>
-                      <a:endParaRPr lang="en-US" sz="1400" dirty="0">
-                        <a:latin typeface="Calibri" charset="0"/>
-                        <a:ea typeface="Calibri" charset="0"/>
-                        <a:cs typeface="Calibri" charset="0"/>
-                      </a:endParaRPr>
-                    </a:p>
-                  </a:txBody>
-                  <a:tcPr marL="109728" marR="109728" marT="45720" marB="45720" anchor="ctr">
-                    <a:lnL w="6350" cap="flat" cmpd="sng" algn="ctr">
-                      <a:solidFill>
-                        <a:srgbClr val="D5DDD8"/>
-                      </a:solidFill>
-                      <a:prstDash val="solid"/>
-                      <a:round/>
-                      <a:headEnd type="none" w="med" len="med"/>
-                      <a:tailEnd type="none" w="med" len="med"/>
-                    </a:lnL>
-                    <a:lnR w="6350" cap="flat" cmpd="sng" algn="ctr">
-                      <a:solidFill>
-                        <a:srgbClr val="D5DDD8"/>
-                      </a:solidFill>
-                      <a:prstDash val="solid"/>
-                      <a:round/>
-                      <a:headEnd type="none" w="med" len="med"/>
-                      <a:tailEnd type="none" w="med" len="med"/>
-                    </a:lnR>
-                    <a:lnT w="6350" cap="flat" cmpd="sng" algn="ctr">
-                      <a:solidFill>
-                        <a:srgbClr val="D5DDD8"/>
-                      </a:solidFill>
-                      <a:prstDash val="solid"/>
-                      <a:round/>
-                      <a:headEnd type="none" w="med" len="med"/>
-                      <a:tailEnd type="none" w="med" len="med"/>
-                    </a:lnT>
-                    <a:lnB w="6350" cap="flat" cmpd="sng" algn="ctr">
-                      <a:solidFill>
-                        <a:srgbClr val="D5DDD8"/>
-                      </a:solidFill>
-                      <a:prstDash val="solid"/>
-                      <a:round/>
-                      <a:headEnd type="none" w="med" len="med"/>
-                      <a:tailEnd type="none" w="med" len="med"/>
-                    </a:lnB>
-                    <a:solidFill>
-                      <a:srgbClr val="1F3A35"/>
-                    </a:solidFill>
-                  </a:tcPr>
-                </a:tc>
-              </a:tr>
-              <a:tr h="502920">
-                <a:tc>
-                  <a:txBody>
-                    <a:bodyPr/>
-                    <a:lstStyle/>
-                    <a:p>
-                      <a:pPr indent="0" marL="0">
-                        <a:buNone/>
-                      </a:pPr>
-                      <a:r>
-                        <a:rPr lang="en-US" sz="1400" dirty="0">
-                          <a:solidFill>
-                            <a:srgbClr val="1C2321"/>
-                          </a:solidFill>
-                          <a:latin typeface="Calibri" pitchFamily="34" charset="0"/>
-                          <a:ea typeface="Calibri" pitchFamily="34" charset="-122"/>
-                          <a:cs typeface="Calibri" pitchFamily="34" charset="-120"/>
-                        </a:rPr>
-                        <a:t>Gehen</a:t>
-                      </a:r>
-                      <a:endParaRPr lang="en-US" sz="1400" dirty="0">
-                        <a:latin typeface="Calibri" charset="0"/>
-                        <a:ea typeface="Calibri" charset="0"/>
-                        <a:cs typeface="Calibri" charset="0"/>
-                      </a:endParaRPr>
-                    </a:p>
-                  </a:txBody>
-                  <a:tcPr marL="109728" marR="109728" marT="45720" marB="45720" anchor="ctr">
-                    <a:lnL w="6350" cap="flat" cmpd="sng" algn="ctr">
-                      <a:solidFill>
-                        <a:srgbClr val="D5DDD8"/>
-                      </a:solidFill>
-                      <a:prstDash val="solid"/>
-                      <a:round/>
-                      <a:headEnd type="none" w="med" len="med"/>
-                      <a:tailEnd type="none" w="med" len="med"/>
-                    </a:lnL>
-                    <a:lnR w="6350" cap="flat" cmpd="sng" algn="ctr">
-                      <a:solidFill>
-                        <a:srgbClr val="D5DDD8"/>
-                      </a:solidFill>
-                      <a:prstDash val="solid"/>
-                      <a:round/>
-                      <a:headEnd type="none" w="med" len="med"/>
-                      <a:tailEnd type="none" w="med" len="med"/>
-                    </a:lnR>
-                    <a:lnT w="6350" cap="flat" cmpd="sng" algn="ctr">
-                      <a:solidFill>
-                        <a:srgbClr val="D5DDD8"/>
-                      </a:solidFill>
-                      <a:prstDash val="solid"/>
-                      <a:round/>
-                      <a:headEnd type="none" w="med" len="med"/>
-                      <a:tailEnd type="none" w="med" len="med"/>
-                    </a:lnT>
-                    <a:lnB w="6350" cap="flat" cmpd="sng" algn="ctr">
-                      <a:solidFill>
-                        <a:srgbClr val="D5DDD8"/>
-                      </a:solidFill>
-                      <a:prstDash val="solid"/>
-                      <a:round/>
-                      <a:headEnd type="none" w="med" len="med"/>
-                      <a:tailEnd type="none" w="med" len="med"/>
-                    </a:lnB>
-                    <a:solidFill>
-                      <a:srgbClr val="FFFFFF"/>
-                    </a:solidFill>
-                  </a:tcPr>
-                </a:tc>
-                <a:tc>
-                  <a:txBody>
-                    <a:bodyPr/>
-                    <a:lstStyle/>
-                    <a:p>
-                      <a:pPr indent="0" marL="0">
-                        <a:buNone/>
-                      </a:pPr>
-                      <a:r>
-                        <a:rPr lang="en-US" sz="1400" dirty="0">
-                          <a:solidFill>
-                            <a:srgbClr val="1C2321"/>
-                          </a:solidFill>
-                          <a:latin typeface="Calibri" pitchFamily="34" charset="0"/>
-                          <a:ea typeface="Calibri" pitchFamily="34" charset="-122"/>
-                          <a:cs typeface="Calibri" pitchFamily="34" charset="-120"/>
-                        </a:rPr>
-                        <a:t>0,52 m/s, Dreifuß</a:t>
-                      </a:r>
-                      <a:endParaRPr lang="en-US" sz="1400" dirty="0">
-                        <a:latin typeface="Calibri" charset="0"/>
-                        <a:ea typeface="Calibri" charset="0"/>
-                        <a:cs typeface="Calibri" charset="0"/>
-                      </a:endParaRPr>
-                    </a:p>
-                  </a:txBody>
-                  <a:tcPr marL="109728" marR="109728" marT="45720" marB="45720" anchor="ctr">
-                    <a:lnL w="6350" cap="flat" cmpd="sng" algn="ctr">
-                      <a:solidFill>
-                        <a:srgbClr val="D5DDD8"/>
-                      </a:solidFill>
-                      <a:prstDash val="solid"/>
-                      <a:round/>
-                      <a:headEnd type="none" w="med" len="med"/>
-                      <a:tailEnd type="none" w="med" len="med"/>
-                    </a:lnL>
-                    <a:lnR w="6350" cap="flat" cmpd="sng" algn="ctr">
-                      <a:solidFill>
-                        <a:srgbClr val="D5DDD8"/>
-                      </a:solidFill>
-                      <a:prstDash val="solid"/>
-                      <a:round/>
-                      <a:headEnd type="none" w="med" len="med"/>
-                      <a:tailEnd type="none" w="med" len="med"/>
-                    </a:lnR>
-                    <a:lnT w="6350" cap="flat" cmpd="sng" algn="ctr">
-                      <a:solidFill>
-                        <a:srgbClr val="D5DDD8"/>
-                      </a:solidFill>
-                      <a:prstDash val="solid"/>
-                      <a:round/>
-                      <a:headEnd type="none" w="med" len="med"/>
-                      <a:tailEnd type="none" w="med" len="med"/>
-                    </a:lnT>
-                    <a:lnB w="6350" cap="flat" cmpd="sng" algn="ctr">
-                      <a:solidFill>
-                        <a:srgbClr val="D5DDD8"/>
-                      </a:solidFill>
-                      <a:prstDash val="solid"/>
-                      <a:round/>
-                      <a:headEnd type="none" w="med" len="med"/>
-                      <a:tailEnd type="none" w="med" len="med"/>
-                    </a:lnB>
-                    <a:solidFill>
-                      <a:srgbClr val="FFFFFF"/>
-                    </a:solidFill>
-                  </a:tcPr>
-                </a:tc>
-                <a:tc>
-                  <a:txBody>
-                    <a:bodyPr/>
-                    <a:lstStyle/>
-                    <a:p>
-                      <a:pPr indent="0" marL="0">
-                        <a:buNone/>
-                      </a:pPr>
-                      <a:r>
-                        <a:rPr lang="en-US" sz="1400" dirty="0">
-                          <a:solidFill>
-                            <a:srgbClr val="1C2321"/>
-                          </a:solidFill>
-                          <a:latin typeface="Calibri" pitchFamily="34" charset="0"/>
-                          <a:ea typeface="Calibri" pitchFamily="34" charset="-122"/>
-                          <a:cs typeface="Calibri" pitchFamily="34" charset="-120"/>
-                        </a:rPr>
-                        <a:t>0,59 m/s, flüssig</a:t>
-                      </a:r>
-                      <a:endParaRPr lang="en-US" sz="1400" dirty="0">
-                        <a:latin typeface="Calibri" charset="0"/>
-                        <a:ea typeface="Calibri" charset="0"/>
-                        <a:cs typeface="Calibri" charset="0"/>
-                      </a:endParaRPr>
-                    </a:p>
-                  </a:txBody>
-                  <a:tcPr marL="109728" marR="109728" marT="45720" marB="45720" anchor="ctr">
-                    <a:lnL w="6350" cap="flat" cmpd="sng" algn="ctr">
-                      <a:solidFill>
-                        <a:srgbClr val="D5DDD8"/>
-                      </a:solidFill>
-                      <a:prstDash val="solid"/>
-                      <a:round/>
-                      <a:headEnd type="none" w="med" len="med"/>
-                      <a:tailEnd type="none" w="med" len="med"/>
-                    </a:lnL>
-                    <a:lnR w="6350" cap="flat" cmpd="sng" algn="ctr">
-                      <a:solidFill>
-                        <a:srgbClr val="D5DDD8"/>
-                      </a:solidFill>
-                      <a:prstDash val="solid"/>
-                      <a:round/>
-                      <a:headEnd type="none" w="med" len="med"/>
-                      <a:tailEnd type="none" w="med" len="med"/>
-                    </a:lnR>
-                    <a:lnT w="6350" cap="flat" cmpd="sng" algn="ctr">
-                      <a:solidFill>
-                        <a:srgbClr val="D5DDD8"/>
-                      </a:solidFill>
-                      <a:prstDash val="solid"/>
-                      <a:round/>
-                      <a:headEnd type="none" w="med" len="med"/>
-                      <a:tailEnd type="none" w="med" len="med"/>
-                    </a:lnT>
-                    <a:lnB w="6350" cap="flat" cmpd="sng" algn="ctr">
-                      <a:solidFill>
-                        <a:srgbClr val="D5DDD8"/>
-                      </a:solidFill>
-                      <a:prstDash val="solid"/>
-                      <a:round/>
-                      <a:headEnd type="none" w="med" len="med"/>
-                      <a:tailEnd type="none" w="med" len="med"/>
-                    </a:lnB>
-                    <a:solidFill>
-                      <a:srgbClr val="FFFFFF"/>
-                    </a:solidFill>
-                  </a:tcPr>
-                </a:tc>
-              </a:tr>
-              <a:tr h="502920">
-                <a:tc>
-                  <a:txBody>
-                    <a:bodyPr/>
-                    <a:lstStyle/>
-                    <a:p>
-                      <a:pPr indent="0" marL="0">
-                        <a:buNone/>
-                      </a:pPr>
-                      <a:r>
-                        <a:rPr lang="en-US" sz="1400" dirty="0">
-                          <a:solidFill>
-                            <a:srgbClr val="1C2321"/>
-                          </a:solidFill>
-                          <a:latin typeface="Calibri" pitchFamily="34" charset="0"/>
-                          <a:ea typeface="Calibri" pitchFamily="34" charset="-122"/>
-                          <a:cs typeface="Calibri" pitchFamily="34" charset="-120"/>
-                        </a:rPr>
-                        <a:t>Vollgas</a:t>
-                      </a:r>
-                      <a:endParaRPr lang="en-US" sz="1400" dirty="0">
-                        <a:latin typeface="Calibri" charset="0"/>
-                        <a:ea typeface="Calibri" charset="0"/>
-                        <a:cs typeface="Calibri" charset="0"/>
-                      </a:endParaRPr>
-                    </a:p>
-                  </a:txBody>
-                  <a:tcPr marL="109728" marR="109728" marT="45720" marB="45720" anchor="ctr">
-                    <a:lnL w="6350" cap="flat" cmpd="sng" algn="ctr">
-                      <a:solidFill>
-                        <a:srgbClr val="D5DDD8"/>
-                      </a:solidFill>
-                      <a:prstDash val="solid"/>
-                      <a:round/>
-                      <a:headEnd type="none" w="med" len="med"/>
-                      <a:tailEnd type="none" w="med" len="med"/>
-                    </a:lnL>
-                    <a:lnR w="6350" cap="flat" cmpd="sng" algn="ctr">
-                      <a:solidFill>
-                        <a:srgbClr val="D5DDD8"/>
-                      </a:solidFill>
-                      <a:prstDash val="solid"/>
-                      <a:round/>
-                      <a:headEnd type="none" w="med" len="med"/>
-                      <a:tailEnd type="none" w="med" len="med"/>
-                    </a:lnR>
-                    <a:lnT w="6350" cap="flat" cmpd="sng" algn="ctr">
-                      <a:solidFill>
-                        <a:srgbClr val="D5DDD8"/>
-                      </a:solidFill>
-                      <a:prstDash val="solid"/>
-                      <a:round/>
-                      <a:headEnd type="none" w="med" len="med"/>
-                      <a:tailEnd type="none" w="med" len="med"/>
-                    </a:lnT>
-                    <a:lnB w="6350" cap="flat" cmpd="sng" algn="ctr">
-                      <a:solidFill>
-                        <a:srgbClr val="D5DDD8"/>
-                      </a:solidFill>
-                      <a:prstDash val="solid"/>
-                      <a:round/>
-                      <a:headEnd type="none" w="med" len="med"/>
-                      <a:tailEnd type="none" w="med" len="med"/>
-                    </a:lnB>
-                    <a:solidFill>
-                      <a:srgbClr val="EDF2EF"/>
-                    </a:solidFill>
-                  </a:tcPr>
-                </a:tc>
-                <a:tc>
-                  <a:txBody>
-                    <a:bodyPr/>
-                    <a:lstStyle/>
-                    <a:p>
-                      <a:pPr indent="0" marL="0">
-                        <a:buNone/>
-                      </a:pPr>
-                      <a:r>
-                        <a:rPr lang="en-US" sz="1400" dirty="0">
-                          <a:solidFill>
-                            <a:srgbClr val="1C2321"/>
-                          </a:solidFill>
-                          <a:latin typeface="Calibri" pitchFamily="34" charset="0"/>
-                          <a:ea typeface="Calibri" pitchFamily="34" charset="-122"/>
-                          <a:cs typeface="Calibri" pitchFamily="34" charset="-120"/>
-                        </a:rPr>
-                        <a:t>1,08 m/s</a:t>
-                      </a:r>
-                      <a:endParaRPr lang="en-US" sz="1400" dirty="0">
-                        <a:latin typeface="Calibri" charset="0"/>
-                        <a:ea typeface="Calibri" charset="0"/>
-                        <a:cs typeface="Calibri" charset="0"/>
-                      </a:endParaRPr>
-                    </a:p>
-                  </a:txBody>
-                  <a:tcPr marL="109728" marR="109728" marT="45720" marB="45720" anchor="ctr">
-                    <a:lnL w="6350" cap="flat" cmpd="sng" algn="ctr">
-                      <a:solidFill>
-                        <a:srgbClr val="D5DDD8"/>
-                      </a:solidFill>
-                      <a:prstDash val="solid"/>
-                      <a:round/>
-                      <a:headEnd type="none" w="med" len="med"/>
-                      <a:tailEnd type="none" w="med" len="med"/>
-                    </a:lnL>
-                    <a:lnR w="6350" cap="flat" cmpd="sng" algn="ctr">
-                      <a:solidFill>
-                        <a:srgbClr val="D5DDD8"/>
-                      </a:solidFill>
-                      <a:prstDash val="solid"/>
-                      <a:round/>
-                      <a:headEnd type="none" w="med" len="med"/>
-                      <a:tailEnd type="none" w="med" len="med"/>
-                    </a:lnR>
-                    <a:lnT w="6350" cap="flat" cmpd="sng" algn="ctr">
-                      <a:solidFill>
-                        <a:srgbClr val="D5DDD8"/>
-                      </a:solidFill>
-                      <a:prstDash val="solid"/>
-                      <a:round/>
-                      <a:headEnd type="none" w="med" len="med"/>
-                      <a:tailEnd type="none" w="med" len="med"/>
-                    </a:lnT>
-                    <a:lnB w="6350" cap="flat" cmpd="sng" algn="ctr">
-                      <a:solidFill>
-                        <a:srgbClr val="D5DDD8"/>
-                      </a:solidFill>
-                      <a:prstDash val="solid"/>
-                      <a:round/>
-                      <a:headEnd type="none" w="med" len="med"/>
-                      <a:tailEnd type="none" w="med" len="med"/>
-                    </a:lnB>
-                    <a:solidFill>
-                      <a:srgbClr val="EDF2EF"/>
-                    </a:solidFill>
-                  </a:tcPr>
-                </a:tc>
-                <a:tc>
-                  <a:txBody>
-                    <a:bodyPr/>
-                    <a:lstStyle/>
-                    <a:p>
-                      <a:pPr indent="0" marL="0">
-                        <a:buNone/>
-                      </a:pPr>
-                      <a:r>
-                        <a:rPr lang="en-US" sz="1400" dirty="0">
-                          <a:solidFill>
-                            <a:srgbClr val="1C2321"/>
-                          </a:solidFill>
-                          <a:latin typeface="Calibri" pitchFamily="34" charset="0"/>
-                          <a:ea typeface="Calibri" pitchFamily="34" charset="-122"/>
-                          <a:cs typeface="Calibri" pitchFamily="34" charset="-120"/>
-                        </a:rPr>
-                        <a:t>bis 4,1 m/s Sprint</a:t>
-                      </a:r>
-                      <a:endParaRPr lang="en-US" sz="1400" dirty="0">
-                        <a:latin typeface="Calibri" charset="0"/>
-                        <a:ea typeface="Calibri" charset="0"/>
-                        <a:cs typeface="Calibri" charset="0"/>
-                      </a:endParaRPr>
-                    </a:p>
-                  </a:txBody>
-                  <a:tcPr marL="109728" marR="109728" marT="45720" marB="45720" anchor="ctr">
-                    <a:lnL w="6350" cap="flat" cmpd="sng" algn="ctr">
-                      <a:solidFill>
-                        <a:srgbClr val="D5DDD8"/>
-                      </a:solidFill>
-                      <a:prstDash val="solid"/>
-                      <a:round/>
-                      <a:headEnd type="none" w="med" len="med"/>
-                      <a:tailEnd type="none" w="med" len="med"/>
-                    </a:lnL>
-                    <a:lnR w="6350" cap="flat" cmpd="sng" algn="ctr">
-                      <a:solidFill>
-                        <a:srgbClr val="D5DDD8"/>
-                      </a:solidFill>
-                      <a:prstDash val="solid"/>
-                      <a:round/>
-                      <a:headEnd type="none" w="med" len="med"/>
-                      <a:tailEnd type="none" w="med" len="med"/>
-                    </a:lnR>
-                    <a:lnT w="6350" cap="flat" cmpd="sng" algn="ctr">
-                      <a:solidFill>
-                        <a:srgbClr val="D5DDD8"/>
-                      </a:solidFill>
-                      <a:prstDash val="solid"/>
-                      <a:round/>
-                      <a:headEnd type="none" w="med" len="med"/>
-                      <a:tailEnd type="none" w="med" len="med"/>
-                    </a:lnT>
-                    <a:lnB w="6350" cap="flat" cmpd="sng" algn="ctr">
-                      <a:solidFill>
-                        <a:srgbClr val="D5DDD8"/>
-                      </a:solidFill>
-                      <a:prstDash val="solid"/>
-                      <a:round/>
-                      <a:headEnd type="none" w="med" len="med"/>
-                      <a:tailEnd type="none" w="med" len="med"/>
-                    </a:lnB>
-                    <a:solidFill>
-                      <a:srgbClr val="EDF2EF"/>
-                    </a:solidFill>
-                  </a:tcPr>
-                </a:tc>
-              </a:tr>
-              <a:tr h="502920">
-                <a:tc>
-                  <a:txBody>
-                    <a:bodyPr/>
-                    <a:lstStyle/>
-                    <a:p>
-                      <a:pPr indent="0" marL="0">
-                        <a:buNone/>
-                      </a:pPr>
-                      <a:r>
-                        <a:rPr lang="en-US" sz="1400" dirty="0">
-                          <a:solidFill>
-                            <a:srgbClr val="1C2321"/>
-                          </a:solidFill>
-                          <a:latin typeface="Calibri" pitchFamily="34" charset="0"/>
-                          <a:ea typeface="Calibri" pitchFamily="34" charset="-122"/>
-                          <a:cs typeface="Calibri" pitchFamily="34" charset="-120"/>
-                        </a:rPr>
-                        <a:t>Besonderes</a:t>
-                      </a:r>
-                      <a:endParaRPr lang="en-US" sz="1400" dirty="0">
-                        <a:latin typeface="Calibri" charset="0"/>
-                        <a:ea typeface="Calibri" charset="0"/>
-                        <a:cs typeface="Calibri" charset="0"/>
-                      </a:endParaRPr>
-                    </a:p>
-                  </a:txBody>
-                  <a:tcPr marL="109728" marR="109728" marT="45720" marB="45720" anchor="ctr">
-                    <a:lnL w="6350" cap="flat" cmpd="sng" algn="ctr">
-                      <a:solidFill>
-                        <a:srgbClr val="D5DDD8"/>
-                      </a:solidFill>
-                      <a:prstDash val="solid"/>
-                      <a:round/>
-                      <a:headEnd type="none" w="med" len="med"/>
-                      <a:tailEnd type="none" w="med" len="med"/>
-                    </a:lnL>
-                    <a:lnR w="6350" cap="flat" cmpd="sng" algn="ctr">
-                      <a:solidFill>
-                        <a:srgbClr val="D5DDD8"/>
-                      </a:solidFill>
-                      <a:prstDash val="solid"/>
-                      <a:round/>
-                      <a:headEnd type="none" w="med" len="med"/>
-                      <a:tailEnd type="none" w="med" len="med"/>
-                    </a:lnR>
-                    <a:lnT w="6350" cap="flat" cmpd="sng" algn="ctr">
-                      <a:solidFill>
-                        <a:srgbClr val="D5DDD8"/>
-                      </a:solidFill>
-                      <a:prstDash val="solid"/>
-                      <a:round/>
-                      <a:headEnd type="none" w="med" len="med"/>
-                      <a:tailEnd type="none" w="med" len="med"/>
-                    </a:lnT>
-                    <a:lnB w="6350" cap="flat" cmpd="sng" algn="ctr">
-                      <a:solidFill>
-                        <a:srgbClr val="D5DDD8"/>
-                      </a:solidFill>
-                      <a:prstDash val="solid"/>
-                      <a:round/>
-                      <a:headEnd type="none" w="med" len="med"/>
-                      <a:tailEnd type="none" w="med" len="med"/>
-                    </a:lnB>
-                    <a:solidFill>
-                      <a:srgbClr val="FFFFFF"/>
-                    </a:solidFill>
-                  </a:tcPr>
-                </a:tc>
-                <a:tc>
-                  <a:txBody>
-                    <a:bodyPr/>
-                    <a:lstStyle/>
-                    <a:p>
-                      <a:pPr indent="0" marL="0">
-                        <a:buNone/>
-                      </a:pPr>
-                      <a:r>
-                        <a:rPr lang="en-US" sz="1400" dirty="0">
-                          <a:solidFill>
-                            <a:srgbClr val="1C2321"/>
-                          </a:solidFill>
-                          <a:latin typeface="Calibri" pitchFamily="34" charset="0"/>
-                          <a:ea typeface="Calibri" pitchFamily="34" charset="-122"/>
-                          <a:cs typeface="Calibri" pitchFamily="34" charset="-120"/>
-                        </a:rPr>
-                        <a:t>rückwärts, dreht am Ort</a:t>
-                      </a:r>
-                      <a:endParaRPr lang="en-US" sz="1400" dirty="0">
-                        <a:latin typeface="Calibri" charset="0"/>
-                        <a:ea typeface="Calibri" charset="0"/>
-                        <a:cs typeface="Calibri" charset="0"/>
-                      </a:endParaRPr>
-                    </a:p>
-                  </a:txBody>
-                  <a:tcPr marL="109728" marR="109728" marT="45720" marB="45720" anchor="ctr">
-                    <a:lnL w="6350" cap="flat" cmpd="sng" algn="ctr">
-                      <a:solidFill>
-                        <a:srgbClr val="D5DDD8"/>
-                      </a:solidFill>
-                      <a:prstDash val="solid"/>
-                      <a:round/>
-                      <a:headEnd type="none" w="med" len="med"/>
-                      <a:tailEnd type="none" w="med" len="med"/>
-                    </a:lnL>
-                    <a:lnR w="6350" cap="flat" cmpd="sng" algn="ctr">
-                      <a:solidFill>
-                        <a:srgbClr val="D5DDD8"/>
-                      </a:solidFill>
-                      <a:prstDash val="solid"/>
-                      <a:round/>
-                      <a:headEnd type="none" w="med" len="med"/>
-                      <a:tailEnd type="none" w="med" len="med"/>
-                    </a:lnR>
-                    <a:lnT w="6350" cap="flat" cmpd="sng" algn="ctr">
-                      <a:solidFill>
-                        <a:srgbClr val="D5DDD8"/>
-                      </a:solidFill>
-                      <a:prstDash val="solid"/>
-                      <a:round/>
-                      <a:headEnd type="none" w="med" len="med"/>
-                      <a:tailEnd type="none" w="med" len="med"/>
-                    </a:lnT>
-                    <a:lnB w="6350" cap="flat" cmpd="sng" algn="ctr">
-                      <a:solidFill>
-                        <a:srgbClr val="D5DDD8"/>
-                      </a:solidFill>
-                      <a:prstDash val="solid"/>
-                      <a:round/>
-                      <a:headEnd type="none" w="med" len="med"/>
-                      <a:tailEnd type="none" w="med" len="med"/>
-                    </a:lnB>
-                    <a:solidFill>
-                      <a:srgbClr val="FFFFFF"/>
-                    </a:solidFill>
-                  </a:tcPr>
-                </a:tc>
-                <a:tc>
-                  <a:txBody>
-                    <a:bodyPr/>
-                    <a:lstStyle/>
-                    <a:p>
-                      <a:pPr indent="0" marL="0">
-                        <a:buNone/>
-                      </a:pPr>
-                      <a:r>
-                        <a:rPr lang="en-US" sz="1400" dirty="0">
-                          <a:solidFill>
-                            <a:srgbClr val="1C2321"/>
-                          </a:solidFill>
-                          <a:latin typeface="Calibri" pitchFamily="34" charset="0"/>
-                          <a:ea typeface="Calibri" pitchFamily="34" charset="-122"/>
-                          <a:cs typeface="Calibri" pitchFamily="34" charset="-120"/>
-                        </a:rPr>
-                        <a:t>bremst ohne Sturz</a:t>
-                      </a:r>
-                      <a:endParaRPr lang="en-US" sz="1400" dirty="0">
-                        <a:latin typeface="Calibri" charset="0"/>
-                        <a:ea typeface="Calibri" charset="0"/>
-                        <a:cs typeface="Calibri" charset="0"/>
-                      </a:endParaRPr>
-                    </a:p>
-                  </a:txBody>
-                  <a:tcPr marL="109728" marR="109728" marT="45720" marB="45720" anchor="ctr">
-                    <a:lnL w="6350" cap="flat" cmpd="sng" algn="ctr">
-                      <a:solidFill>
-                        <a:srgbClr val="D5DDD8"/>
-                      </a:solidFill>
-                      <a:prstDash val="solid"/>
-                      <a:round/>
-                      <a:headEnd type="none" w="med" len="med"/>
-                      <a:tailEnd type="none" w="med" len="med"/>
-                    </a:lnL>
-                    <a:lnR w="6350" cap="flat" cmpd="sng" algn="ctr">
-                      <a:solidFill>
-                        <a:srgbClr val="D5DDD8"/>
-                      </a:solidFill>
-                      <a:prstDash val="solid"/>
-                      <a:round/>
-                      <a:headEnd type="none" w="med" len="med"/>
-                      <a:tailEnd type="none" w="med" len="med"/>
-                    </a:lnR>
-                    <a:lnT w="6350" cap="flat" cmpd="sng" algn="ctr">
-                      <a:solidFill>
-                        <a:srgbClr val="D5DDD8"/>
-                      </a:solidFill>
-                      <a:prstDash val="solid"/>
-                      <a:round/>
-                      <a:headEnd type="none" w="med" len="med"/>
-                      <a:tailEnd type="none" w="med" len="med"/>
-                    </a:lnT>
-                    <a:lnB w="6350" cap="flat" cmpd="sng" algn="ctr">
-                      <a:solidFill>
-                        <a:srgbClr val="D5DDD8"/>
-                      </a:solidFill>
-                      <a:prstDash val="solid"/>
-                      <a:round/>
-                      <a:headEnd type="none" w="med" len="med"/>
-                      <a:tailEnd type="none" w="med" len="med"/>
-                    </a:lnB>
-                    <a:solidFill>
-                      <a:srgbClr val="FFFFFF"/>
-                    </a:solidFill>
-                  </a:tcPr>
-                </a:tc>
-              </a:tr>
-              <a:tr h="502920">
-                <a:tc>
-                  <a:txBody>
-                    <a:bodyPr/>
-                    <a:lstStyle/>
-                    <a:p>
-                      <a:pPr indent="0" marL="0">
-                        <a:buNone/>
-                      </a:pPr>
-                      <a:r>
-                        <a:rPr lang="en-US" sz="1400" dirty="0">
-                          <a:solidFill>
-                            <a:srgbClr val="1C2321"/>
-                          </a:solidFill>
-                          <a:latin typeface="Calibri" pitchFamily="34" charset="0"/>
-                          <a:ea typeface="Calibri" pitchFamily="34" charset="-122"/>
-                          <a:cs typeface="Calibri" pitchFamily="34" charset="-120"/>
-                        </a:rPr>
-                        <a:t>Jagen (2D)</a:t>
-                      </a:r>
-                      <a:endParaRPr lang="en-US" sz="1400" dirty="0">
-                        <a:latin typeface="Calibri" charset="0"/>
-                        <a:ea typeface="Calibri" charset="0"/>
-                        <a:cs typeface="Calibri" charset="0"/>
-                      </a:endParaRPr>
-                    </a:p>
-                  </a:txBody>
-                  <a:tcPr marL="109728" marR="109728" marT="45720" marB="45720" anchor="ctr">
-                    <a:lnL w="6350" cap="flat" cmpd="sng" algn="ctr">
-                      <a:solidFill>
-                        <a:srgbClr val="D5DDD8"/>
-                      </a:solidFill>
-                      <a:prstDash val="solid"/>
-                      <a:round/>
-                      <a:headEnd type="none" w="med" len="med"/>
-                      <a:tailEnd type="none" w="med" len="med"/>
-                    </a:lnL>
-                    <a:lnR w="6350" cap="flat" cmpd="sng" algn="ctr">
-                      <a:solidFill>
-                        <a:srgbClr val="D5DDD8"/>
-                      </a:solidFill>
-                      <a:prstDash val="solid"/>
-                      <a:round/>
-                      <a:headEnd type="none" w="med" len="med"/>
-                      <a:tailEnd type="none" w="med" len="med"/>
-                    </a:lnR>
-                    <a:lnT w="6350" cap="flat" cmpd="sng" algn="ctr">
-                      <a:solidFill>
-                        <a:srgbClr val="D5DDD8"/>
-                      </a:solidFill>
-                      <a:prstDash val="solid"/>
-                      <a:round/>
-                      <a:headEnd type="none" w="med" len="med"/>
-                      <a:tailEnd type="none" w="med" len="med"/>
-                    </a:lnT>
-                    <a:lnB w="6350" cap="flat" cmpd="sng" algn="ctr">
-                      <a:solidFill>
-                        <a:srgbClr val="D5DDD8"/>
-                      </a:solidFill>
-                      <a:prstDash val="solid"/>
-                      <a:round/>
-                      <a:headEnd type="none" w="med" len="med"/>
-                      <a:tailEnd type="none" w="med" len="med"/>
-                    </a:lnB>
-                    <a:solidFill>
-                      <a:srgbClr val="EDF2EF"/>
-                    </a:solidFill>
-                  </a:tcPr>
-                </a:tc>
-                <a:tc>
-                  <a:txBody>
-                    <a:bodyPr/>
-                    <a:lstStyle/>
-                    <a:p>
-                      <a:pPr indent="0" marL="0">
-                        <a:buNone/>
-                      </a:pPr>
-                      <a:r>
-                        <a:rPr lang="en-US" sz="1400" dirty="0">
-                          <a:solidFill>
-                            <a:srgbClr val="1C2321"/>
-                          </a:solidFill>
-                          <a:latin typeface="Calibri" pitchFamily="34" charset="0"/>
-                          <a:ea typeface="Calibri" pitchFamily="34" charset="-122"/>
-                          <a:cs typeface="Calibri" pitchFamily="34" charset="-120"/>
-                        </a:rPr>
-                        <a:t>4,0 Beute / 10 min</a:t>
-                      </a:r>
-                      <a:endParaRPr lang="en-US" sz="1400" dirty="0">
-                        <a:latin typeface="Calibri" charset="0"/>
-                        <a:ea typeface="Calibri" charset="0"/>
-                        <a:cs typeface="Calibri" charset="0"/>
-                      </a:endParaRPr>
-                    </a:p>
-                  </a:txBody>
-                  <a:tcPr marL="109728" marR="109728" marT="45720" marB="45720" anchor="ctr">
-                    <a:lnL w="6350" cap="flat" cmpd="sng" algn="ctr">
-                      <a:solidFill>
-                        <a:srgbClr val="D5DDD8"/>
-                      </a:solidFill>
-                      <a:prstDash val="solid"/>
-                      <a:round/>
-                      <a:headEnd type="none" w="med" len="med"/>
-                      <a:tailEnd type="none" w="med" len="med"/>
-                    </a:lnL>
-                    <a:lnR w="6350" cap="flat" cmpd="sng" algn="ctr">
-                      <a:solidFill>
-                        <a:srgbClr val="D5DDD8"/>
-                      </a:solidFill>
-                      <a:prstDash val="solid"/>
-                      <a:round/>
-                      <a:headEnd type="none" w="med" len="med"/>
-                      <a:tailEnd type="none" w="med" len="med"/>
-                    </a:lnR>
-                    <a:lnT w="6350" cap="flat" cmpd="sng" algn="ctr">
-                      <a:solidFill>
-                        <a:srgbClr val="D5DDD8"/>
-                      </a:solidFill>
-                      <a:prstDash val="solid"/>
-                      <a:round/>
-                      <a:headEnd type="none" w="med" len="med"/>
-                      <a:tailEnd type="none" w="med" len="med"/>
-                    </a:lnT>
-                    <a:lnB w="6350" cap="flat" cmpd="sng" algn="ctr">
-                      <a:solidFill>
-                        <a:srgbClr val="D5DDD8"/>
-                      </a:solidFill>
-                      <a:prstDash val="solid"/>
-                      <a:round/>
-                      <a:headEnd type="none" w="med" len="med"/>
-                      <a:tailEnd type="none" w="med" len="med"/>
-                    </a:lnB>
-                    <a:solidFill>
-                      <a:srgbClr val="EDF2EF"/>
-                    </a:solidFill>
-                  </a:tcPr>
-                </a:tc>
-                <a:tc>
-                  <a:txBody>
-                    <a:bodyPr/>
-                    <a:lstStyle/>
-                    <a:p>
-                      <a:pPr indent="0" marL="0">
-                        <a:buNone/>
-                      </a:pPr>
-                      <a:r>
-                        <a:rPr lang="en-US" sz="1400" dirty="0">
-                          <a:solidFill>
-                            <a:srgbClr val="1C2321"/>
-                          </a:solidFill>
-                          <a:latin typeface="Calibri" pitchFamily="34" charset="0"/>
-                          <a:ea typeface="Calibri" pitchFamily="34" charset="-122"/>
-                          <a:cs typeface="Calibri" pitchFamily="34" charset="-120"/>
-                        </a:rPr>
-                        <a:t>4,6 Beute / 10 min</a:t>
-                      </a:r>
-                      <a:endParaRPr lang="en-US" sz="1400" dirty="0">
-                        <a:latin typeface="Calibri" charset="0"/>
-                        <a:ea typeface="Calibri" charset="0"/>
-                        <a:cs typeface="Calibri" charset="0"/>
-                      </a:endParaRPr>
-                    </a:p>
-                  </a:txBody>
-                  <a:tcPr marL="109728" marR="109728" marT="45720" marB="45720" anchor="ctr">
-                    <a:lnL w="6350" cap="flat" cmpd="sng" algn="ctr">
-                      <a:solidFill>
-                        <a:srgbClr val="D5DDD8"/>
-                      </a:solidFill>
-                      <a:prstDash val="solid"/>
-                      <a:round/>
-                      <a:headEnd type="none" w="med" len="med"/>
-                      <a:tailEnd type="none" w="med" len="med"/>
-                    </a:lnL>
-                    <a:lnR w="6350" cap="flat" cmpd="sng" algn="ctr">
-                      <a:solidFill>
-                        <a:srgbClr val="D5DDD8"/>
-                      </a:solidFill>
-                      <a:prstDash val="solid"/>
-                      <a:round/>
-                      <a:headEnd type="none" w="med" len="med"/>
-                      <a:tailEnd type="none" w="med" len="med"/>
-                    </a:lnR>
-                    <a:lnT w="6350" cap="flat" cmpd="sng" algn="ctr">
-                      <a:solidFill>
-                        <a:srgbClr val="D5DDD8"/>
-                      </a:solidFill>
-                      <a:prstDash val="solid"/>
-                      <a:round/>
-                      <a:headEnd type="none" w="med" len="med"/>
-                      <a:tailEnd type="none" w="med" len="med"/>
-                    </a:lnT>
-                    <a:lnB w="6350" cap="flat" cmpd="sng" algn="ctr">
-                      <a:solidFill>
-                        <a:srgbClr val="D5DDD8"/>
-                      </a:solidFill>
-                      <a:prstDash val="solid"/>
-                      <a:round/>
-                      <a:headEnd type="none" w="med" len="med"/>
-                      <a:tailEnd type="none" w="med" len="med"/>
-                    </a:lnB>
-                    <a:solidFill>
-                      <a:srgbClr val="EDF2EF"/>
-                    </a:solidFill>
-                  </a:tcPr>
-                </a:tc>
-              </a:tr>
-            </a:tbl>
-          </a:graphicData>
-        </a:graphic>
-      </p:graphicFrame>
-      <p:sp>
-        <p:nvSpPr>
-          <p:cNvPr id="14" name="Text 10"/>
+              <a:t>bei 1 m/s</a:t>
+            </a:r>
+            <a:endParaRPr lang="en-US" sz="1200" dirty="0"/>
+          </a:p>
+        </p:txBody>
+      </p:sp>
+      <p:sp>
+        <p:nvSpPr>
+          <p:cNvPr id="14" name="dc_stat3"/>
+          <p:cNvSpPr/>
+          <p:nvPr/>
+        </p:nvSpPr>
+        <p:spPr>
+          <a:xfrm>
+            <a:off x="10241280" y="1325880"/>
+            <a:ext cx="1298448" cy="1600200"/>
+          </a:xfrm>
+          <a:prstGeom prst="roundRect">
+            <a:avLst>
+              <a:gd name="adj" fmla="val 5634"/>
+            </a:avLst>
+          </a:prstGeom>
+          <a:solidFill>
+            <a:schemeClr val="bg2"/>
+          </a:solidFill>
+          <a:ln w="12700">
+            <a:solidFill>
+              <a:schemeClr val="bg2"/>
+            </a:solidFill>
+            <a:prstDash val="solid"/>
+          </a:ln>
+        </p:spPr>
+      </p:sp>
+      <p:sp>
+        <p:nvSpPr>
+          <p:cNvPr id="15" name="Text 12"/>
           <p:cNvSpPr txBox="1"/>
           <p:nvPr/>
         </p:nvSpPr>
         <p:spPr>
           <a:xfrm>
-            <a:off x="6400800" y="4069080"/>
-            <a:ext cx="5212080" cy="822960"/>
+            <a:off x="10287000" y="1463040"/>
+            <a:ext cx="1207008" cy="502920"/>
           </a:xfrm>
           <a:prstGeom prst="rect">
             <a:avLst/>
@@ -8808,11 +7825,50 @@
           <a:bodyPr wrap="square" lIns="0" tIns="0" rIns="0" bIns="0" rtlCol="0" anchor="t"/>
           <a:lstStyle/>
           <a:p>
-            <a:pPr indent="0" marL="0">
-              <a:buNone/>
-            </a:pPr>
-            <a:r>
-              <a:rPr lang="en-US" sz="1400" i="1" dirty="0">
+            <a:pPr algn="ctr" indent="0" marL="0">
+              <a:buNone/>
+            </a:pPr>
+            <a:r>
+              <a:rPr lang="en-US" sz="1900" b="1" dirty="0">
+                <a:solidFill>
+                  <a:schemeClr val="accent1"/>
+                </a:solidFill>
+                <a:latin typeface="Cambria" pitchFamily="34" charset="0"/>
+                <a:ea typeface="Cambria" pitchFamily="34" charset="-122"/>
+                <a:cs typeface="Cambria" pitchFamily="34" charset="-120"/>
+              </a:rPr>
+              <a:t>3 von 3</a:t>
+            </a:r>
+            <a:endParaRPr lang="en-US" sz="1900" dirty="0"/>
+          </a:p>
+        </p:txBody>
+      </p:sp>
+      <p:sp>
+        <p:nvSpPr>
+          <p:cNvPr id="16" name="Text 13"/>
+          <p:cNvSpPr txBox="1"/>
+          <p:nvPr/>
+        </p:nvSpPr>
+        <p:spPr>
+          <a:xfrm>
+            <a:off x="10287000" y="2057400"/>
+            <a:ext cx="1207008" cy="777240"/>
+          </a:xfrm>
+          <a:prstGeom prst="rect">
+            <a:avLst/>
+          </a:prstGeom>
+          <a:noFill/>
+          <a:ln/>
+        </p:spPr>
+        <p:txBody>
+          <a:bodyPr wrap="square" lIns="0" tIns="0" rIns="0" bIns="0" rtlCol="0" anchor="t"/>
+          <a:lstStyle/>
+          <a:p>
+            <a:pPr algn="ctr" indent="0" marL="0">
+              <a:buNone/>
+            </a:pPr>
+            <a:r>
+              <a:rPr lang="en-US" sz="1200" dirty="0">
                 <a:solidFill>
                   <a:schemeClr val="tx2"/>
                 </a:solidFill>
@@ -8820,9 +7876,261 @@
                 <a:ea typeface="Calibri" pitchFamily="34" charset="-122"/>
                 <a:cs typeface="Calibri" pitchFamily="34" charset="-120"/>
               </a:rPr>
-              <a:t>Beide Läufer final, beide jagen im Habitat; ein 30-s-Showcase-Video zeigt sie zusammen.</a:t>
+              <a:t>Bremsen aus dem</a:t>
+            </a:r>
+            <a:endParaRPr lang="en-US" sz="1200" dirty="0"/>
+          </a:p>
+          <a:p>
+            <a:pPr algn="ctr" indent="0" marL="0">
+              <a:buNone/>
+            </a:pPr>
+            <a:r>
+              <a:rPr lang="en-US" sz="1200" dirty="0">
+                <a:solidFill>
+                  <a:schemeClr val="tx2"/>
+                </a:solidFill>
+                <a:latin typeface="Calibri" pitchFamily="34" charset="0"/>
+                <a:ea typeface="Calibri" pitchFamily="34" charset="-122"/>
+                <a:cs typeface="Calibri" pitchFamily="34" charset="-120"/>
+              </a:rPr>
+              <a:t>Sprint ohne Sturz</a:t>
+            </a:r>
+            <a:endParaRPr lang="en-US" sz="1200" dirty="0"/>
+          </a:p>
+        </p:txBody>
+      </p:sp>
+      <p:sp>
+        <p:nvSpPr>
+          <p:cNvPr id="17" name="dc_path"/>
+          <p:cNvSpPr/>
+          <p:nvPr/>
+        </p:nvSpPr>
+        <p:spPr>
+          <a:xfrm>
+            <a:off x="5989320" y="3108960"/>
+            <a:ext cx="5623560" cy="2423160"/>
+          </a:xfrm>
+          <a:prstGeom prst="roundRect">
+            <a:avLst>
+              <a:gd name="adj" fmla="val 3019"/>
+            </a:avLst>
+          </a:prstGeom>
+          <a:solidFill>
+            <a:schemeClr val="bg2"/>
+          </a:solidFill>
+          <a:ln w="12700">
+            <a:solidFill>
+              <a:schemeClr val="bg2"/>
+            </a:solidFill>
+            <a:prstDash val="solid"/>
+          </a:ln>
+        </p:spPr>
+      </p:sp>
+      <p:sp>
+        <p:nvSpPr>
+          <p:cNvPr id="18" name="Text 15"/>
+          <p:cNvSpPr txBox="1"/>
+          <p:nvPr/>
+        </p:nvSpPr>
+        <p:spPr>
+          <a:xfrm>
+            <a:off x="6217920" y="3246120"/>
+            <a:ext cx="5212080" cy="365760"/>
+          </a:xfrm>
+          <a:prstGeom prst="rect">
+            <a:avLst/>
+          </a:prstGeom>
+          <a:noFill/>
+          <a:ln/>
+        </p:spPr>
+        <p:txBody>
+          <a:bodyPr wrap="square" lIns="0" tIns="0" rIns="0" bIns="0" rtlCol="0" anchor="t"/>
+          <a:lstStyle/>
+          <a:p>
+            <a:pPr indent="0" marL="0">
+              <a:buNone/>
+            </a:pPr>
+            <a:r>
+              <a:rPr lang="en-US" sz="1700" b="1" dirty="0">
+                <a:solidFill>
+                  <a:schemeClr val="tx2"/>
+                </a:solidFill>
+                <a:latin typeface="Calibri" pitchFamily="34" charset="0"/>
+                <a:ea typeface="Calibri" pitchFamily="34" charset="-122"/>
+                <a:cs typeface="Calibri" pitchFamily="34" charset="-120"/>
+              </a:rPr>
+              <a:t>Der Weg zum Raubkatzen-Gang</a:t>
+            </a:r>
+            <a:endParaRPr lang="en-US" sz="1700" dirty="0"/>
+          </a:p>
+        </p:txBody>
+      </p:sp>
+      <p:sp>
+        <p:nvSpPr>
+          <p:cNvPr id="19" name="Text 16"/>
+          <p:cNvSpPr txBox="1"/>
+          <p:nvPr/>
+        </p:nvSpPr>
+        <p:spPr>
+          <a:xfrm>
+            <a:off x="6217920" y="3703320"/>
+            <a:ext cx="5257800" cy="1783080"/>
+          </a:xfrm>
+          <a:prstGeom prst="rect">
+            <a:avLst/>
+          </a:prstGeom>
+          <a:noFill/>
+          <a:ln/>
+        </p:spPr>
+        <p:txBody>
+          <a:bodyPr wrap="square" lIns="0" tIns="0" rIns="0" bIns="0" rtlCol="0" anchor="t"/>
+          <a:lstStyle/>
+          <a:p>
+            <a:pPr marL="342900" indent="-342900">
+              <a:spcAft>
+                <a:spcPts val="600"/>
+              </a:spcAft>
+              <a:buSzPct val="100000"/>
+              <a:buChar char="•"/>
+            </a:pPr>
+            <a:r>
+              <a:rPr lang="en-US" sz="1400" dirty="0">
+                <a:solidFill>
+                  <a:srgbClr val="000000"/>
+                </a:solidFill>
+              </a:rPr>
+              <a:t>v2: Schritt und Trab im Gangtakt, 2,4× weniger Energie</a:t>
             </a:r>
             <a:endParaRPr lang="en-US" sz="1400" dirty="0"/>
+          </a:p>
+          <a:p>
+            <a:pPr marL="342900" indent="-342900">
+              <a:spcAft>
+                <a:spcPts val="600"/>
+              </a:spcAft>
+              <a:buSzPct val="100000"/>
+              <a:buChar char="•"/>
+            </a:pPr>
+            <a:r>
+              <a:rPr lang="en-US" sz="1400" dirty="0">
+                <a:solidFill>
+                  <a:srgbClr val="000000"/>
+                </a:solidFill>
+              </a:rPr>
+              <a:t>v5: langer Panther-Schritt (0,62 m)</a:t>
+            </a:r>
+            <a:endParaRPr lang="en-US" sz="1400" dirty="0"/>
+          </a:p>
+          <a:p>
+            <a:pPr marL="342900" indent="-342900">
+              <a:spcAft>
+                <a:spcPts val="600"/>
+              </a:spcAft>
+              <a:buSzPct val="100000"/>
+              <a:buChar char="•"/>
+            </a:pPr>
+            <a:r>
+              <a:rPr lang="en-US" sz="1400" dirty="0">
+                <a:solidFill>
+                  <a:srgbClr val="000000"/>
+                </a:solidFill>
+              </a:rPr>
+              <a:t>v8: „Handstand“ auf Vorderbeinen und Armen</a:t>
+            </a:r>
+            <a:endParaRPr lang="en-US" sz="1400" dirty="0"/>
+          </a:p>
+          <a:p>
+            <a:pPr marL="342900" indent="-342900">
+              <a:spcAft>
+                <a:spcPts val="600"/>
+              </a:spcAft>
+              <a:buSzPct val="100000"/>
+              <a:buChar char="•"/>
+            </a:pPr>
+            <a:r>
+              <a:rPr lang="en-US" sz="1400" dirty="0">
+                <a:solidFill>
+                  <a:srgbClr val="000000"/>
+                </a:solidFill>
+              </a:rPr>
+              <a:t>v11: Raubkatzen-Gewichte – kein Trippeln mehr</a:t>
+            </a:r>
+            <a:endParaRPr lang="en-US" sz="1400" dirty="0"/>
+          </a:p>
+          <a:p>
+            <a:pPr marL="342900" indent="-342900">
+              <a:spcAft>
+                <a:spcPts val="600"/>
+              </a:spcAft>
+              <a:buSzPct val="100000"/>
+              <a:buChar char="•"/>
+            </a:pPr>
+            <a:r>
+              <a:rPr lang="en-US" sz="1400" dirty="0">
+                <a:solidFill>
+                  <a:srgbClr val="000000"/>
+                </a:solidFill>
+              </a:rPr>
+              <a:t>v12: 218-Teile-Körper, Wolf-Vorbild, T-Rex-Arme, neue Hand</a:t>
+            </a:r>
+            <a:endParaRPr lang="en-US" sz="1400" dirty="0"/>
+          </a:p>
+          <a:p>
+            <a:pPr marL="342900" indent="-342900">
+              <a:spcAft>
+                <a:spcPts val="600"/>
+              </a:spcAft>
+              <a:buSzPct val="100000"/>
+              <a:buChar char="•"/>
+            </a:pPr>
+            <a:r>
+              <a:rPr lang="en-US" sz="1400" dirty="0">
+                <a:solidFill>
+                  <a:srgbClr val="000000"/>
+                </a:solidFill>
+              </a:rPr>
+              <a:t>v12z: Planke weg, Gang geglättet → final</a:t>
+            </a:r>
+            <a:endParaRPr lang="en-US" sz="1400" dirty="0"/>
+          </a:p>
+        </p:txBody>
+      </p:sp>
+      <p:sp>
+        <p:nvSpPr>
+          <p:cNvPr id="20" name="Text 17"/>
+          <p:cNvSpPr txBox="1"/>
+          <p:nvPr/>
+        </p:nvSpPr>
+        <p:spPr>
+          <a:xfrm>
+            <a:off x="5989320" y="5760720"/>
+            <a:ext cx="5623560" cy="365760"/>
+          </a:xfrm>
+          <a:prstGeom prst="rect">
+            <a:avLst/>
+          </a:prstGeom>
+          <a:noFill/>
+          <a:ln/>
+        </p:spPr>
+        <p:txBody>
+          <a:bodyPr wrap="square" lIns="0" tIns="0" rIns="0" bIns="0" rtlCol="0" anchor="t"/>
+          <a:lstStyle/>
+          <a:p>
+            <a:pPr indent="0" marL="0">
+              <a:buNone/>
+            </a:pPr>
+            <a:r>
+              <a:rPr lang="en-US" sz="1300" i="1" dirty="0">
+                <a:solidFill>
+                  <a:schemeClr val="accent3"/>
+                </a:solidFill>
+                <a:latin typeface="Calibri" pitchFamily="34" charset="0"/>
+                <a:ea typeface="Calibri" pitchFamily="34" charset="-122"/>
+                <a:cs typeface="Calibri" pitchFamily="34" charset="-120"/>
+              </a:rPr>
+              <a:t>Schritt 0,52–0,97 m · Wippen ≤ 2 cm · keine Stürze · offen: Drehen am Ort</a:t>
+            </a:r>
+            <a:endParaRPr lang="en-US" sz="1300" dirty="0"/>
           </a:p>
         </p:txBody>
       </p:sp>

</xml_diff>

<commit_message>
One comparable learning curve for both creatures: all 363 checkpoints tested the same way (walking quality at 0.6 m/s), best brain per version + released brains; replaces the per-version panels in the 10-minute deck
Co-Authored-By: Claude Opus 5.5 <noreply@anthropic.com>
</commit_message>
<xml_diff>
--- a/docs/presentation/Endemic_Creatures_RL_10min.pptx
+++ b/docs/presentation/Endemic_Creatures_RL_10min.pptx
@@ -118,19 +118,19 @@
   <p:extLst>
     <p:ext uri="{521415D9-36F7-43E2-AB2F-B90AF26B5E84}">
       <p14:sectionLst xmlns:p14="http://schemas.microsoft.com/office/powerpoint/2010/main">
-        <p14:section name="Einstieg" id="{d4f47887-1d5f-b262-6658-003b8d26de2c}">
+        <p14:section name="Einstieg" id="{899a1cd8-0019-5a21-1011-b829d79ee58b}">
           <p14:sldIdLst>
             <p14:sldId id="256"/>
             <p14:sldId id="257"/>
           </p14:sldIdLst>
         </p14:section>
-        <p14:section name="Vorgehen" id="{c583a77f-bcd8-2693-b4f8-e9e19e1eec82}">
+        <p14:section name="Vorgehen" id="{467f687f-08db-8b21-92cf-282e9e4f40c4}">
           <p14:sldIdLst>
             <p14:sldId id="258"/>
             <p14:sldId id="259"/>
           </p14:sldIdLst>
         </p14:section>
-        <p14:section name="Lernen" id="{feacbd48-ad0c-4475-07d4-9f21ff6b7859}">
+        <p14:section name="Lernen" id="{2e1035d7-2757-df25-721a-d16eaa61e9a1}">
           <p14:sldIdLst>
             <p14:sldId id="260"/>
             <p14:sldId id="261"/>
@@ -138,7 +138,7 @@
             <p14:sldId id="263"/>
           </p14:sldIdLst>
         </p14:section>
-        <p14:section name="Rückblick" id="{76365ab4-6b44-0283-c455-10bdc607e283}">
+        <p14:section name="Rückblick" id="{5efdf5e8-3d58-c167-e1de-60098ae0fa7b}">
           <p14:sldIdLst>
             <p14:sldId id="264"/>
             <p14:sldId id="265"/>
@@ -1430,7 +1430,7 @@
           <a:p>
             <a:r>
               <a:rPr lang="en-US" dirty="0"/>
-              <a:t>ca. 45 s. Links alle Myrranox-, rechts alle DC-Versionen, je ein kleines Diagramm. Wichtig: die Werte sind zwischen Versionen nicht vergleichbar, nur der Verlauf. Gut zu sehen: v1-v3 lernen stetig; Einbrüche bei v4/v5 durch strengere Regeln; v9 die neue Belohnung; beim DC v12 viele kurze Stufen bis zum finalen Gehirn.</a:t>
+              <a:t>ca. 45 s. Da sich die Belohnung zwischen den Versionen geändert hat, habe ich alle Gehirne beider Kreaturen nachträglich mit dem gleichen Test gemessen. Man sieht: Fortschritt nicht geradlinig - v6/v8 beim DC waren Einbrüche (sechs Gliedmaßen, Handstand), der Myrranox brach bei v9 ein (Schubkarre). Der finale DC v12z ist das beste DC-Gehirn; beim Myrranox v10 kostet das Trippeln der Vorderbeine Punkte.</a:t>
             </a:r>
             <a:endParaRPr lang="en-US" dirty="0"/>
           </a:p>
@@ -10315,7 +10315,7 @@
                 <a:ea typeface="Cambria" pitchFamily="34" charset="-122"/>
                 <a:cs typeface="Cambria" pitchFamily="34" charset="-120"/>
               </a:rPr>
-              <a:t>Lernkurven aller Gehirn-Versionen</a:t>
+              <a:t>Lernkurve beider Kreaturen über alle Versionen</a:t>
             </a:r>
             <a:endParaRPr lang="en-US" sz="3200" dirty="0"/>
           </a:p>
@@ -10323,7 +10323,7 @@
       </p:sp>
       <p:pic>
         <p:nvPicPr>
-          <p:cNvPr id="3" name="lc_myr" descr="C:\Users\thoma\PycharmProjects\Reinforcement_Learning_Creature\docs\figures\locomotion\learning_curves_all_myrranox.png">    </p:cNvPr>
+          <p:cNvPr id="3" name="lc_common" descr="C:\Users\thoma\PycharmProjects\Reinforcement_Learning_Creature\docs\figures\locomotion\learning_curve_common.png">    </p:cNvPr>
           <p:cNvPicPr>
             <a:picLocks noChangeAspect="1"/>
           </p:cNvPicPr>
@@ -10337,48 +10337,24 @@
         </p:blipFill>
         <p:spPr>
           <a:xfrm>
-            <a:off x="548640" y="1234440"/>
-            <a:ext cx="5486400" cy="4370070"/>
+            <a:off x="1051560" y="1143000"/>
+            <a:ext cx="10058400" cy="4861560"/>
           </a:xfrm>
           <a:prstGeom prst="rect">
             <a:avLst/>
           </a:prstGeom>
         </p:spPr>
       </p:pic>
-      <p:pic>
-        <p:nvPicPr>
-          <p:cNvPr id="4" name="lc_dc" descr="C:\Users\thoma\PycharmProjects\Reinforcement_Learning_Creature\docs\figures\locomotion\learning_curves_all_dc.png">    </p:cNvPr>
-          <p:cNvPicPr>
-            <a:picLocks noChangeAspect="1"/>
-          </p:cNvPicPr>
-          <p:nvPr/>
-        </p:nvPicPr>
-        <p:blipFill>
-          <a:blip r:embed="rId2"/>
-          <a:stretch>
-            <a:fillRect/>
-          </a:stretch>
-        </p:blipFill>
-        <p:spPr>
-          <a:xfrm>
-            <a:off x="7086600" y="1188720"/>
-            <a:ext cx="4572000" cy="4762500"/>
-          </a:xfrm>
-          <a:prstGeom prst="rect">
-            <a:avLst/>
-          </a:prstGeom>
-        </p:spPr>
-      </p:pic>
-      <p:sp>
-        <p:nvSpPr>
-          <p:cNvPr id="5" name="Text 1"/>
+      <p:sp>
+        <p:nvSpPr>
+          <p:cNvPr id="4" name="Text 1"/>
           <p:cNvSpPr txBox="1"/>
           <p:nvPr/>
         </p:nvSpPr>
         <p:spPr>
           <a:xfrm>
-            <a:off x="548640" y="5715000"/>
-            <a:ext cx="6263640" cy="640080"/>
+            <a:off x="548640" y="6035040"/>
+            <a:ext cx="11064240" cy="457200"/>
           </a:xfrm>
           <a:prstGeom prst="rect">
             <a:avLst/>
@@ -10394,7 +10370,7 @@
               <a:buNone/>
             </a:pPr>
             <a:r>
-              <a:rPr lang="en-US" sz="1200" i="1" dirty="0">
+              <a:rPr lang="en-US" sz="1100" i="1" dirty="0">
                 <a:solidFill>
                   <a:schemeClr val="tx2"/>
                 </a:solidFill>
@@ -10402,9 +10378,9 @@
                 <a:ea typeface="Calibri" pitchFamily="34" charset="-122"/>
                 <a:cs typeface="Calibri" pitchFamily="34" charset="-120"/>
               </a:rPr>
-              <a:t>Jede Version mit eigener Skala: Die Belohnung wurde fast jedes Mal anders definiert (v1–v8 bis ≈ 3.000 je Episode, ab v9 multiplikativ 0–50). Steigende Kurven = das Gehirn lernt; Einbrüche = neue Regeln oder ein Schlupfloch.</a:t>
-            </a:r>
-            <a:endParaRPr lang="en-US" sz="1200" dirty="0"/>
+              <a:t>Gleicher Test für alle 363 gespeicherten Gehirne: Befehl „Gehen mit 0,6 m/s“. Lauf-Qualität = Tempo trifft × Rumpf ruhig × Takt gleichmäßig × kein Sturz. Punkte = alle Checkpoints einer Version, Linie = bestes Gehirn, Stern = freigegebenes Gehirn. Nicht gemessen: wie tierähnlich der Gang aussieht.</a:t>
+            </a:r>
+            <a:endParaRPr lang="en-US" sz="1100" dirty="0"/>
           </a:p>
         </p:txBody>
       </p:sp>

</xml_diff>